<commit_message>
vw_gold_lancamentos_consolidados_dia criada para criação da tabela utilizada na segunda aba operacional, ela agrega os lançamentos por dia, ao invés de trazer a granularidade por id de lançamento
</commit_message>
<xml_diff>
--- a/dashboards/Mockup dashboard (em construção).pptx
+++ b/dashboards/Mockup dashboard (em construção).pptx
@@ -260,7 +260,7 @@
           <a:p>
             <a:fld id="{2DB56B22-234B-48A0-9B90-72A4AF419D03}" type="datetimeFigureOut">
               <a:rPr lang="pt-BR" smtClean="0"/>
-              <a:t>17/02/2026</a:t>
+              <a:t>21/02/2026</a:t>
             </a:fld>
             <a:endParaRPr lang="pt-BR"/>
           </a:p>
@@ -458,7 +458,7 @@
           <a:p>
             <a:fld id="{2DB56B22-234B-48A0-9B90-72A4AF419D03}" type="datetimeFigureOut">
               <a:rPr lang="pt-BR" smtClean="0"/>
-              <a:t>17/02/2026</a:t>
+              <a:t>21/02/2026</a:t>
             </a:fld>
             <a:endParaRPr lang="pt-BR"/>
           </a:p>
@@ -666,7 +666,7 @@
           <a:p>
             <a:fld id="{2DB56B22-234B-48A0-9B90-72A4AF419D03}" type="datetimeFigureOut">
               <a:rPr lang="pt-BR" smtClean="0"/>
-              <a:t>17/02/2026</a:t>
+              <a:t>21/02/2026</a:t>
             </a:fld>
             <a:endParaRPr lang="pt-BR"/>
           </a:p>
@@ -864,7 +864,7 @@
           <a:p>
             <a:fld id="{2DB56B22-234B-48A0-9B90-72A4AF419D03}" type="datetimeFigureOut">
               <a:rPr lang="pt-BR" smtClean="0"/>
-              <a:t>17/02/2026</a:t>
+              <a:t>21/02/2026</a:t>
             </a:fld>
             <a:endParaRPr lang="pt-BR"/>
           </a:p>
@@ -1139,7 +1139,7 @@
           <a:p>
             <a:fld id="{2DB56B22-234B-48A0-9B90-72A4AF419D03}" type="datetimeFigureOut">
               <a:rPr lang="pt-BR" smtClean="0"/>
-              <a:t>17/02/2026</a:t>
+              <a:t>21/02/2026</a:t>
             </a:fld>
             <a:endParaRPr lang="pt-BR"/>
           </a:p>
@@ -1404,7 +1404,7 @@
           <a:p>
             <a:fld id="{2DB56B22-234B-48A0-9B90-72A4AF419D03}" type="datetimeFigureOut">
               <a:rPr lang="pt-BR" smtClean="0"/>
-              <a:t>17/02/2026</a:t>
+              <a:t>21/02/2026</a:t>
             </a:fld>
             <a:endParaRPr lang="pt-BR"/>
           </a:p>
@@ -1816,7 +1816,7 @@
           <a:p>
             <a:fld id="{2DB56B22-234B-48A0-9B90-72A4AF419D03}" type="datetimeFigureOut">
               <a:rPr lang="pt-BR" smtClean="0"/>
-              <a:t>17/02/2026</a:t>
+              <a:t>21/02/2026</a:t>
             </a:fld>
             <a:endParaRPr lang="pt-BR"/>
           </a:p>
@@ -1957,7 +1957,7 @@
           <a:p>
             <a:fld id="{2DB56B22-234B-48A0-9B90-72A4AF419D03}" type="datetimeFigureOut">
               <a:rPr lang="pt-BR" smtClean="0"/>
-              <a:t>17/02/2026</a:t>
+              <a:t>21/02/2026</a:t>
             </a:fld>
             <a:endParaRPr lang="pt-BR"/>
           </a:p>
@@ -2070,7 +2070,7 @@
           <a:p>
             <a:fld id="{2DB56B22-234B-48A0-9B90-72A4AF419D03}" type="datetimeFigureOut">
               <a:rPr lang="pt-BR" smtClean="0"/>
-              <a:t>17/02/2026</a:t>
+              <a:t>21/02/2026</a:t>
             </a:fld>
             <a:endParaRPr lang="pt-BR"/>
           </a:p>
@@ -2381,7 +2381,7 @@
           <a:p>
             <a:fld id="{2DB56B22-234B-48A0-9B90-72A4AF419D03}" type="datetimeFigureOut">
               <a:rPr lang="pt-BR" smtClean="0"/>
-              <a:t>17/02/2026</a:t>
+              <a:t>21/02/2026</a:t>
             </a:fld>
             <a:endParaRPr lang="pt-BR"/>
           </a:p>
@@ -2669,7 +2669,7 @@
           <a:p>
             <a:fld id="{2DB56B22-234B-48A0-9B90-72A4AF419D03}" type="datetimeFigureOut">
               <a:rPr lang="pt-BR" smtClean="0"/>
-              <a:t>17/02/2026</a:t>
+              <a:t>21/02/2026</a:t>
             </a:fld>
             <a:endParaRPr lang="pt-BR"/>
           </a:p>
@@ -2910,7 +2910,7 @@
           <a:p>
             <a:fld id="{2DB56B22-234B-48A0-9B90-72A4AF419D03}" type="datetimeFigureOut">
               <a:rPr lang="pt-BR" smtClean="0"/>
-              <a:t>17/02/2026</a:t>
+              <a:t>21/02/2026</a:t>
             </a:fld>
             <a:endParaRPr lang="pt-BR"/>
           </a:p>
@@ -5567,230 +5567,6 @@
           </a:p>
         </p:txBody>
       </p:sp>
-      <p:sp>
-        <p:nvSpPr>
-          <p:cNvPr id="56" name="Retângulo: Cantos Arredondados 55">
-            <a:extLst>
-              <a:ext uri="{FF2B5EF4-FFF2-40B4-BE49-F238E27FC236}">
-                <a16:creationId xmlns:a16="http://schemas.microsoft.com/office/drawing/2014/main" id="{D4F2FB47-E006-A114-B89C-26A04457A230}"/>
-              </a:ext>
-            </a:extLst>
-          </p:cNvPr>
-          <p:cNvSpPr/>
-          <p:nvPr/>
-        </p:nvSpPr>
-        <p:spPr>
-          <a:xfrm>
-            <a:off x="2872933" y="936982"/>
-            <a:ext cx="433589" cy="466012"/>
-          </a:xfrm>
-          <a:prstGeom prst="roundRect">
-            <a:avLst>
-              <a:gd name="adj" fmla="val 35127"/>
-            </a:avLst>
-          </a:prstGeom>
-          <a:solidFill>
-            <a:srgbClr val="2F3A5F">
-              <a:alpha val="18000"/>
-            </a:srgbClr>
-          </a:solidFill>
-          <a:ln>
-            <a:noFill/>
-          </a:ln>
-        </p:spPr>
-        <p:style>
-          <a:lnRef idx="2">
-            <a:schemeClr val="accent1">
-              <a:shade val="15000"/>
-            </a:schemeClr>
-          </a:lnRef>
-          <a:fillRef idx="1">
-            <a:schemeClr val="accent1"/>
-          </a:fillRef>
-          <a:effectRef idx="0">
-            <a:schemeClr val="accent1"/>
-          </a:effectRef>
-          <a:fontRef idx="minor">
-            <a:schemeClr val="lt1"/>
-          </a:fontRef>
-        </p:style>
-        <p:txBody>
-          <a:bodyPr rtlCol="0" anchor="ctr"/>
-          <a:lstStyle/>
-          <a:p>
-            <a:pPr algn="ctr"/>
-            <a:endParaRPr lang="pt-BR" dirty="0"/>
-          </a:p>
-        </p:txBody>
-      </p:sp>
-      <p:sp>
-        <p:nvSpPr>
-          <p:cNvPr id="57" name="Retângulo: Cantos Arredondados 56">
-            <a:extLst>
-              <a:ext uri="{FF2B5EF4-FFF2-40B4-BE49-F238E27FC236}">
-                <a16:creationId xmlns:a16="http://schemas.microsoft.com/office/drawing/2014/main" id="{D9909437-8353-1D03-C311-8E09F289071E}"/>
-              </a:ext>
-            </a:extLst>
-          </p:cNvPr>
-          <p:cNvSpPr/>
-          <p:nvPr/>
-        </p:nvSpPr>
-        <p:spPr>
-          <a:xfrm>
-            <a:off x="5681557" y="930022"/>
-            <a:ext cx="450374" cy="466489"/>
-          </a:xfrm>
-          <a:prstGeom prst="roundRect">
-            <a:avLst>
-              <a:gd name="adj" fmla="val 35127"/>
-            </a:avLst>
-          </a:prstGeom>
-          <a:solidFill>
-            <a:srgbClr val="2F3A5F">
-              <a:alpha val="17647"/>
-            </a:srgbClr>
-          </a:solidFill>
-          <a:ln>
-            <a:noFill/>
-          </a:ln>
-        </p:spPr>
-        <p:style>
-          <a:lnRef idx="2">
-            <a:schemeClr val="accent1">
-              <a:shade val="15000"/>
-            </a:schemeClr>
-          </a:lnRef>
-          <a:fillRef idx="1">
-            <a:schemeClr val="accent1"/>
-          </a:fillRef>
-          <a:effectRef idx="0">
-            <a:schemeClr val="accent1"/>
-          </a:effectRef>
-          <a:fontRef idx="minor">
-            <a:schemeClr val="lt1"/>
-          </a:fontRef>
-        </p:style>
-        <p:txBody>
-          <a:bodyPr rtlCol="0" anchor="ctr"/>
-          <a:lstStyle/>
-          <a:p>
-            <a:pPr algn="ctr"/>
-            <a:endParaRPr lang="pt-BR"/>
-          </a:p>
-        </p:txBody>
-      </p:sp>
-      <p:sp>
-        <p:nvSpPr>
-          <p:cNvPr id="58" name="Retângulo: Cantos Arredondados 57">
-            <a:extLst>
-              <a:ext uri="{FF2B5EF4-FFF2-40B4-BE49-F238E27FC236}">
-                <a16:creationId xmlns:a16="http://schemas.microsoft.com/office/drawing/2014/main" id="{849E17AF-F204-D19B-83B7-493ED982D77C}"/>
-              </a:ext>
-            </a:extLst>
-          </p:cNvPr>
-          <p:cNvSpPr/>
-          <p:nvPr/>
-        </p:nvSpPr>
-        <p:spPr>
-          <a:xfrm>
-            <a:off x="8492961" y="930022"/>
-            <a:ext cx="450374" cy="466489"/>
-          </a:xfrm>
-          <a:prstGeom prst="roundRect">
-            <a:avLst>
-              <a:gd name="adj" fmla="val 35127"/>
-            </a:avLst>
-          </a:prstGeom>
-          <a:solidFill>
-            <a:srgbClr val="2F3A5F">
-              <a:alpha val="18000"/>
-            </a:srgbClr>
-          </a:solidFill>
-          <a:ln>
-            <a:noFill/>
-          </a:ln>
-        </p:spPr>
-        <p:style>
-          <a:lnRef idx="2">
-            <a:schemeClr val="accent1">
-              <a:shade val="15000"/>
-            </a:schemeClr>
-          </a:lnRef>
-          <a:fillRef idx="1">
-            <a:schemeClr val="accent1"/>
-          </a:fillRef>
-          <a:effectRef idx="0">
-            <a:schemeClr val="accent1"/>
-          </a:effectRef>
-          <a:fontRef idx="minor">
-            <a:schemeClr val="lt1"/>
-          </a:fontRef>
-        </p:style>
-        <p:txBody>
-          <a:bodyPr rtlCol="0" anchor="ctr"/>
-          <a:lstStyle/>
-          <a:p>
-            <a:pPr algn="ctr"/>
-            <a:endParaRPr lang="pt-BR"/>
-          </a:p>
-        </p:txBody>
-      </p:sp>
-      <p:sp>
-        <p:nvSpPr>
-          <p:cNvPr id="59" name="Retângulo: Cantos Arredondados 58">
-            <a:extLst>
-              <a:ext uri="{FF2B5EF4-FFF2-40B4-BE49-F238E27FC236}">
-                <a16:creationId xmlns:a16="http://schemas.microsoft.com/office/drawing/2014/main" id="{52FF75AF-44A2-0E85-0E41-7AB475B2B28B}"/>
-              </a:ext>
-            </a:extLst>
-          </p:cNvPr>
-          <p:cNvSpPr/>
-          <p:nvPr/>
-        </p:nvSpPr>
-        <p:spPr>
-          <a:xfrm>
-            <a:off x="11329317" y="930022"/>
-            <a:ext cx="450374" cy="466489"/>
-          </a:xfrm>
-          <a:prstGeom prst="roundRect">
-            <a:avLst>
-              <a:gd name="adj" fmla="val 35127"/>
-            </a:avLst>
-          </a:prstGeom>
-          <a:solidFill>
-            <a:srgbClr val="2F3A5F">
-              <a:alpha val="18000"/>
-            </a:srgbClr>
-          </a:solidFill>
-          <a:ln>
-            <a:noFill/>
-          </a:ln>
-        </p:spPr>
-        <p:style>
-          <a:lnRef idx="2">
-            <a:schemeClr val="accent1">
-              <a:shade val="15000"/>
-            </a:schemeClr>
-          </a:lnRef>
-          <a:fillRef idx="1">
-            <a:schemeClr val="accent1"/>
-          </a:fillRef>
-          <a:effectRef idx="0">
-            <a:schemeClr val="accent1"/>
-          </a:effectRef>
-          <a:fontRef idx="minor">
-            <a:schemeClr val="lt1"/>
-          </a:fontRef>
-        </p:style>
-        <p:txBody>
-          <a:bodyPr rtlCol="0" anchor="ctr"/>
-          <a:lstStyle/>
-          <a:p>
-            <a:pPr algn="ctr"/>
-            <a:endParaRPr lang="pt-BR"/>
-          </a:p>
-        </p:txBody>
-      </p:sp>
       <p:pic>
         <p:nvPicPr>
           <p:cNvPr id="3" name="Imagem 2" descr="Ícone&#10;&#10;O conteúdo gerado por IA pode estar incorreto.">
@@ -6013,8 +5789,8 @@
         </p:blipFill>
         <p:spPr>
           <a:xfrm>
-            <a:off x="2910020" y="1003659"/>
-            <a:ext cx="332657" cy="332657"/>
+            <a:off x="3053508" y="996463"/>
+            <a:ext cx="255261" cy="255261"/>
           </a:xfrm>
           <a:prstGeom prst="rect">
             <a:avLst/>
@@ -6049,8 +5825,8 @@
         </p:blipFill>
         <p:spPr>
           <a:xfrm>
-            <a:off x="8552239" y="979400"/>
-            <a:ext cx="331817" cy="331817"/>
+            <a:off x="8701646" y="974540"/>
+            <a:ext cx="267729" cy="267729"/>
           </a:xfrm>
           <a:prstGeom prst="rect">
             <a:avLst/>
@@ -6085,8 +5861,8 @@
         </p:blipFill>
         <p:spPr>
           <a:xfrm>
-            <a:off x="11383752" y="974437"/>
-            <a:ext cx="341503" cy="341503"/>
+            <a:off x="11520243" y="1003659"/>
+            <a:ext cx="238610" cy="238610"/>
           </a:xfrm>
           <a:prstGeom prst="rect">
             <a:avLst/>
@@ -6121,8 +5897,8 @@
         </p:blipFill>
         <p:spPr>
           <a:xfrm>
-            <a:off x="5735340" y="989268"/>
-            <a:ext cx="331634" cy="331634"/>
+            <a:off x="5843643" y="989268"/>
+            <a:ext cx="269652" cy="269652"/>
           </a:xfrm>
           <a:prstGeom prst="rect">
             <a:avLst/>
@@ -6744,6 +6520,230 @@
           </a:prstGeom>
         </p:spPr>
       </p:pic>
+      <p:sp>
+        <p:nvSpPr>
+          <p:cNvPr id="16" name="Retângulo: Cantos Arredondados 15">
+            <a:extLst>
+              <a:ext uri="{FF2B5EF4-FFF2-40B4-BE49-F238E27FC236}">
+                <a16:creationId xmlns:a16="http://schemas.microsoft.com/office/drawing/2014/main" id="{CC698D58-1F9B-2973-DA50-83C730A06717}"/>
+              </a:ext>
+            </a:extLst>
+          </p:cNvPr>
+          <p:cNvSpPr/>
+          <p:nvPr/>
+        </p:nvSpPr>
+        <p:spPr>
+          <a:xfrm>
+            <a:off x="2989250" y="922380"/>
+            <a:ext cx="383779" cy="406040"/>
+          </a:xfrm>
+          <a:prstGeom prst="roundRect">
+            <a:avLst>
+              <a:gd name="adj" fmla="val 35127"/>
+            </a:avLst>
+          </a:prstGeom>
+          <a:solidFill>
+            <a:srgbClr val="2F3A5F">
+              <a:alpha val="18000"/>
+            </a:srgbClr>
+          </a:solidFill>
+          <a:ln>
+            <a:noFill/>
+          </a:ln>
+        </p:spPr>
+        <p:style>
+          <a:lnRef idx="2">
+            <a:schemeClr val="accent1">
+              <a:shade val="15000"/>
+            </a:schemeClr>
+          </a:lnRef>
+          <a:fillRef idx="1">
+            <a:schemeClr val="accent1"/>
+          </a:fillRef>
+          <a:effectRef idx="0">
+            <a:schemeClr val="accent1"/>
+          </a:effectRef>
+          <a:fontRef idx="minor">
+            <a:schemeClr val="lt1"/>
+          </a:fontRef>
+        </p:style>
+        <p:txBody>
+          <a:bodyPr rtlCol="0" anchor="ctr"/>
+          <a:lstStyle/>
+          <a:p>
+            <a:pPr algn="ctr"/>
+            <a:endParaRPr lang="pt-BR" dirty="0"/>
+          </a:p>
+        </p:txBody>
+      </p:sp>
+      <p:sp>
+        <p:nvSpPr>
+          <p:cNvPr id="19" name="Retângulo: Cantos Arredondados 18">
+            <a:extLst>
+              <a:ext uri="{FF2B5EF4-FFF2-40B4-BE49-F238E27FC236}">
+                <a16:creationId xmlns:a16="http://schemas.microsoft.com/office/drawing/2014/main" id="{A94D199B-B254-6A6D-AFA8-4406AA7564C1}"/>
+              </a:ext>
+            </a:extLst>
+          </p:cNvPr>
+          <p:cNvSpPr/>
+          <p:nvPr/>
+        </p:nvSpPr>
+        <p:spPr>
+          <a:xfrm>
+            <a:off x="5759526" y="919796"/>
+            <a:ext cx="418317" cy="402043"/>
+          </a:xfrm>
+          <a:prstGeom prst="roundRect">
+            <a:avLst>
+              <a:gd name="adj" fmla="val 35127"/>
+            </a:avLst>
+          </a:prstGeom>
+          <a:solidFill>
+            <a:srgbClr val="2F3A5F">
+              <a:alpha val="18000"/>
+            </a:srgbClr>
+          </a:solidFill>
+          <a:ln>
+            <a:noFill/>
+          </a:ln>
+        </p:spPr>
+        <p:style>
+          <a:lnRef idx="2">
+            <a:schemeClr val="accent1">
+              <a:shade val="15000"/>
+            </a:schemeClr>
+          </a:lnRef>
+          <a:fillRef idx="1">
+            <a:schemeClr val="accent1"/>
+          </a:fillRef>
+          <a:effectRef idx="0">
+            <a:schemeClr val="accent1"/>
+          </a:effectRef>
+          <a:fontRef idx="minor">
+            <a:schemeClr val="lt1"/>
+          </a:fontRef>
+        </p:style>
+        <p:txBody>
+          <a:bodyPr rtlCol="0" anchor="ctr"/>
+          <a:lstStyle/>
+          <a:p>
+            <a:pPr algn="ctr"/>
+            <a:endParaRPr lang="pt-BR"/>
+          </a:p>
+        </p:txBody>
+      </p:sp>
+      <p:sp>
+        <p:nvSpPr>
+          <p:cNvPr id="20" name="Retângulo: Cantos Arredondados 19">
+            <a:extLst>
+              <a:ext uri="{FF2B5EF4-FFF2-40B4-BE49-F238E27FC236}">
+                <a16:creationId xmlns:a16="http://schemas.microsoft.com/office/drawing/2014/main" id="{0E19E131-03D2-D92F-69A8-033EF3C082B8}"/>
+              </a:ext>
+            </a:extLst>
+          </p:cNvPr>
+          <p:cNvSpPr/>
+          <p:nvPr/>
+        </p:nvSpPr>
+        <p:spPr>
+          <a:xfrm>
+            <a:off x="8666707" y="910787"/>
+            <a:ext cx="337606" cy="393868"/>
+          </a:xfrm>
+          <a:prstGeom prst="roundRect">
+            <a:avLst>
+              <a:gd name="adj" fmla="val 35127"/>
+            </a:avLst>
+          </a:prstGeom>
+          <a:solidFill>
+            <a:srgbClr val="2F3A5F">
+              <a:alpha val="18000"/>
+            </a:srgbClr>
+          </a:solidFill>
+          <a:ln>
+            <a:noFill/>
+          </a:ln>
+        </p:spPr>
+        <p:style>
+          <a:lnRef idx="2">
+            <a:schemeClr val="accent1">
+              <a:shade val="15000"/>
+            </a:schemeClr>
+          </a:lnRef>
+          <a:fillRef idx="1">
+            <a:schemeClr val="accent1"/>
+          </a:fillRef>
+          <a:effectRef idx="0">
+            <a:schemeClr val="accent1"/>
+          </a:effectRef>
+          <a:fontRef idx="minor">
+            <a:schemeClr val="lt1"/>
+          </a:fontRef>
+        </p:style>
+        <p:txBody>
+          <a:bodyPr rtlCol="0" anchor="ctr"/>
+          <a:lstStyle/>
+          <a:p>
+            <a:pPr algn="ctr"/>
+            <a:endParaRPr lang="pt-BR"/>
+          </a:p>
+        </p:txBody>
+      </p:sp>
+      <p:sp>
+        <p:nvSpPr>
+          <p:cNvPr id="22" name="Retângulo: Cantos Arredondados 21">
+            <a:extLst>
+              <a:ext uri="{FF2B5EF4-FFF2-40B4-BE49-F238E27FC236}">
+                <a16:creationId xmlns:a16="http://schemas.microsoft.com/office/drawing/2014/main" id="{C71CE498-97D1-4D8B-F632-AA7BBBAEC550}"/>
+              </a:ext>
+            </a:extLst>
+          </p:cNvPr>
+          <p:cNvSpPr/>
+          <p:nvPr/>
+        </p:nvSpPr>
+        <p:spPr>
+          <a:xfrm>
+            <a:off x="11463698" y="922380"/>
+            <a:ext cx="351700" cy="393867"/>
+          </a:xfrm>
+          <a:prstGeom prst="roundRect">
+            <a:avLst>
+              <a:gd name="adj" fmla="val 35127"/>
+            </a:avLst>
+          </a:prstGeom>
+          <a:solidFill>
+            <a:srgbClr val="2F3A5F">
+              <a:alpha val="20000"/>
+            </a:srgbClr>
+          </a:solidFill>
+          <a:ln>
+            <a:noFill/>
+          </a:ln>
+        </p:spPr>
+        <p:style>
+          <a:lnRef idx="2">
+            <a:schemeClr val="accent1">
+              <a:shade val="15000"/>
+            </a:schemeClr>
+          </a:lnRef>
+          <a:fillRef idx="1">
+            <a:schemeClr val="accent1"/>
+          </a:fillRef>
+          <a:effectRef idx="0">
+            <a:schemeClr val="accent1"/>
+          </a:effectRef>
+          <a:fontRef idx="minor">
+            <a:schemeClr val="lt1"/>
+          </a:fontRef>
+        </p:style>
+        <p:txBody>
+          <a:bodyPr rtlCol="0" anchor="ctr"/>
+          <a:lstStyle/>
+          <a:p>
+            <a:pPr algn="ctr"/>
+            <a:endParaRPr lang="pt-BR" dirty="0"/>
+          </a:p>
+        </p:txBody>
+      </p:sp>
     </p:spTree>
     <p:extLst>
       <p:ext uri="{BB962C8B-B14F-4D97-AF65-F5344CB8AC3E}">

</xml_diff>

<commit_message>
feat: aba operacional - detalhamento criada
</commit_message>
<xml_diff>
--- a/dashboards/Mockup dashboard (em construção).pptx
+++ b/dashboards/Mockup dashboard (em construção).pptx
@@ -7,6 +7,7 @@
   <p:sldIdLst>
     <p:sldId id="258" r:id="rId2"/>
     <p:sldId id="259" r:id="rId3"/>
+    <p:sldId id="260" r:id="rId4"/>
   </p:sldIdLst>
   <p:sldSz cx="12192000" cy="6858000"/>
   <p:notesSz cx="6858000" cy="9144000"/>
@@ -260,7 +261,7 @@
           <a:p>
             <a:fld id="{2DB56B22-234B-48A0-9B90-72A4AF419D03}" type="datetimeFigureOut">
               <a:rPr lang="pt-BR" smtClean="0"/>
-              <a:t>21/02/2026</a:t>
+              <a:t>08/03/2026</a:t>
             </a:fld>
             <a:endParaRPr lang="pt-BR"/>
           </a:p>
@@ -458,7 +459,7 @@
           <a:p>
             <a:fld id="{2DB56B22-234B-48A0-9B90-72A4AF419D03}" type="datetimeFigureOut">
               <a:rPr lang="pt-BR" smtClean="0"/>
-              <a:t>21/02/2026</a:t>
+              <a:t>08/03/2026</a:t>
             </a:fld>
             <a:endParaRPr lang="pt-BR"/>
           </a:p>
@@ -666,7 +667,7 @@
           <a:p>
             <a:fld id="{2DB56B22-234B-48A0-9B90-72A4AF419D03}" type="datetimeFigureOut">
               <a:rPr lang="pt-BR" smtClean="0"/>
-              <a:t>21/02/2026</a:t>
+              <a:t>08/03/2026</a:t>
             </a:fld>
             <a:endParaRPr lang="pt-BR"/>
           </a:p>
@@ -864,7 +865,7 @@
           <a:p>
             <a:fld id="{2DB56B22-234B-48A0-9B90-72A4AF419D03}" type="datetimeFigureOut">
               <a:rPr lang="pt-BR" smtClean="0"/>
-              <a:t>21/02/2026</a:t>
+              <a:t>08/03/2026</a:t>
             </a:fld>
             <a:endParaRPr lang="pt-BR"/>
           </a:p>
@@ -1139,7 +1140,7 @@
           <a:p>
             <a:fld id="{2DB56B22-234B-48A0-9B90-72A4AF419D03}" type="datetimeFigureOut">
               <a:rPr lang="pt-BR" smtClean="0"/>
-              <a:t>21/02/2026</a:t>
+              <a:t>08/03/2026</a:t>
             </a:fld>
             <a:endParaRPr lang="pt-BR"/>
           </a:p>
@@ -1404,7 +1405,7 @@
           <a:p>
             <a:fld id="{2DB56B22-234B-48A0-9B90-72A4AF419D03}" type="datetimeFigureOut">
               <a:rPr lang="pt-BR" smtClean="0"/>
-              <a:t>21/02/2026</a:t>
+              <a:t>08/03/2026</a:t>
             </a:fld>
             <a:endParaRPr lang="pt-BR"/>
           </a:p>
@@ -1816,7 +1817,7 @@
           <a:p>
             <a:fld id="{2DB56B22-234B-48A0-9B90-72A4AF419D03}" type="datetimeFigureOut">
               <a:rPr lang="pt-BR" smtClean="0"/>
-              <a:t>21/02/2026</a:t>
+              <a:t>08/03/2026</a:t>
             </a:fld>
             <a:endParaRPr lang="pt-BR"/>
           </a:p>
@@ -1957,7 +1958,7 @@
           <a:p>
             <a:fld id="{2DB56B22-234B-48A0-9B90-72A4AF419D03}" type="datetimeFigureOut">
               <a:rPr lang="pt-BR" smtClean="0"/>
-              <a:t>21/02/2026</a:t>
+              <a:t>08/03/2026</a:t>
             </a:fld>
             <a:endParaRPr lang="pt-BR"/>
           </a:p>
@@ -2070,7 +2071,7 @@
           <a:p>
             <a:fld id="{2DB56B22-234B-48A0-9B90-72A4AF419D03}" type="datetimeFigureOut">
               <a:rPr lang="pt-BR" smtClean="0"/>
-              <a:t>21/02/2026</a:t>
+              <a:t>08/03/2026</a:t>
             </a:fld>
             <a:endParaRPr lang="pt-BR"/>
           </a:p>
@@ -2381,7 +2382,7 @@
           <a:p>
             <a:fld id="{2DB56B22-234B-48A0-9B90-72A4AF419D03}" type="datetimeFigureOut">
               <a:rPr lang="pt-BR" smtClean="0"/>
-              <a:t>21/02/2026</a:t>
+              <a:t>08/03/2026</a:t>
             </a:fld>
             <a:endParaRPr lang="pt-BR"/>
           </a:p>
@@ -2669,7 +2670,7 @@
           <a:p>
             <a:fld id="{2DB56B22-234B-48A0-9B90-72A4AF419D03}" type="datetimeFigureOut">
               <a:rPr lang="pt-BR" smtClean="0"/>
-              <a:t>21/02/2026</a:t>
+              <a:t>08/03/2026</a:t>
             </a:fld>
             <a:endParaRPr lang="pt-BR"/>
           </a:p>
@@ -2910,7 +2911,7 @@
           <a:p>
             <a:fld id="{2DB56B22-234B-48A0-9B90-72A4AF419D03}" type="datetimeFigureOut">
               <a:rPr lang="pt-BR" smtClean="0"/>
-              <a:t>21/02/2026</a:t>
+              <a:t>08/03/2026</a:t>
             </a:fld>
             <a:endParaRPr lang="pt-BR"/>
           </a:p>
@@ -5451,7 +5452,7 @@
         </p:nvSpPr>
         <p:spPr>
           <a:xfrm>
-            <a:off x="1023457" y="2166731"/>
+            <a:off x="811793" y="2166731"/>
             <a:ext cx="8421442" cy="4501542"/>
           </a:xfrm>
           <a:prstGeom prst="roundRect">
@@ -5653,8 +5654,8 @@
         </p:nvSpPr>
         <p:spPr>
           <a:xfrm>
-            <a:off x="9710530" y="2174508"/>
-            <a:ext cx="2347367" cy="2282750"/>
+            <a:off x="9480224" y="2174508"/>
+            <a:ext cx="2577674" cy="2129373"/>
           </a:xfrm>
           <a:prstGeom prst="roundRect">
             <a:avLst>
@@ -5714,8 +5715,8 @@
         </p:nvSpPr>
         <p:spPr>
           <a:xfrm>
-            <a:off x="9710530" y="4668164"/>
-            <a:ext cx="2337317" cy="2000109"/>
+            <a:off x="9480224" y="4538900"/>
+            <a:ext cx="2567624" cy="2129373"/>
           </a:xfrm>
           <a:prstGeom prst="roundRect">
             <a:avLst>
@@ -5799,10 +5800,10 @@
       </p:pic>
       <p:pic>
         <p:nvPicPr>
-          <p:cNvPr id="24" name="Imagem 23" descr="Ícone&#10;&#10;O conteúdo gerado por IA pode estar incorreto.">
-            <a:extLst>
-              <a:ext uri="{FF2B5EF4-FFF2-40B4-BE49-F238E27FC236}">
-                <a16:creationId xmlns:a16="http://schemas.microsoft.com/office/drawing/2014/main" id="{0EC35161-6032-EBC3-1CDC-7F1E5AF964A5}"/>
+          <p:cNvPr id="31" name="Imagem 30" descr="Ícone&#10;&#10;O conteúdo gerado por IA pode estar incorreto.">
+            <a:extLst>
+              <a:ext uri="{FF2B5EF4-FFF2-40B4-BE49-F238E27FC236}">
+                <a16:creationId xmlns:a16="http://schemas.microsoft.com/office/drawing/2014/main" id="{D8DFE3BC-925E-2547-8113-3CEB4424401D}"/>
               </a:ext>
             </a:extLst>
           </p:cNvPr>
@@ -5813,78 +5814,6 @@
         </p:nvPicPr>
         <p:blipFill>
           <a:blip r:embed="rId5">
-            <a:extLst>
-              <a:ext uri="{28A0092B-C50C-407E-A947-70E740481C1C}">
-                <a14:useLocalDpi xmlns:a14="http://schemas.microsoft.com/office/drawing/2010/main" val="0"/>
-              </a:ext>
-            </a:extLst>
-          </a:blip>
-          <a:stretch>
-            <a:fillRect/>
-          </a:stretch>
-        </p:blipFill>
-        <p:spPr>
-          <a:xfrm>
-            <a:off x="8701646" y="974540"/>
-            <a:ext cx="267729" cy="267729"/>
-          </a:xfrm>
-          <a:prstGeom prst="rect">
-            <a:avLst/>
-          </a:prstGeom>
-        </p:spPr>
-      </p:pic>
-      <p:pic>
-        <p:nvPicPr>
-          <p:cNvPr id="29" name="Imagem 28" descr="Ícone&#10;&#10;O conteúdo gerado por IA pode estar incorreto.">
-            <a:extLst>
-              <a:ext uri="{FF2B5EF4-FFF2-40B4-BE49-F238E27FC236}">
-                <a16:creationId xmlns:a16="http://schemas.microsoft.com/office/drawing/2014/main" id="{6EF39C74-10D2-438D-6758-7FC5583D575B}"/>
-              </a:ext>
-            </a:extLst>
-          </p:cNvPr>
-          <p:cNvPicPr>
-            <a:picLocks noChangeAspect="1"/>
-          </p:cNvPicPr>
-          <p:nvPr/>
-        </p:nvPicPr>
-        <p:blipFill>
-          <a:blip r:embed="rId6">
-            <a:extLst>
-              <a:ext uri="{28A0092B-C50C-407E-A947-70E740481C1C}">
-                <a14:useLocalDpi xmlns:a14="http://schemas.microsoft.com/office/drawing/2010/main" val="0"/>
-              </a:ext>
-            </a:extLst>
-          </a:blip>
-          <a:stretch>
-            <a:fillRect/>
-          </a:stretch>
-        </p:blipFill>
-        <p:spPr>
-          <a:xfrm>
-            <a:off x="11520243" y="1003659"/>
-            <a:ext cx="238610" cy="238610"/>
-          </a:xfrm>
-          <a:prstGeom prst="rect">
-            <a:avLst/>
-          </a:prstGeom>
-        </p:spPr>
-      </p:pic>
-      <p:pic>
-        <p:nvPicPr>
-          <p:cNvPr id="31" name="Imagem 30" descr="Ícone&#10;&#10;O conteúdo gerado por IA pode estar incorreto.">
-            <a:extLst>
-              <a:ext uri="{FF2B5EF4-FFF2-40B4-BE49-F238E27FC236}">
-                <a16:creationId xmlns:a16="http://schemas.microsoft.com/office/drawing/2014/main" id="{D8DFE3BC-925E-2547-8113-3CEB4424401D}"/>
-              </a:ext>
-            </a:extLst>
-          </p:cNvPr>
-          <p:cNvPicPr>
-            <a:picLocks noChangeAspect="1"/>
-          </p:cNvPicPr>
-          <p:nvPr/>
-        </p:nvPicPr>
-        <p:blipFill>
-          <a:blip r:embed="rId7">
             <a:extLst>
               <a:ext uri="{28A0092B-C50C-407E-A947-70E740481C1C}">
                 <a14:useLocalDpi xmlns:a14="http://schemas.microsoft.com/office/drawing/2010/main" val="0"/>
@@ -6334,7 +6263,7 @@
           <p:nvPr/>
         </p:nvPicPr>
         <p:blipFill>
-          <a:blip r:embed="rId8">
+          <a:blip r:embed="rId6">
             <a:extLst>
               <a:ext uri="{28A0092B-C50C-407E-A947-70E740481C1C}">
                 <a14:useLocalDpi xmlns:a14="http://schemas.microsoft.com/office/drawing/2010/main" val="0"/>
@@ -6427,7 +6356,7 @@
           <p:nvPr/>
         </p:nvPicPr>
         <p:blipFill>
-          <a:blip r:embed="rId9">
+          <a:blip r:embed="rId7">
             <a:extLst>
               <a:ext uri="{28A0092B-C50C-407E-A947-70E740481C1C}">
                 <a14:useLocalDpi xmlns:a14="http://schemas.microsoft.com/office/drawing/2010/main" val="0"/>
@@ -6463,7 +6392,7 @@
           <p:nvPr/>
         </p:nvPicPr>
         <p:blipFill>
-          <a:blip r:embed="rId10">
+          <a:blip r:embed="rId8">
             <a:extLst>
               <a:ext uri="{28A0092B-C50C-407E-A947-70E740481C1C}">
                 <a14:useLocalDpi xmlns:a14="http://schemas.microsoft.com/office/drawing/2010/main" val="0"/>
@@ -6499,7 +6428,7 @@
           <p:nvPr/>
         </p:nvPicPr>
         <p:blipFill>
-          <a:blip r:embed="rId11">
+          <a:blip r:embed="rId9">
             <a:extLst>
               <a:ext uri="{28A0092B-C50C-407E-A947-70E740481C1C}">
                 <a14:useLocalDpi xmlns:a14="http://schemas.microsoft.com/office/drawing/2010/main" val="0"/>
@@ -6646,7 +6575,7 @@
         </p:nvSpPr>
         <p:spPr>
           <a:xfrm>
-            <a:off x="8666707" y="910787"/>
+            <a:off x="8651222" y="934552"/>
             <a:ext cx="337606" cy="393868"/>
           </a:xfrm>
           <a:prstGeom prst="roundRect">
@@ -6702,7 +6631,7 @@
         </p:nvSpPr>
         <p:spPr>
           <a:xfrm>
-            <a:off x="11463698" y="922380"/>
+            <a:off x="11478246" y="910788"/>
             <a:ext cx="351700" cy="393867"/>
           </a:xfrm>
           <a:prstGeom prst="roundRect">
@@ -6744,10 +6673,357 @@
           </a:p>
         </p:txBody>
       </p:sp>
+      <p:pic>
+        <p:nvPicPr>
+          <p:cNvPr id="27" name="Imagem 26">
+            <a:extLst>
+              <a:ext uri="{FF2B5EF4-FFF2-40B4-BE49-F238E27FC236}">
+                <a16:creationId xmlns:a16="http://schemas.microsoft.com/office/drawing/2014/main" id="{7D29B853-6F2E-F696-251D-5D6F4336C5D4}"/>
+              </a:ext>
+            </a:extLst>
+          </p:cNvPr>
+          <p:cNvPicPr>
+            <a:picLocks noChangeAspect="1"/>
+          </p:cNvPicPr>
+          <p:nvPr/>
+        </p:nvPicPr>
+        <p:blipFill>
+          <a:blip r:embed="rId10">
+            <a:extLst>
+              <a:ext uri="{28A0092B-C50C-407E-A947-70E740481C1C}">
+                <a14:useLocalDpi xmlns:a14="http://schemas.microsoft.com/office/drawing/2010/main" val="0"/>
+              </a:ext>
+            </a:extLst>
+          </a:blip>
+          <a:stretch>
+            <a:fillRect/>
+          </a:stretch>
+        </p:blipFill>
+        <p:spPr>
+          <a:xfrm>
+            <a:off x="8651222" y="953913"/>
+            <a:ext cx="337605" cy="337605"/>
+          </a:xfrm>
+          <a:prstGeom prst="rect">
+            <a:avLst/>
+          </a:prstGeom>
+        </p:spPr>
+      </p:pic>
+      <p:pic>
+        <p:nvPicPr>
+          <p:cNvPr id="30" name="Imagem 29">
+            <a:extLst>
+              <a:ext uri="{FF2B5EF4-FFF2-40B4-BE49-F238E27FC236}">
+                <a16:creationId xmlns:a16="http://schemas.microsoft.com/office/drawing/2014/main" id="{F7D75856-54AC-12C7-D9BF-F9D2F9803425}"/>
+              </a:ext>
+            </a:extLst>
+          </p:cNvPr>
+          <p:cNvPicPr>
+            <a:picLocks noChangeAspect="1"/>
+          </p:cNvPicPr>
+          <p:nvPr/>
+        </p:nvPicPr>
+        <p:blipFill>
+          <a:blip r:embed="rId11">
+            <a:extLst>
+              <a:ext uri="{28A0092B-C50C-407E-A947-70E740481C1C}">
+                <a14:useLocalDpi xmlns:a14="http://schemas.microsoft.com/office/drawing/2010/main" val="0"/>
+              </a:ext>
+            </a:extLst>
+          </a:blip>
+          <a:stretch>
+            <a:fillRect/>
+          </a:stretch>
+        </p:blipFill>
+        <p:spPr>
+          <a:xfrm>
+            <a:off x="11510697" y="977017"/>
+            <a:ext cx="274707" cy="274707"/>
+          </a:xfrm>
+          <a:prstGeom prst="rect">
+            <a:avLst/>
+          </a:prstGeom>
+        </p:spPr>
+      </p:pic>
     </p:spTree>
     <p:extLst>
       <p:ext uri="{BB962C8B-B14F-4D97-AF65-F5344CB8AC3E}">
         <p14:creationId xmlns:p14="http://schemas.microsoft.com/office/powerpoint/2010/main" val="3804037284"/>
+      </p:ext>
+    </p:extLst>
+  </p:cSld>
+  <p:clrMapOvr>
+    <a:masterClrMapping/>
+  </p:clrMapOvr>
+</p:sld>
+</file>
+
+<file path=ppt/slides/slide3.xml><?xml version="1.0" encoding="utf-8"?>
+<p:sld xmlns:a="http://schemas.openxmlformats.org/drawingml/2006/main" xmlns:r="http://schemas.openxmlformats.org/officeDocument/2006/relationships" xmlns:p="http://schemas.openxmlformats.org/presentationml/2006/main">
+  <p:cSld>
+    <p:bg>
+      <p:bgPr>
+        <a:solidFill>
+          <a:schemeClr val="bg1"/>
+        </a:solidFill>
+        <a:effectLst/>
+      </p:bgPr>
+    </p:bg>
+    <p:spTree>
+      <p:nvGrpSpPr>
+        <p:cNvPr id="1" name=""/>
+        <p:cNvGrpSpPr/>
+        <p:nvPr/>
+      </p:nvGrpSpPr>
+      <p:grpSpPr>
+        <a:xfrm>
+          <a:off x="0" y="0"/>
+          <a:ext cx="0" cy="0"/>
+          <a:chOff x="0" y="0"/>
+          <a:chExt cx="0" cy="0"/>
+        </a:xfrm>
+      </p:grpSpPr>
+      <p:sp>
+        <p:nvSpPr>
+          <p:cNvPr id="10" name="Rectangle 9">
+            <a:extLst>
+              <a:ext uri="{FF2B5EF4-FFF2-40B4-BE49-F238E27FC236}">
+                <a16:creationId xmlns:a16="http://schemas.microsoft.com/office/drawing/2014/main" id="{42A4FC2C-047E-45A5-965D-8E1E3BF09BC6}"/>
+              </a:ext>
+              <a:ext uri="{C183D7F6-B498-43B3-948B-1728B52AA6E4}">
+                <adec:decorative xmlns:adec="http://schemas.microsoft.com/office/drawing/2017/decorative" val="1"/>
+              </a:ext>
+            </a:extLst>
+          </p:cNvPr>
+          <p:cNvSpPr>
+            <a:spLocks noGrp="1" noRot="1" noChangeAspect="1" noMove="1" noResize="1" noEditPoints="1" noAdjustHandles="1" noChangeArrowheads="1" noChangeShapeType="1" noTextEdit="1"/>
+          </p:cNvSpPr>
+          <p:nvPr>
+            <p:extLst>
+              <p:ext uri="{386F3935-93C4-4BCD-93E2-E3B085C9AB24}">
+                <p16:designElem xmlns:p16="http://schemas.microsoft.com/office/powerpoint/2015/main" val="1"/>
+              </p:ext>
+            </p:extLst>
+          </p:nvPr>
+        </p:nvSpPr>
+        <p:spPr bwMode="white">
+          <a:xfrm>
+            <a:off x="1524" y="0"/>
+            <a:ext cx="12188952" cy="6858000"/>
+          </a:xfrm>
+          <a:prstGeom prst="rect">
+            <a:avLst/>
+          </a:prstGeom>
+          <a:noFill/>
+          <a:ln>
+            <a:noFill/>
+          </a:ln>
+        </p:spPr>
+        <p:style>
+          <a:lnRef idx="2">
+            <a:schemeClr val="accent1">
+              <a:shade val="50000"/>
+            </a:schemeClr>
+          </a:lnRef>
+          <a:fillRef idx="1">
+            <a:schemeClr val="accent1"/>
+          </a:fillRef>
+          <a:effectRef idx="0">
+            <a:schemeClr val="accent1"/>
+          </a:effectRef>
+          <a:fontRef idx="minor">
+            <a:schemeClr val="lt1"/>
+          </a:fontRef>
+        </p:style>
+        <p:txBody>
+          <a:bodyPr rtlCol="0" anchor="ctr"/>
+          <a:lstStyle>
+            <a:defPPr>
+              <a:defRPr lang="en-US"/>
+            </a:defPPr>
+            <a:lvl1pPr marL="0" algn="l" defTabSz="914400" rtl="0" eaLnBrk="1" latinLnBrk="0" hangingPunct="1">
+              <a:defRPr sz="1800" kern="1200">
+                <a:solidFill>
+                  <a:schemeClr val="lt1"/>
+                </a:solidFill>
+                <a:latin typeface="+mn-lt"/>
+                <a:ea typeface="+mn-ea"/>
+                <a:cs typeface="+mn-cs"/>
+              </a:defRPr>
+            </a:lvl1pPr>
+            <a:lvl2pPr marL="457200" algn="l" defTabSz="914400" rtl="0" eaLnBrk="1" latinLnBrk="0" hangingPunct="1">
+              <a:defRPr sz="1800" kern="1200">
+                <a:solidFill>
+                  <a:schemeClr val="lt1"/>
+                </a:solidFill>
+                <a:latin typeface="+mn-lt"/>
+                <a:ea typeface="+mn-ea"/>
+                <a:cs typeface="+mn-cs"/>
+              </a:defRPr>
+            </a:lvl2pPr>
+            <a:lvl3pPr marL="914400" algn="l" defTabSz="914400" rtl="0" eaLnBrk="1" latinLnBrk="0" hangingPunct="1">
+              <a:defRPr sz="1800" kern="1200">
+                <a:solidFill>
+                  <a:schemeClr val="lt1"/>
+                </a:solidFill>
+                <a:latin typeface="+mn-lt"/>
+                <a:ea typeface="+mn-ea"/>
+                <a:cs typeface="+mn-cs"/>
+              </a:defRPr>
+            </a:lvl3pPr>
+            <a:lvl4pPr marL="1371600" algn="l" defTabSz="914400" rtl="0" eaLnBrk="1" latinLnBrk="0" hangingPunct="1">
+              <a:defRPr sz="1800" kern="1200">
+                <a:solidFill>
+                  <a:schemeClr val="lt1"/>
+                </a:solidFill>
+                <a:latin typeface="+mn-lt"/>
+                <a:ea typeface="+mn-ea"/>
+                <a:cs typeface="+mn-cs"/>
+              </a:defRPr>
+            </a:lvl4pPr>
+            <a:lvl5pPr marL="1828800" algn="l" defTabSz="914400" rtl="0" eaLnBrk="1" latinLnBrk="0" hangingPunct="1">
+              <a:defRPr sz="1800" kern="1200">
+                <a:solidFill>
+                  <a:schemeClr val="lt1"/>
+                </a:solidFill>
+                <a:latin typeface="+mn-lt"/>
+                <a:ea typeface="+mn-ea"/>
+                <a:cs typeface="+mn-cs"/>
+              </a:defRPr>
+            </a:lvl5pPr>
+            <a:lvl6pPr marL="2286000" algn="l" defTabSz="914400" rtl="0" eaLnBrk="1" latinLnBrk="0" hangingPunct="1">
+              <a:defRPr sz="1800" kern="1200">
+                <a:solidFill>
+                  <a:schemeClr val="lt1"/>
+                </a:solidFill>
+                <a:latin typeface="+mn-lt"/>
+                <a:ea typeface="+mn-ea"/>
+                <a:cs typeface="+mn-cs"/>
+              </a:defRPr>
+            </a:lvl6pPr>
+            <a:lvl7pPr marL="2743200" algn="l" defTabSz="914400" rtl="0" eaLnBrk="1" latinLnBrk="0" hangingPunct="1">
+              <a:defRPr sz="1800" kern="1200">
+                <a:solidFill>
+                  <a:schemeClr val="lt1"/>
+                </a:solidFill>
+                <a:latin typeface="+mn-lt"/>
+                <a:ea typeface="+mn-ea"/>
+                <a:cs typeface="+mn-cs"/>
+              </a:defRPr>
+            </a:lvl7pPr>
+            <a:lvl8pPr marL="3200400" algn="l" defTabSz="914400" rtl="0" eaLnBrk="1" latinLnBrk="0" hangingPunct="1">
+              <a:defRPr sz="1800" kern="1200">
+                <a:solidFill>
+                  <a:schemeClr val="lt1"/>
+                </a:solidFill>
+                <a:latin typeface="+mn-lt"/>
+                <a:ea typeface="+mn-ea"/>
+                <a:cs typeface="+mn-cs"/>
+              </a:defRPr>
+            </a:lvl8pPr>
+            <a:lvl9pPr marL="3657600" algn="l" defTabSz="914400" rtl="0" eaLnBrk="1" latinLnBrk="0" hangingPunct="1">
+              <a:defRPr sz="1800" kern="1200">
+                <a:solidFill>
+                  <a:schemeClr val="lt1"/>
+                </a:solidFill>
+                <a:latin typeface="+mn-lt"/>
+                <a:ea typeface="+mn-ea"/>
+                <a:cs typeface="+mn-cs"/>
+              </a:defRPr>
+            </a:lvl9pPr>
+          </a:lstStyle>
+          <a:p>
+            <a:pPr algn="ctr"/>
+            <a:endParaRPr lang="en-US"/>
+          </a:p>
+        </p:txBody>
+      </p:sp>
+      <p:pic>
+        <p:nvPicPr>
+          <p:cNvPr id="5" name="Imagem 4">
+            <a:extLst>
+              <a:ext uri="{FF2B5EF4-FFF2-40B4-BE49-F238E27FC236}">
+                <a16:creationId xmlns:a16="http://schemas.microsoft.com/office/drawing/2014/main" id="{DDADCDF9-7AD1-B0B1-B37F-359BDE21AB29}"/>
+              </a:ext>
+            </a:extLst>
+          </p:cNvPr>
+          <p:cNvPicPr>
+            <a:picLocks noChangeAspect="1"/>
+          </p:cNvPicPr>
+          <p:nvPr/>
+        </p:nvPicPr>
+        <p:blipFill>
+          <a:blip r:embed="rId2"/>
+          <a:srcRect b="19"/>
+          <a:stretch>
+            <a:fillRect/>
+          </a:stretch>
+        </p:blipFill>
+        <p:spPr>
+          <a:xfrm>
+            <a:off x="20" y="1282"/>
+            <a:ext cx="12191980" cy="6856718"/>
+          </a:xfrm>
+          <a:prstGeom prst="rect">
+            <a:avLst/>
+          </a:prstGeom>
+        </p:spPr>
+      </p:pic>
+      <p:sp>
+        <p:nvSpPr>
+          <p:cNvPr id="6" name="Retângulo: Cantos Arredondados 5">
+            <a:extLst>
+              <a:ext uri="{FF2B5EF4-FFF2-40B4-BE49-F238E27FC236}">
+                <a16:creationId xmlns:a16="http://schemas.microsoft.com/office/drawing/2014/main" id="{C4FEBE7A-C67E-E609-F132-491E4C7B4A3B}"/>
+              </a:ext>
+            </a:extLst>
+          </p:cNvPr>
+          <p:cNvSpPr/>
+          <p:nvPr/>
+        </p:nvSpPr>
+        <p:spPr>
+          <a:xfrm>
+            <a:off x="821268" y="2175933"/>
+            <a:ext cx="8407400" cy="635000"/>
+          </a:xfrm>
+          <a:prstGeom prst="roundRect">
+            <a:avLst>
+              <a:gd name="adj" fmla="val 31160"/>
+            </a:avLst>
+          </a:prstGeom>
+          <a:solidFill>
+            <a:srgbClr val="2F3A5F"/>
+          </a:solidFill>
+        </p:spPr>
+        <p:style>
+          <a:lnRef idx="2">
+            <a:schemeClr val="accent1">
+              <a:shade val="15000"/>
+            </a:schemeClr>
+          </a:lnRef>
+          <a:fillRef idx="1">
+            <a:schemeClr val="accent1"/>
+          </a:fillRef>
+          <a:effectRef idx="0">
+            <a:schemeClr val="accent1"/>
+          </a:effectRef>
+          <a:fontRef idx="minor">
+            <a:schemeClr val="lt1"/>
+          </a:fontRef>
+        </p:style>
+        <p:txBody>
+          <a:bodyPr rtlCol="0" anchor="ctr"/>
+          <a:lstStyle/>
+          <a:p>
+            <a:pPr algn="ctr"/>
+            <a:endParaRPr lang="pt-BR"/>
+          </a:p>
+        </p:txBody>
+      </p:sp>
+    </p:spTree>
+    <p:extLst>
+      <p:ext uri="{BB962C8B-B14F-4D97-AF65-F5344CB8AC3E}">
+        <p14:creationId xmlns:p14="http://schemas.microsoft.com/office/powerpoint/2010/main" val="655971267"/>
       </p:ext>
     </p:extLst>
   </p:cSld>

</xml_diff>

<commit_message>
feat: Aba Analytics - Performance finalizada
</commit_message>
<xml_diff>
--- a/dashboards/Mockup dashboard (em construção).pptx
+++ b/dashboards/Mockup dashboard (em construção).pptx
@@ -6771,7 +6771,13 @@
     </p:bg>
     <p:spTree>
       <p:nvGrpSpPr>
-        <p:cNvPr id="1" name=""/>
+        <p:cNvPr id="1" name="">
+          <a:extLst>
+            <a:ext uri="{FF2B5EF4-FFF2-40B4-BE49-F238E27FC236}">
+              <a16:creationId xmlns:a16="http://schemas.microsoft.com/office/drawing/2014/main" id="{DDA059C2-C4A4-B63E-F1E1-85D995A853BF}"/>
+            </a:ext>
+          </a:extLst>
+        </p:cNvPr>
         <p:cNvGrpSpPr/>
         <p:nvPr/>
       </p:nvGrpSpPr>
@@ -6785,31 +6791,853 @@
       </p:grpSpPr>
       <p:sp>
         <p:nvSpPr>
-          <p:cNvPr id="10" name="Rectangle 9">
-            <a:extLst>
-              <a:ext uri="{FF2B5EF4-FFF2-40B4-BE49-F238E27FC236}">
-                <a16:creationId xmlns:a16="http://schemas.microsoft.com/office/drawing/2014/main" id="{42A4FC2C-047E-45A5-965D-8E1E3BF09BC6}"/>
-              </a:ext>
-              <a:ext uri="{C183D7F6-B498-43B3-948B-1728B52AA6E4}">
-                <adec:decorative xmlns:adec="http://schemas.microsoft.com/office/drawing/2017/decorative" val="1"/>
+          <p:cNvPr id="33" name="Retângulo: Cantos Arredondados 32">
+            <a:extLst>
+              <a:ext uri="{FF2B5EF4-FFF2-40B4-BE49-F238E27FC236}">
+                <a16:creationId xmlns:a16="http://schemas.microsoft.com/office/drawing/2014/main" id="{45E11D63-BBE6-BDCF-114B-A605ABA514D8}"/>
+              </a:ext>
+            </a:extLst>
+          </p:cNvPr>
+          <p:cNvSpPr/>
+          <p:nvPr/>
+        </p:nvSpPr>
+        <p:spPr>
+          <a:xfrm>
+            <a:off x="0" y="0"/>
+            <a:ext cx="12192000" cy="6858000"/>
+          </a:xfrm>
+          <a:prstGeom prst="roundRect">
+            <a:avLst>
+              <a:gd name="adj" fmla="val 4058"/>
+            </a:avLst>
+          </a:prstGeom>
+          <a:solidFill>
+            <a:srgbClr val="F3F4F8"/>
+          </a:solidFill>
+          <a:ln>
+            <a:noFill/>
+          </a:ln>
+        </p:spPr>
+        <p:style>
+          <a:lnRef idx="2">
+            <a:schemeClr val="accent1">
+              <a:shade val="15000"/>
+            </a:schemeClr>
+          </a:lnRef>
+          <a:fillRef idx="1">
+            <a:schemeClr val="accent1"/>
+          </a:fillRef>
+          <a:effectRef idx="0">
+            <a:schemeClr val="accent1"/>
+          </a:effectRef>
+          <a:fontRef idx="minor">
+            <a:schemeClr val="lt1"/>
+          </a:fontRef>
+        </p:style>
+        <p:txBody>
+          <a:bodyPr rtlCol="0" anchor="ctr"/>
+          <a:lstStyle/>
+          <a:p>
+            <a:endParaRPr lang="pt-BR"/>
+          </a:p>
+        </p:txBody>
+      </p:sp>
+      <p:sp>
+        <p:nvSpPr>
+          <p:cNvPr id="5" name="Retângulo: Cantos Arredondados 4">
+            <a:extLst>
+              <a:ext uri="{FF2B5EF4-FFF2-40B4-BE49-F238E27FC236}">
+                <a16:creationId xmlns:a16="http://schemas.microsoft.com/office/drawing/2014/main" id="{9DA83FE9-4556-0BC2-4684-C023939A94F6}"/>
+              </a:ext>
+            </a:extLst>
+          </p:cNvPr>
+          <p:cNvSpPr/>
+          <p:nvPr/>
+        </p:nvSpPr>
+        <p:spPr>
+          <a:xfrm>
+            <a:off x="-177079" y="897622"/>
+            <a:ext cx="715733" cy="4337108"/>
+          </a:xfrm>
+          <a:prstGeom prst="roundRect">
+            <a:avLst/>
+          </a:prstGeom>
+          <a:solidFill>
+            <a:srgbClr val="2F3A5F"/>
+          </a:solidFill>
+          <a:ln>
+            <a:noFill/>
+          </a:ln>
+          <a:effectLst>
+            <a:outerShdw blurRad="101600" dist="38100" dir="5400000" algn="t" rotWithShape="0">
+              <a:prstClr val="black">
+                <a:alpha val="20000"/>
+              </a:prstClr>
+            </a:outerShdw>
+          </a:effectLst>
+        </p:spPr>
+        <p:style>
+          <a:lnRef idx="2">
+            <a:schemeClr val="accent1">
+              <a:shade val="15000"/>
+            </a:schemeClr>
+          </a:lnRef>
+          <a:fillRef idx="1">
+            <a:schemeClr val="accent1"/>
+          </a:fillRef>
+          <a:effectRef idx="0">
+            <a:schemeClr val="accent1"/>
+          </a:effectRef>
+          <a:fontRef idx="minor">
+            <a:schemeClr val="lt1"/>
+          </a:fontRef>
+        </p:style>
+        <p:txBody>
+          <a:bodyPr rtlCol="0" anchor="ctr"/>
+          <a:lstStyle/>
+          <a:p>
+            <a:pPr algn="ctr"/>
+            <a:endParaRPr lang="pt-BR"/>
+          </a:p>
+        </p:txBody>
+      </p:sp>
+      <p:sp>
+        <p:nvSpPr>
+          <p:cNvPr id="43" name="Retângulo: Cantos Arredondados 42">
+            <a:extLst>
+              <a:ext uri="{FF2B5EF4-FFF2-40B4-BE49-F238E27FC236}">
+                <a16:creationId xmlns:a16="http://schemas.microsoft.com/office/drawing/2014/main" id="{34CEEA33-8D78-0A90-2C50-B77250D0C733}"/>
+              </a:ext>
+            </a:extLst>
+          </p:cNvPr>
+          <p:cNvSpPr/>
+          <p:nvPr/>
+        </p:nvSpPr>
+        <p:spPr>
+          <a:xfrm>
+            <a:off x="-1170" y="-45343"/>
+            <a:ext cx="12233684" cy="853130"/>
+          </a:xfrm>
+          <a:custGeom>
+            <a:avLst/>
+            <a:gdLst>
+              <a:gd name="connsiteX0" fmla="*/ 0 w 12192000"/>
+              <a:gd name="connsiteY0" fmla="*/ 245786 h 491571"/>
+              <a:gd name="connsiteX1" fmla="*/ 245786 w 12192000"/>
+              <a:gd name="connsiteY1" fmla="*/ 0 h 491571"/>
+              <a:gd name="connsiteX2" fmla="*/ 11946215 w 12192000"/>
+              <a:gd name="connsiteY2" fmla="*/ 0 h 491571"/>
+              <a:gd name="connsiteX3" fmla="*/ 12192001 w 12192000"/>
+              <a:gd name="connsiteY3" fmla="*/ 245786 h 491571"/>
+              <a:gd name="connsiteX4" fmla="*/ 12192000 w 12192000"/>
+              <a:gd name="connsiteY4" fmla="*/ 245786 h 491571"/>
+              <a:gd name="connsiteX5" fmla="*/ 11946214 w 12192000"/>
+              <a:gd name="connsiteY5" fmla="*/ 491572 h 491571"/>
+              <a:gd name="connsiteX6" fmla="*/ 245786 w 12192000"/>
+              <a:gd name="connsiteY6" fmla="*/ 491571 h 491571"/>
+              <a:gd name="connsiteX7" fmla="*/ 0 w 12192000"/>
+              <a:gd name="connsiteY7" fmla="*/ 245785 h 491571"/>
+              <a:gd name="connsiteX8" fmla="*/ 0 w 12192000"/>
+              <a:gd name="connsiteY8" fmla="*/ 245786 h 491571"/>
+              <a:gd name="connsiteX0" fmla="*/ 8746 w 12200747"/>
+              <a:gd name="connsiteY0" fmla="*/ 245786 h 525126"/>
+              <a:gd name="connsiteX1" fmla="*/ 254532 w 12200747"/>
+              <a:gd name="connsiteY1" fmla="*/ 0 h 525126"/>
+              <a:gd name="connsiteX2" fmla="*/ 11954961 w 12200747"/>
+              <a:gd name="connsiteY2" fmla="*/ 0 h 525126"/>
+              <a:gd name="connsiteX3" fmla="*/ 12200747 w 12200747"/>
+              <a:gd name="connsiteY3" fmla="*/ 245786 h 525126"/>
+              <a:gd name="connsiteX4" fmla="*/ 12200746 w 12200747"/>
+              <a:gd name="connsiteY4" fmla="*/ 245786 h 525126"/>
+              <a:gd name="connsiteX5" fmla="*/ 11954960 w 12200747"/>
+              <a:gd name="connsiteY5" fmla="*/ 491572 h 525126"/>
+              <a:gd name="connsiteX6" fmla="*/ 95141 w 12200747"/>
+              <a:gd name="connsiteY6" fmla="*/ 525126 h 525126"/>
+              <a:gd name="connsiteX7" fmla="*/ 8746 w 12200747"/>
+              <a:gd name="connsiteY7" fmla="*/ 245785 h 525126"/>
+              <a:gd name="connsiteX8" fmla="*/ 8746 w 12200747"/>
+              <a:gd name="connsiteY8" fmla="*/ 245786 h 525126"/>
+              <a:gd name="connsiteX0" fmla="*/ 7009 w 12199010"/>
+              <a:gd name="connsiteY0" fmla="*/ 245786 h 539413"/>
+              <a:gd name="connsiteX1" fmla="*/ 252795 w 12199010"/>
+              <a:gd name="connsiteY1" fmla="*/ 0 h 539413"/>
+              <a:gd name="connsiteX2" fmla="*/ 11953224 w 12199010"/>
+              <a:gd name="connsiteY2" fmla="*/ 0 h 539413"/>
+              <a:gd name="connsiteX3" fmla="*/ 12199010 w 12199010"/>
+              <a:gd name="connsiteY3" fmla="*/ 245786 h 539413"/>
+              <a:gd name="connsiteX4" fmla="*/ 12199009 w 12199010"/>
+              <a:gd name="connsiteY4" fmla="*/ 245786 h 539413"/>
+              <a:gd name="connsiteX5" fmla="*/ 11953223 w 12199010"/>
+              <a:gd name="connsiteY5" fmla="*/ 491572 h 539413"/>
+              <a:gd name="connsiteX6" fmla="*/ 98167 w 12199010"/>
+              <a:gd name="connsiteY6" fmla="*/ 539413 h 539413"/>
+              <a:gd name="connsiteX7" fmla="*/ 7009 w 12199010"/>
+              <a:gd name="connsiteY7" fmla="*/ 245785 h 539413"/>
+              <a:gd name="connsiteX8" fmla="*/ 7009 w 12199010"/>
+              <a:gd name="connsiteY8" fmla="*/ 245786 h 539413"/>
+              <a:gd name="connsiteX0" fmla="*/ 4473 w 12196474"/>
+              <a:gd name="connsiteY0" fmla="*/ 245786 h 539439"/>
+              <a:gd name="connsiteX1" fmla="*/ 250259 w 12196474"/>
+              <a:gd name="connsiteY1" fmla="*/ 0 h 539439"/>
+              <a:gd name="connsiteX2" fmla="*/ 11950688 w 12196474"/>
+              <a:gd name="connsiteY2" fmla="*/ 0 h 539439"/>
+              <a:gd name="connsiteX3" fmla="*/ 12196474 w 12196474"/>
+              <a:gd name="connsiteY3" fmla="*/ 245786 h 539439"/>
+              <a:gd name="connsiteX4" fmla="*/ 12196473 w 12196474"/>
+              <a:gd name="connsiteY4" fmla="*/ 245786 h 539439"/>
+              <a:gd name="connsiteX5" fmla="*/ 11950687 w 12196474"/>
+              <a:gd name="connsiteY5" fmla="*/ 491572 h 539439"/>
+              <a:gd name="connsiteX6" fmla="*/ 95631 w 12196474"/>
+              <a:gd name="connsiteY6" fmla="*/ 539413 h 539439"/>
+              <a:gd name="connsiteX7" fmla="*/ 4473 w 12196474"/>
+              <a:gd name="connsiteY7" fmla="*/ 245785 h 539439"/>
+              <a:gd name="connsiteX8" fmla="*/ 4473 w 12196474"/>
+              <a:gd name="connsiteY8" fmla="*/ 245786 h 539439"/>
+              <a:gd name="connsiteX0" fmla="*/ 48673 w 12240674"/>
+              <a:gd name="connsiteY0" fmla="*/ 245786 h 539439"/>
+              <a:gd name="connsiteX1" fmla="*/ 294459 w 12240674"/>
+              <a:gd name="connsiteY1" fmla="*/ 0 h 539439"/>
+              <a:gd name="connsiteX2" fmla="*/ 11994888 w 12240674"/>
+              <a:gd name="connsiteY2" fmla="*/ 0 h 539439"/>
+              <a:gd name="connsiteX3" fmla="*/ 12240674 w 12240674"/>
+              <a:gd name="connsiteY3" fmla="*/ 245786 h 539439"/>
+              <a:gd name="connsiteX4" fmla="*/ 12240673 w 12240674"/>
+              <a:gd name="connsiteY4" fmla="*/ 245786 h 539439"/>
+              <a:gd name="connsiteX5" fmla="*/ 11994887 w 12240674"/>
+              <a:gd name="connsiteY5" fmla="*/ 491572 h 539439"/>
+              <a:gd name="connsiteX6" fmla="*/ 58868 w 12240674"/>
+              <a:gd name="connsiteY6" fmla="*/ 539413 h 539439"/>
+              <a:gd name="connsiteX7" fmla="*/ 48673 w 12240674"/>
+              <a:gd name="connsiteY7" fmla="*/ 245785 h 539439"/>
+              <a:gd name="connsiteX8" fmla="*/ 48673 w 12240674"/>
+              <a:gd name="connsiteY8" fmla="*/ 245786 h 539439"/>
+              <a:gd name="connsiteX0" fmla="*/ 0 w 12192001"/>
+              <a:gd name="connsiteY0" fmla="*/ 245786 h 540522"/>
+              <a:gd name="connsiteX1" fmla="*/ 245786 w 12192001"/>
+              <a:gd name="connsiteY1" fmla="*/ 0 h 540522"/>
+              <a:gd name="connsiteX2" fmla="*/ 11946215 w 12192001"/>
+              <a:gd name="connsiteY2" fmla="*/ 0 h 540522"/>
+              <a:gd name="connsiteX3" fmla="*/ 12192001 w 12192001"/>
+              <a:gd name="connsiteY3" fmla="*/ 245786 h 540522"/>
+              <a:gd name="connsiteX4" fmla="*/ 12192000 w 12192001"/>
+              <a:gd name="connsiteY4" fmla="*/ 245786 h 540522"/>
+              <a:gd name="connsiteX5" fmla="*/ 11946214 w 12192001"/>
+              <a:gd name="connsiteY5" fmla="*/ 491572 h 540522"/>
+              <a:gd name="connsiteX6" fmla="*/ 10195 w 12192001"/>
+              <a:gd name="connsiteY6" fmla="*/ 539413 h 540522"/>
+              <a:gd name="connsiteX7" fmla="*/ 0 w 12192001"/>
+              <a:gd name="connsiteY7" fmla="*/ 245785 h 540522"/>
+              <a:gd name="connsiteX8" fmla="*/ 0 w 12192001"/>
+              <a:gd name="connsiteY8" fmla="*/ 245786 h 540522"/>
+              <a:gd name="connsiteX0" fmla="*/ 1172 w 12193173"/>
+              <a:gd name="connsiteY0" fmla="*/ 245786 h 540522"/>
+              <a:gd name="connsiteX1" fmla="*/ 246958 w 12193173"/>
+              <a:gd name="connsiteY1" fmla="*/ 0 h 540522"/>
+              <a:gd name="connsiteX2" fmla="*/ 11947387 w 12193173"/>
+              <a:gd name="connsiteY2" fmla="*/ 0 h 540522"/>
+              <a:gd name="connsiteX3" fmla="*/ 12193173 w 12193173"/>
+              <a:gd name="connsiteY3" fmla="*/ 245786 h 540522"/>
+              <a:gd name="connsiteX4" fmla="*/ 12193172 w 12193173"/>
+              <a:gd name="connsiteY4" fmla="*/ 245786 h 540522"/>
+              <a:gd name="connsiteX5" fmla="*/ 11947386 w 12193173"/>
+              <a:gd name="connsiteY5" fmla="*/ 491572 h 540522"/>
+              <a:gd name="connsiteX6" fmla="*/ 4223 w 12193173"/>
+              <a:gd name="connsiteY6" fmla="*/ 539413 h 540522"/>
+              <a:gd name="connsiteX7" fmla="*/ 1172 w 12193173"/>
+              <a:gd name="connsiteY7" fmla="*/ 245785 h 540522"/>
+              <a:gd name="connsiteX8" fmla="*/ 1172 w 12193173"/>
+              <a:gd name="connsiteY8" fmla="*/ 245786 h 540522"/>
+              <a:gd name="connsiteX0" fmla="*/ 1172 w 12231428"/>
+              <a:gd name="connsiteY0" fmla="*/ 245786 h 540522"/>
+              <a:gd name="connsiteX1" fmla="*/ 246958 w 12231428"/>
+              <a:gd name="connsiteY1" fmla="*/ 0 h 540522"/>
+              <a:gd name="connsiteX2" fmla="*/ 11947387 w 12231428"/>
+              <a:gd name="connsiteY2" fmla="*/ 0 h 540522"/>
+              <a:gd name="connsiteX3" fmla="*/ 12193173 w 12231428"/>
+              <a:gd name="connsiteY3" fmla="*/ 245786 h 540522"/>
+              <a:gd name="connsiteX4" fmla="*/ 12193172 w 12231428"/>
+              <a:gd name="connsiteY4" fmla="*/ 245786 h 540522"/>
+              <a:gd name="connsiteX5" fmla="*/ 12161698 w 12231428"/>
+              <a:gd name="connsiteY5" fmla="*/ 486810 h 540522"/>
+              <a:gd name="connsiteX6" fmla="*/ 4223 w 12231428"/>
+              <a:gd name="connsiteY6" fmla="*/ 539413 h 540522"/>
+              <a:gd name="connsiteX7" fmla="*/ 1172 w 12231428"/>
+              <a:gd name="connsiteY7" fmla="*/ 245785 h 540522"/>
+              <a:gd name="connsiteX8" fmla="*/ 1172 w 12231428"/>
+              <a:gd name="connsiteY8" fmla="*/ 245786 h 540522"/>
+              <a:gd name="connsiteX0" fmla="*/ 1172 w 12195146"/>
+              <a:gd name="connsiteY0" fmla="*/ 245786 h 540522"/>
+              <a:gd name="connsiteX1" fmla="*/ 246958 w 12195146"/>
+              <a:gd name="connsiteY1" fmla="*/ 0 h 540522"/>
+              <a:gd name="connsiteX2" fmla="*/ 11947387 w 12195146"/>
+              <a:gd name="connsiteY2" fmla="*/ 0 h 540522"/>
+              <a:gd name="connsiteX3" fmla="*/ 12193173 w 12195146"/>
+              <a:gd name="connsiteY3" fmla="*/ 245786 h 540522"/>
+              <a:gd name="connsiteX4" fmla="*/ 12193172 w 12195146"/>
+              <a:gd name="connsiteY4" fmla="*/ 245786 h 540522"/>
+              <a:gd name="connsiteX5" fmla="*/ 12161698 w 12195146"/>
+              <a:gd name="connsiteY5" fmla="*/ 486810 h 540522"/>
+              <a:gd name="connsiteX6" fmla="*/ 4223 w 12195146"/>
+              <a:gd name="connsiteY6" fmla="*/ 539413 h 540522"/>
+              <a:gd name="connsiteX7" fmla="*/ 1172 w 12195146"/>
+              <a:gd name="connsiteY7" fmla="*/ 245785 h 540522"/>
+              <a:gd name="connsiteX8" fmla="*/ 1172 w 12195146"/>
+              <a:gd name="connsiteY8" fmla="*/ 245786 h 540522"/>
+              <a:gd name="connsiteX0" fmla="*/ 1172 w 12244277"/>
+              <a:gd name="connsiteY0" fmla="*/ 245786 h 540522"/>
+              <a:gd name="connsiteX1" fmla="*/ 246958 w 12244277"/>
+              <a:gd name="connsiteY1" fmla="*/ 0 h 540522"/>
+              <a:gd name="connsiteX2" fmla="*/ 11947387 w 12244277"/>
+              <a:gd name="connsiteY2" fmla="*/ 0 h 540522"/>
+              <a:gd name="connsiteX3" fmla="*/ 12193173 w 12244277"/>
+              <a:gd name="connsiteY3" fmla="*/ 245786 h 540522"/>
+              <a:gd name="connsiteX4" fmla="*/ 12193172 w 12244277"/>
+              <a:gd name="connsiteY4" fmla="*/ 245786 h 540522"/>
+              <a:gd name="connsiteX5" fmla="*/ 12230754 w 12244277"/>
+              <a:gd name="connsiteY5" fmla="*/ 484428 h 540522"/>
+              <a:gd name="connsiteX6" fmla="*/ 4223 w 12244277"/>
+              <a:gd name="connsiteY6" fmla="*/ 539413 h 540522"/>
+              <a:gd name="connsiteX7" fmla="*/ 1172 w 12244277"/>
+              <a:gd name="connsiteY7" fmla="*/ 245785 h 540522"/>
+              <a:gd name="connsiteX8" fmla="*/ 1172 w 12244277"/>
+              <a:gd name="connsiteY8" fmla="*/ 245786 h 540522"/>
+              <a:gd name="connsiteX0" fmla="*/ 1172 w 12222094"/>
+              <a:gd name="connsiteY0" fmla="*/ 245786 h 540522"/>
+              <a:gd name="connsiteX1" fmla="*/ 246958 w 12222094"/>
+              <a:gd name="connsiteY1" fmla="*/ 0 h 540522"/>
+              <a:gd name="connsiteX2" fmla="*/ 11947387 w 12222094"/>
+              <a:gd name="connsiteY2" fmla="*/ 0 h 540522"/>
+              <a:gd name="connsiteX3" fmla="*/ 12193173 w 12222094"/>
+              <a:gd name="connsiteY3" fmla="*/ 245786 h 540522"/>
+              <a:gd name="connsiteX4" fmla="*/ 12193172 w 12222094"/>
+              <a:gd name="connsiteY4" fmla="*/ 245786 h 540522"/>
+              <a:gd name="connsiteX5" fmla="*/ 12204561 w 12222094"/>
+              <a:gd name="connsiteY5" fmla="*/ 489190 h 540522"/>
+              <a:gd name="connsiteX6" fmla="*/ 4223 w 12222094"/>
+              <a:gd name="connsiteY6" fmla="*/ 539413 h 540522"/>
+              <a:gd name="connsiteX7" fmla="*/ 1172 w 12222094"/>
+              <a:gd name="connsiteY7" fmla="*/ 245785 h 540522"/>
+              <a:gd name="connsiteX8" fmla="*/ 1172 w 12222094"/>
+              <a:gd name="connsiteY8" fmla="*/ 245786 h 540522"/>
+              <a:gd name="connsiteX0" fmla="*/ 1172 w 12207823"/>
+              <a:gd name="connsiteY0" fmla="*/ 245786 h 540522"/>
+              <a:gd name="connsiteX1" fmla="*/ 246958 w 12207823"/>
+              <a:gd name="connsiteY1" fmla="*/ 0 h 540522"/>
+              <a:gd name="connsiteX2" fmla="*/ 11947387 w 12207823"/>
+              <a:gd name="connsiteY2" fmla="*/ 0 h 540522"/>
+              <a:gd name="connsiteX3" fmla="*/ 12193173 w 12207823"/>
+              <a:gd name="connsiteY3" fmla="*/ 245786 h 540522"/>
+              <a:gd name="connsiteX4" fmla="*/ 12193172 w 12207823"/>
+              <a:gd name="connsiteY4" fmla="*/ 245786 h 540522"/>
+              <a:gd name="connsiteX5" fmla="*/ 12185511 w 12207823"/>
+              <a:gd name="connsiteY5" fmla="*/ 491571 h 540522"/>
+              <a:gd name="connsiteX6" fmla="*/ 4223 w 12207823"/>
+              <a:gd name="connsiteY6" fmla="*/ 539413 h 540522"/>
+              <a:gd name="connsiteX7" fmla="*/ 1172 w 12207823"/>
+              <a:gd name="connsiteY7" fmla="*/ 245785 h 540522"/>
+              <a:gd name="connsiteX8" fmla="*/ 1172 w 12207823"/>
+              <a:gd name="connsiteY8" fmla="*/ 245786 h 540522"/>
+              <a:gd name="connsiteX0" fmla="*/ 1172 w 12202618"/>
+              <a:gd name="connsiteY0" fmla="*/ 245786 h 540522"/>
+              <a:gd name="connsiteX1" fmla="*/ 246958 w 12202618"/>
+              <a:gd name="connsiteY1" fmla="*/ 0 h 540522"/>
+              <a:gd name="connsiteX2" fmla="*/ 11947387 w 12202618"/>
+              <a:gd name="connsiteY2" fmla="*/ 0 h 540522"/>
+              <a:gd name="connsiteX3" fmla="*/ 12193173 w 12202618"/>
+              <a:gd name="connsiteY3" fmla="*/ 245786 h 540522"/>
+              <a:gd name="connsiteX4" fmla="*/ 12193172 w 12202618"/>
+              <a:gd name="connsiteY4" fmla="*/ 245786 h 540522"/>
+              <a:gd name="connsiteX5" fmla="*/ 12185511 w 12202618"/>
+              <a:gd name="connsiteY5" fmla="*/ 491571 h 540522"/>
+              <a:gd name="connsiteX6" fmla="*/ 4223 w 12202618"/>
+              <a:gd name="connsiteY6" fmla="*/ 539413 h 540522"/>
+              <a:gd name="connsiteX7" fmla="*/ 1172 w 12202618"/>
+              <a:gd name="connsiteY7" fmla="*/ 245785 h 540522"/>
+              <a:gd name="connsiteX8" fmla="*/ 1172 w 12202618"/>
+              <a:gd name="connsiteY8" fmla="*/ 245786 h 540522"/>
+              <a:gd name="connsiteX0" fmla="*/ 1172 w 12213078"/>
+              <a:gd name="connsiteY0" fmla="*/ 245786 h 540522"/>
+              <a:gd name="connsiteX1" fmla="*/ 246958 w 12213078"/>
+              <a:gd name="connsiteY1" fmla="*/ 0 h 540522"/>
+              <a:gd name="connsiteX2" fmla="*/ 11947387 w 12213078"/>
+              <a:gd name="connsiteY2" fmla="*/ 0 h 540522"/>
+              <a:gd name="connsiteX3" fmla="*/ 12193173 w 12213078"/>
+              <a:gd name="connsiteY3" fmla="*/ 245786 h 540522"/>
+              <a:gd name="connsiteX4" fmla="*/ 12193172 w 12213078"/>
+              <a:gd name="connsiteY4" fmla="*/ 245786 h 540522"/>
+              <a:gd name="connsiteX5" fmla="*/ 12199798 w 12213078"/>
+              <a:gd name="connsiteY5" fmla="*/ 491571 h 540522"/>
+              <a:gd name="connsiteX6" fmla="*/ 4223 w 12213078"/>
+              <a:gd name="connsiteY6" fmla="*/ 539413 h 540522"/>
+              <a:gd name="connsiteX7" fmla="*/ 1172 w 12213078"/>
+              <a:gd name="connsiteY7" fmla="*/ 245785 h 540522"/>
+              <a:gd name="connsiteX8" fmla="*/ 1172 w 12213078"/>
+              <a:gd name="connsiteY8" fmla="*/ 245786 h 540522"/>
+              <a:gd name="connsiteX0" fmla="*/ 1172 w 12198313"/>
+              <a:gd name="connsiteY0" fmla="*/ 245786 h 540522"/>
+              <a:gd name="connsiteX1" fmla="*/ 246958 w 12198313"/>
+              <a:gd name="connsiteY1" fmla="*/ 0 h 540522"/>
+              <a:gd name="connsiteX2" fmla="*/ 11947387 w 12198313"/>
+              <a:gd name="connsiteY2" fmla="*/ 0 h 540522"/>
+              <a:gd name="connsiteX3" fmla="*/ 12193173 w 12198313"/>
+              <a:gd name="connsiteY3" fmla="*/ 245786 h 540522"/>
+              <a:gd name="connsiteX4" fmla="*/ 12193172 w 12198313"/>
+              <a:gd name="connsiteY4" fmla="*/ 245786 h 540522"/>
+              <a:gd name="connsiteX5" fmla="*/ 12178366 w 12198313"/>
+              <a:gd name="connsiteY5" fmla="*/ 526990 h 540522"/>
+              <a:gd name="connsiteX6" fmla="*/ 4223 w 12198313"/>
+              <a:gd name="connsiteY6" fmla="*/ 539413 h 540522"/>
+              <a:gd name="connsiteX7" fmla="*/ 1172 w 12198313"/>
+              <a:gd name="connsiteY7" fmla="*/ 245785 h 540522"/>
+              <a:gd name="connsiteX8" fmla="*/ 1172 w 12198313"/>
+              <a:gd name="connsiteY8" fmla="*/ 245786 h 540522"/>
+              <a:gd name="connsiteX0" fmla="*/ 1172 w 12233684"/>
+              <a:gd name="connsiteY0" fmla="*/ 245786 h 551725"/>
+              <a:gd name="connsiteX1" fmla="*/ 246958 w 12233684"/>
+              <a:gd name="connsiteY1" fmla="*/ 0 h 551725"/>
+              <a:gd name="connsiteX2" fmla="*/ 11947387 w 12233684"/>
+              <a:gd name="connsiteY2" fmla="*/ 0 h 551725"/>
+              <a:gd name="connsiteX3" fmla="*/ 12193173 w 12233684"/>
+              <a:gd name="connsiteY3" fmla="*/ 245786 h 551725"/>
+              <a:gd name="connsiteX4" fmla="*/ 12193172 w 12233684"/>
+              <a:gd name="connsiteY4" fmla="*/ 245786 h 551725"/>
+              <a:gd name="connsiteX5" fmla="*/ 12224086 w 12233684"/>
+              <a:gd name="connsiteY5" fmla="*/ 551630 h 551725"/>
+              <a:gd name="connsiteX6" fmla="*/ 4223 w 12233684"/>
+              <a:gd name="connsiteY6" fmla="*/ 539413 h 551725"/>
+              <a:gd name="connsiteX7" fmla="*/ 1172 w 12233684"/>
+              <a:gd name="connsiteY7" fmla="*/ 245785 h 551725"/>
+              <a:gd name="connsiteX8" fmla="*/ 1172 w 12233684"/>
+              <a:gd name="connsiteY8" fmla="*/ 245786 h 551725"/>
+            </a:gdLst>
+            <a:ahLst/>
+            <a:cxnLst>
+              <a:cxn ang="0">
+                <a:pos x="connsiteX0" y="connsiteY0"/>
+              </a:cxn>
+              <a:cxn ang="0">
+                <a:pos x="connsiteX1" y="connsiteY1"/>
+              </a:cxn>
+              <a:cxn ang="0">
+                <a:pos x="connsiteX2" y="connsiteY2"/>
+              </a:cxn>
+              <a:cxn ang="0">
+                <a:pos x="connsiteX3" y="connsiteY3"/>
+              </a:cxn>
+              <a:cxn ang="0">
+                <a:pos x="connsiteX4" y="connsiteY4"/>
+              </a:cxn>
+              <a:cxn ang="0">
+                <a:pos x="connsiteX5" y="connsiteY5"/>
+              </a:cxn>
+              <a:cxn ang="0">
+                <a:pos x="connsiteX6" y="connsiteY6"/>
+              </a:cxn>
+              <a:cxn ang="0">
+                <a:pos x="connsiteX7" y="connsiteY7"/>
+              </a:cxn>
+              <a:cxn ang="0">
+                <a:pos x="connsiteX8" y="connsiteY8"/>
+              </a:cxn>
+            </a:cxnLst>
+            <a:rect l="l" t="t" r="r" b="b"/>
+            <a:pathLst>
+              <a:path w="12233684" h="551725">
+                <a:moveTo>
+                  <a:pt x="1172" y="245786"/>
+                </a:moveTo>
+                <a:cubicBezTo>
+                  <a:pt x="1172" y="110042"/>
+                  <a:pt x="111214" y="0"/>
+                  <a:pt x="246958" y="0"/>
+                </a:cubicBezTo>
+                <a:lnTo>
+                  <a:pt x="11947387" y="0"/>
+                </a:lnTo>
+                <a:cubicBezTo>
+                  <a:pt x="12083131" y="0"/>
+                  <a:pt x="12193173" y="110042"/>
+                  <a:pt x="12193173" y="245786"/>
+                </a:cubicBezTo>
+                <a:lnTo>
+                  <a:pt x="12193172" y="245786"/>
+                </a:lnTo>
+                <a:cubicBezTo>
+                  <a:pt x="12193172" y="381530"/>
+                  <a:pt x="12257437" y="556393"/>
+                  <a:pt x="12224086" y="551630"/>
+                </a:cubicBezTo>
+                <a:lnTo>
+                  <a:pt x="4223" y="539413"/>
+                </a:lnTo>
+                <a:cubicBezTo>
+                  <a:pt x="-2934" y="556082"/>
+                  <a:pt x="1172" y="381529"/>
+                  <a:pt x="1172" y="245785"/>
+                </a:cubicBezTo>
+                <a:lnTo>
+                  <a:pt x="1172" y="245786"/>
+                </a:lnTo>
+                <a:close/>
+              </a:path>
+            </a:pathLst>
+          </a:custGeom>
+          <a:solidFill>
+            <a:schemeClr val="bg1"/>
+          </a:solidFill>
+          <a:ln>
+            <a:noFill/>
+          </a:ln>
+          <a:effectLst/>
+        </p:spPr>
+        <p:style>
+          <a:lnRef idx="2">
+            <a:schemeClr val="accent1">
+              <a:shade val="15000"/>
+            </a:schemeClr>
+          </a:lnRef>
+          <a:fillRef idx="1">
+            <a:schemeClr val="accent1"/>
+          </a:fillRef>
+          <a:effectRef idx="0">
+            <a:schemeClr val="accent1"/>
+          </a:effectRef>
+          <a:fontRef idx="minor">
+            <a:schemeClr val="lt1"/>
+          </a:fontRef>
+        </p:style>
+        <p:txBody>
+          <a:bodyPr rtlCol="0" anchor="ctr"/>
+          <a:lstStyle/>
+          <a:p>
+            <a:pPr algn="ctr"/>
+            <a:endParaRPr lang="pt-BR"/>
+          </a:p>
+        </p:txBody>
+      </p:sp>
+      <p:sp>
+        <p:nvSpPr>
+          <p:cNvPr id="6" name="Retângulo: Cantos Arredondados 5">
+            <a:extLst>
+              <a:ext uri="{FF2B5EF4-FFF2-40B4-BE49-F238E27FC236}">
+                <a16:creationId xmlns:a16="http://schemas.microsoft.com/office/drawing/2014/main" id="{7B0AAC71-D4F2-B509-F02D-DA1CDC005A9C}"/>
+              </a:ext>
+            </a:extLst>
+          </p:cNvPr>
+          <p:cNvSpPr/>
+          <p:nvPr/>
+        </p:nvSpPr>
+        <p:spPr>
+          <a:xfrm>
+            <a:off x="1049149" y="949534"/>
+            <a:ext cx="2387600" cy="1037820"/>
+          </a:xfrm>
+          <a:prstGeom prst="roundRect">
+            <a:avLst>
+              <a:gd name="adj" fmla="val 8257"/>
+            </a:avLst>
+          </a:prstGeom>
+          <a:solidFill>
+            <a:schemeClr val="bg1"/>
+          </a:solidFill>
+          <a:ln>
+            <a:noFill/>
+          </a:ln>
+          <a:effectLst>
+            <a:outerShdw blurRad="101600" dist="38100" dir="5400000" algn="t" rotWithShape="0">
+              <a:prstClr val="black">
+                <a:alpha val="20000"/>
+              </a:prstClr>
+            </a:outerShdw>
+          </a:effectLst>
+        </p:spPr>
+        <p:style>
+          <a:lnRef idx="2">
+            <a:schemeClr val="accent1">
+              <a:shade val="15000"/>
+            </a:schemeClr>
+          </a:lnRef>
+          <a:fillRef idx="1">
+            <a:schemeClr val="accent1"/>
+          </a:fillRef>
+          <a:effectRef idx="0">
+            <a:schemeClr val="accent1"/>
+          </a:effectRef>
+          <a:fontRef idx="minor">
+            <a:schemeClr val="lt1"/>
+          </a:fontRef>
+        </p:style>
+        <p:txBody>
+          <a:bodyPr rtlCol="0" anchor="ctr"/>
+          <a:lstStyle/>
+          <a:p>
+            <a:pPr algn="ctr"/>
+            <a:endParaRPr lang="pt-BR"/>
+          </a:p>
+        </p:txBody>
+      </p:sp>
+      <p:sp>
+        <p:nvSpPr>
+          <p:cNvPr id="7" name="Retângulo: Cantos Arredondados 6">
+            <a:extLst>
+              <a:ext uri="{FF2B5EF4-FFF2-40B4-BE49-F238E27FC236}">
+                <a16:creationId xmlns:a16="http://schemas.microsoft.com/office/drawing/2014/main" id="{41C8273C-8026-BE1D-4E2D-EFAE5A122036}"/>
+              </a:ext>
+            </a:extLst>
+          </p:cNvPr>
+          <p:cNvSpPr/>
+          <p:nvPr/>
+        </p:nvSpPr>
+        <p:spPr>
+          <a:xfrm>
+            <a:off x="3813903" y="949534"/>
+            <a:ext cx="2387600" cy="1037820"/>
+          </a:xfrm>
+          <a:prstGeom prst="roundRect">
+            <a:avLst>
+              <a:gd name="adj" fmla="val 7416"/>
+            </a:avLst>
+          </a:prstGeom>
+          <a:solidFill>
+            <a:schemeClr val="bg1"/>
+          </a:solidFill>
+          <a:ln>
+            <a:noFill/>
+          </a:ln>
+          <a:effectLst>
+            <a:outerShdw blurRad="101600" dist="38100" dir="5400000" algn="t" rotWithShape="0">
+              <a:prstClr val="black">
+                <a:alpha val="20000"/>
+              </a:prstClr>
+            </a:outerShdw>
+          </a:effectLst>
+        </p:spPr>
+        <p:style>
+          <a:lnRef idx="2">
+            <a:schemeClr val="accent1">
+              <a:shade val="15000"/>
+            </a:schemeClr>
+          </a:lnRef>
+          <a:fillRef idx="1">
+            <a:schemeClr val="accent1"/>
+          </a:fillRef>
+          <a:effectRef idx="0">
+            <a:schemeClr val="accent1"/>
+          </a:effectRef>
+          <a:fontRef idx="minor">
+            <a:schemeClr val="lt1"/>
+          </a:fontRef>
+        </p:style>
+        <p:txBody>
+          <a:bodyPr rtlCol="0" anchor="ctr"/>
+          <a:lstStyle/>
+          <a:p>
+            <a:pPr algn="ctr"/>
+            <a:endParaRPr lang="pt-BR"/>
+          </a:p>
+        </p:txBody>
+      </p:sp>
+      <p:sp>
+        <p:nvSpPr>
+          <p:cNvPr id="8" name="Retângulo: Cantos Arredondados 7">
+            <a:extLst>
+              <a:ext uri="{FF2B5EF4-FFF2-40B4-BE49-F238E27FC236}">
+                <a16:creationId xmlns:a16="http://schemas.microsoft.com/office/drawing/2014/main" id="{FB556580-20D0-5196-3206-249BDACADC40}"/>
+              </a:ext>
+            </a:extLst>
+          </p:cNvPr>
+          <p:cNvSpPr/>
+          <p:nvPr/>
+        </p:nvSpPr>
+        <p:spPr>
+          <a:xfrm>
+            <a:off x="9380638" y="950110"/>
+            <a:ext cx="2387600" cy="1030940"/>
+          </a:xfrm>
+          <a:prstGeom prst="roundRect">
+            <a:avLst>
+              <a:gd name="adj" fmla="val 7416"/>
+            </a:avLst>
+          </a:prstGeom>
+          <a:solidFill>
+            <a:schemeClr val="bg1"/>
+          </a:solidFill>
+          <a:ln>
+            <a:noFill/>
+          </a:ln>
+          <a:effectLst>
+            <a:outerShdw blurRad="101600" dist="38100" dir="5400000" algn="t" rotWithShape="0">
+              <a:prstClr val="black">
+                <a:alpha val="20000"/>
+              </a:prstClr>
+            </a:outerShdw>
+          </a:effectLst>
+        </p:spPr>
+        <p:style>
+          <a:lnRef idx="2">
+            <a:schemeClr val="accent1">
+              <a:shade val="15000"/>
+            </a:schemeClr>
+          </a:lnRef>
+          <a:fillRef idx="1">
+            <a:schemeClr val="accent1"/>
+          </a:fillRef>
+          <a:effectRef idx="0">
+            <a:schemeClr val="accent1"/>
+          </a:effectRef>
+          <a:fontRef idx="minor">
+            <a:schemeClr val="lt1"/>
+          </a:fontRef>
+        </p:style>
+        <p:txBody>
+          <a:bodyPr rtlCol="0" anchor="ctr"/>
+          <a:lstStyle/>
+          <a:p>
+            <a:pPr algn="ctr"/>
+            <a:endParaRPr lang="pt-BR"/>
+          </a:p>
+        </p:txBody>
+      </p:sp>
+      <p:sp>
+        <p:nvSpPr>
+          <p:cNvPr id="10" name="Retângulo: Cantos Arredondados 9">
+            <a:extLst>
+              <a:ext uri="{FF2B5EF4-FFF2-40B4-BE49-F238E27FC236}">
+                <a16:creationId xmlns:a16="http://schemas.microsoft.com/office/drawing/2014/main" id="{7433BFA1-C2CE-2D8D-6401-6AD7D6B8D1EA}"/>
+              </a:ext>
+            </a:extLst>
+          </p:cNvPr>
+          <p:cNvSpPr/>
+          <p:nvPr/>
+        </p:nvSpPr>
+        <p:spPr>
+          <a:xfrm>
+            <a:off x="1049149" y="2144577"/>
+            <a:ext cx="10737908" cy="2418961"/>
+          </a:xfrm>
+          <a:prstGeom prst="roundRect">
+            <a:avLst>
+              <a:gd name="adj" fmla="val 5297"/>
+            </a:avLst>
+          </a:prstGeom>
+          <a:solidFill>
+            <a:schemeClr val="bg1"/>
+          </a:solidFill>
+          <a:ln>
+            <a:noFill/>
+          </a:ln>
+          <a:effectLst>
+            <a:outerShdw blurRad="101600" dist="38100" dir="5400000" algn="t" rotWithShape="0">
+              <a:prstClr val="black">
+                <a:alpha val="20000"/>
+              </a:prstClr>
+            </a:outerShdw>
+          </a:effectLst>
+        </p:spPr>
+        <p:style>
+          <a:lnRef idx="2">
+            <a:schemeClr val="accent1">
+              <a:shade val="15000"/>
+            </a:schemeClr>
+          </a:lnRef>
+          <a:fillRef idx="1">
+            <a:schemeClr val="accent1"/>
+          </a:fillRef>
+          <a:effectRef idx="0">
+            <a:schemeClr val="accent1"/>
+          </a:effectRef>
+          <a:fontRef idx="minor">
+            <a:schemeClr val="lt1"/>
+          </a:fontRef>
+        </p:style>
+        <p:txBody>
+          <a:bodyPr rtlCol="0" anchor="ctr"/>
+          <a:lstStyle/>
+          <a:p>
+            <a:pPr algn="ctr"/>
+            <a:endParaRPr lang="pt-BR"/>
+          </a:p>
+        </p:txBody>
+      </p:sp>
+      <p:sp>
+        <p:nvSpPr>
+          <p:cNvPr id="12" name="Retângulo: Cantos Arredondados 11">
+            <a:extLst>
+              <a:ext uri="{FF2B5EF4-FFF2-40B4-BE49-F238E27FC236}">
+                <a16:creationId xmlns:a16="http://schemas.microsoft.com/office/drawing/2014/main" id="{CD45ED86-85EB-46B1-CBAD-4C2114EB13BB}"/>
+              </a:ext>
+            </a:extLst>
+          </p:cNvPr>
+          <p:cNvSpPr/>
+          <p:nvPr/>
+        </p:nvSpPr>
+        <p:spPr>
+          <a:xfrm>
+            <a:off x="1049149" y="4820478"/>
+            <a:ext cx="10737908" cy="1921835"/>
+          </a:xfrm>
+          <a:prstGeom prst="roundRect">
+            <a:avLst>
+              <a:gd name="adj" fmla="val 4729"/>
+            </a:avLst>
+          </a:prstGeom>
+          <a:solidFill>
+            <a:schemeClr val="bg1"/>
+          </a:solidFill>
+          <a:ln>
+            <a:noFill/>
+          </a:ln>
+          <a:effectLst>
+            <a:outerShdw blurRad="101600" dist="38100" dir="5400000" algn="t" rotWithShape="0">
+              <a:prstClr val="black">
+                <a:alpha val="20000"/>
+              </a:prstClr>
+            </a:outerShdw>
+          </a:effectLst>
+        </p:spPr>
+        <p:style>
+          <a:lnRef idx="2">
+            <a:schemeClr val="accent1">
+              <a:shade val="15000"/>
+            </a:schemeClr>
+          </a:lnRef>
+          <a:fillRef idx="1">
+            <a:schemeClr val="accent1"/>
+          </a:fillRef>
+          <a:effectRef idx="0">
+            <a:schemeClr val="accent1"/>
+          </a:effectRef>
+          <a:fontRef idx="minor">
+            <a:schemeClr val="lt1"/>
+          </a:fontRef>
+        </p:style>
+        <p:txBody>
+          <a:bodyPr rtlCol="0" anchor="ctr"/>
+          <a:lstStyle/>
+          <a:p>
+            <a:pPr algn="ctr"/>
+            <a:endParaRPr lang="pt-BR"/>
+          </a:p>
+        </p:txBody>
+      </p:sp>
+      <p:sp>
+        <p:nvSpPr>
+          <p:cNvPr id="34" name="Rectangle 1">
+            <a:extLst>
+              <a:ext uri="{FF2B5EF4-FFF2-40B4-BE49-F238E27FC236}">
+                <a16:creationId xmlns:a16="http://schemas.microsoft.com/office/drawing/2014/main" id="{5CD6965F-0E66-8080-2B63-26B4C3F43AE9}"/>
               </a:ext>
             </a:extLst>
           </p:cNvPr>
           <p:cNvSpPr>
-            <a:spLocks noGrp="1" noRot="1" noChangeAspect="1" noMove="1" noResize="1" noEditPoints="1" noAdjustHandles="1" noChangeArrowheads="1" noChangeShapeType="1" noTextEdit="1"/>
+            <a:spLocks noChangeArrowheads="1"/>
           </p:cNvSpPr>
-          <p:nvPr>
-            <p:extLst>
-              <p:ext uri="{386F3935-93C4-4BCD-93E2-E3B085C9AB24}">
-                <p16:designElem xmlns:p16="http://schemas.microsoft.com/office/powerpoint/2015/main" val="1"/>
-              </p:ext>
-            </p:extLst>
-          </p:nvPr>
-        </p:nvSpPr>
-        <p:spPr bwMode="white">
-          <a:xfrm>
-            <a:off x="1524" y="0"/>
-            <a:ext cx="12188952" cy="6858000"/>
+          <p:nvPr/>
+        </p:nvSpPr>
+        <p:spPr bwMode="auto">
+          <a:xfrm>
+            <a:off x="0" y="0"/>
+            <a:ext cx="12192000" cy="0"/>
           </a:xfrm>
           <a:prstGeom prst="rect">
             <a:avLst/>
@@ -6818,132 +7646,55 @@
           <a:ln>
             <a:noFill/>
           </a:ln>
-        </p:spPr>
-        <p:style>
-          <a:lnRef idx="2">
-            <a:schemeClr val="accent1">
-              <a:shade val="50000"/>
-            </a:schemeClr>
-          </a:lnRef>
-          <a:fillRef idx="1">
-            <a:schemeClr val="accent1"/>
-          </a:fillRef>
-          <a:effectRef idx="0">
-            <a:schemeClr val="accent1"/>
-          </a:effectRef>
-          <a:fontRef idx="minor">
-            <a:schemeClr val="lt1"/>
-          </a:fontRef>
-        </p:style>
-        <p:txBody>
-          <a:bodyPr rtlCol="0" anchor="ctr"/>
-          <a:lstStyle>
-            <a:defPPr>
-              <a:defRPr lang="en-US"/>
-            </a:defPPr>
-            <a:lvl1pPr marL="0" algn="l" defTabSz="914400" rtl="0" eaLnBrk="1" latinLnBrk="0" hangingPunct="1">
-              <a:defRPr sz="1800" kern="1200">
+          <a:effectLst/>
+          <a:extLst>
+            <a:ext uri="{909E8E84-426E-40DD-AFC4-6F175D3DCCD1}">
+              <a14:hiddenFill xmlns:a14="http://schemas.microsoft.com/office/drawing/2010/main">
                 <a:solidFill>
-                  <a:schemeClr val="lt1"/>
+                  <a:schemeClr val="accent1"/>
                 </a:solidFill>
-                <a:latin typeface="+mn-lt"/>
-                <a:ea typeface="+mn-ea"/>
-                <a:cs typeface="+mn-cs"/>
-              </a:defRPr>
-            </a:lvl1pPr>
-            <a:lvl2pPr marL="457200" algn="l" defTabSz="914400" rtl="0" eaLnBrk="1" latinLnBrk="0" hangingPunct="1">
-              <a:defRPr sz="1800" kern="1200">
+              </a14:hiddenFill>
+            </a:ext>
+            <a:ext uri="{91240B29-F687-4F45-9708-019B960494DF}">
+              <a14:hiddenLine xmlns:a14="http://schemas.microsoft.com/office/drawing/2010/main" w="9525">
                 <a:solidFill>
-                  <a:schemeClr val="lt1"/>
+                  <a:schemeClr val="tx1"/>
                 </a:solidFill>
-                <a:latin typeface="+mn-lt"/>
-                <a:ea typeface="+mn-ea"/>
-                <a:cs typeface="+mn-cs"/>
-              </a:defRPr>
-            </a:lvl2pPr>
-            <a:lvl3pPr marL="914400" algn="l" defTabSz="914400" rtl="0" eaLnBrk="1" latinLnBrk="0" hangingPunct="1">
-              <a:defRPr sz="1800" kern="1200">
-                <a:solidFill>
-                  <a:schemeClr val="lt1"/>
-                </a:solidFill>
-                <a:latin typeface="+mn-lt"/>
-                <a:ea typeface="+mn-ea"/>
-                <a:cs typeface="+mn-cs"/>
-              </a:defRPr>
-            </a:lvl3pPr>
-            <a:lvl4pPr marL="1371600" algn="l" defTabSz="914400" rtl="0" eaLnBrk="1" latinLnBrk="0" hangingPunct="1">
-              <a:defRPr sz="1800" kern="1200">
-                <a:solidFill>
-                  <a:schemeClr val="lt1"/>
-                </a:solidFill>
-                <a:latin typeface="+mn-lt"/>
-                <a:ea typeface="+mn-ea"/>
-                <a:cs typeface="+mn-cs"/>
-              </a:defRPr>
-            </a:lvl4pPr>
-            <a:lvl5pPr marL="1828800" algn="l" defTabSz="914400" rtl="0" eaLnBrk="1" latinLnBrk="0" hangingPunct="1">
-              <a:defRPr sz="1800" kern="1200">
-                <a:solidFill>
-                  <a:schemeClr val="lt1"/>
-                </a:solidFill>
-                <a:latin typeface="+mn-lt"/>
-                <a:ea typeface="+mn-ea"/>
-                <a:cs typeface="+mn-cs"/>
-              </a:defRPr>
-            </a:lvl5pPr>
-            <a:lvl6pPr marL="2286000" algn="l" defTabSz="914400" rtl="0" eaLnBrk="1" latinLnBrk="0" hangingPunct="1">
-              <a:defRPr sz="1800" kern="1200">
-                <a:solidFill>
-                  <a:schemeClr val="lt1"/>
-                </a:solidFill>
-                <a:latin typeface="+mn-lt"/>
-                <a:ea typeface="+mn-ea"/>
-                <a:cs typeface="+mn-cs"/>
-              </a:defRPr>
-            </a:lvl6pPr>
-            <a:lvl7pPr marL="2743200" algn="l" defTabSz="914400" rtl="0" eaLnBrk="1" latinLnBrk="0" hangingPunct="1">
-              <a:defRPr sz="1800" kern="1200">
-                <a:solidFill>
-                  <a:schemeClr val="lt1"/>
-                </a:solidFill>
-                <a:latin typeface="+mn-lt"/>
-                <a:ea typeface="+mn-ea"/>
-                <a:cs typeface="+mn-cs"/>
-              </a:defRPr>
-            </a:lvl7pPr>
-            <a:lvl8pPr marL="3200400" algn="l" defTabSz="914400" rtl="0" eaLnBrk="1" latinLnBrk="0" hangingPunct="1">
-              <a:defRPr sz="1800" kern="1200">
-                <a:solidFill>
-                  <a:schemeClr val="lt1"/>
-                </a:solidFill>
-                <a:latin typeface="+mn-lt"/>
-                <a:ea typeface="+mn-ea"/>
-                <a:cs typeface="+mn-cs"/>
-              </a:defRPr>
-            </a:lvl8pPr>
-            <a:lvl9pPr marL="3657600" algn="l" defTabSz="914400" rtl="0" eaLnBrk="1" latinLnBrk="0" hangingPunct="1">
-              <a:defRPr sz="1800" kern="1200">
-                <a:solidFill>
-                  <a:schemeClr val="lt1"/>
-                </a:solidFill>
-                <a:latin typeface="+mn-lt"/>
-                <a:ea typeface="+mn-ea"/>
-                <a:cs typeface="+mn-cs"/>
-              </a:defRPr>
-            </a:lvl9pPr>
-          </a:lstStyle>
-          <a:p>
-            <a:pPr algn="ctr"/>
-            <a:endParaRPr lang="en-US"/>
+                <a:miter lim="800000"/>
+                <a:headEnd/>
+                <a:tailEnd/>
+              </a14:hiddenLine>
+            </a:ext>
+            <a:ext uri="{AF507438-7753-43E0-B8FC-AC1667EBCBE1}">
+              <a14:hiddenEffects xmlns:a14="http://schemas.microsoft.com/office/drawing/2010/main">
+                <a:effectLst>
+                  <a:outerShdw dist="35921" dir="2700000" algn="ctr" rotWithShape="0">
+                    <a:schemeClr val="bg2"/>
+                  </a:outerShdw>
+                </a:effectLst>
+              </a14:hiddenEffects>
+            </a:ext>
+          </a:extLst>
+        </p:spPr>
+        <p:txBody>
+          <a:bodyPr vert="horz" wrap="none" lIns="91440" tIns="45720" rIns="91440" bIns="45720" numCol="1" anchor="ctr" anchorCtr="0" compatLnSpc="1">
+            <a:prstTxWarp prst="textNoShape">
+              <a:avLst/>
+            </a:prstTxWarp>
+            <a:spAutoFit/>
+          </a:bodyPr>
+          <a:lstStyle/>
+          <a:p>
+            <a:endParaRPr lang="pt-BR"/>
           </a:p>
         </p:txBody>
       </p:sp>
       <p:pic>
         <p:nvPicPr>
-          <p:cNvPr id="5" name="Imagem 4">
-            <a:extLst>
-              <a:ext uri="{FF2B5EF4-FFF2-40B4-BE49-F238E27FC236}">
-                <a16:creationId xmlns:a16="http://schemas.microsoft.com/office/drawing/2014/main" id="{DDADCDF9-7AD1-B0B1-B37F-359BDE21AB29}"/>
+          <p:cNvPr id="40" name="Imagem 39" descr="Logotipo&#10;&#10;O conteúdo gerado por IA pode estar incorreto.">
+            <a:extLst>
+              <a:ext uri="{FF2B5EF4-FFF2-40B4-BE49-F238E27FC236}">
+                <a16:creationId xmlns:a16="http://schemas.microsoft.com/office/drawing/2014/main" id="{95EDC010-24E1-5CEF-002C-3286AF360F8A}"/>
               </a:ext>
             </a:extLst>
           </p:cNvPr>
@@ -6953,16 +7704,21 @@
           <p:nvPr/>
         </p:nvPicPr>
         <p:blipFill>
-          <a:blip r:embed="rId2"/>
-          <a:srcRect b="19"/>
+          <a:blip r:embed="rId2">
+            <a:extLst>
+              <a:ext uri="{28A0092B-C50C-407E-A947-70E740481C1C}">
+                <a14:useLocalDpi xmlns:a14="http://schemas.microsoft.com/office/drawing/2010/main" val="0"/>
+              </a:ext>
+            </a:extLst>
+          </a:blip>
           <a:stretch>
             <a:fillRect/>
           </a:stretch>
         </p:blipFill>
         <p:spPr>
           <a:xfrm>
-            <a:off x="20" y="1282"/>
-            <a:ext cx="12191980" cy="6856718"/>
+            <a:off x="-151400" y="-496476"/>
+            <a:ext cx="2342499" cy="1801131"/>
           </a:xfrm>
           <a:prstGeom prst="rect">
             <a:avLst/>
@@ -6971,10 +7727,10 @@
       </p:pic>
       <p:sp>
         <p:nvSpPr>
-          <p:cNvPr id="6" name="Retângulo: Cantos Arredondados 5">
-            <a:extLst>
-              <a:ext uri="{FF2B5EF4-FFF2-40B4-BE49-F238E27FC236}">
-                <a16:creationId xmlns:a16="http://schemas.microsoft.com/office/drawing/2014/main" id="{C4FEBE7A-C67E-E609-F132-491E4C7B4A3B}"/>
+          <p:cNvPr id="46" name="Retângulo: Cantos Arredondados 45">
+            <a:extLst>
+              <a:ext uri="{FF2B5EF4-FFF2-40B4-BE49-F238E27FC236}">
+                <a16:creationId xmlns:a16="http://schemas.microsoft.com/office/drawing/2014/main" id="{412D39A9-6C07-5E90-08AF-839E1F1508C5}"/>
               </a:ext>
             </a:extLst>
           </p:cNvPr>
@@ -6983,17 +7739,20 @@
         </p:nvSpPr>
         <p:spPr>
           <a:xfrm>
-            <a:off x="821268" y="2175933"/>
-            <a:ext cx="8407400" cy="635000"/>
+            <a:off x="1699975" y="227802"/>
+            <a:ext cx="3205399" cy="309954"/>
           </a:xfrm>
           <a:prstGeom prst="roundRect">
             <a:avLst>
-              <a:gd name="adj" fmla="val 31160"/>
+              <a:gd name="adj" fmla="val 26287"/>
             </a:avLst>
           </a:prstGeom>
           <a:solidFill>
             <a:srgbClr val="2F3A5F"/>
           </a:solidFill>
+          <a:ln>
+            <a:noFill/>
+          </a:ln>
         </p:spPr>
         <p:style>
           <a:lnRef idx="2">
@@ -7016,14 +7775,683 @@
           <a:lstStyle/>
           <a:p>
             <a:pPr algn="ctr"/>
+            <a:r>
+              <a:rPr lang="pt-BR" sz="1400" dirty="0" err="1"/>
+              <a:t>Analytics</a:t>
+            </a:r>
+            <a:r>
+              <a:rPr lang="pt-BR" sz="1400" dirty="0"/>
+              <a:t> – Performance Orçamentária</a:t>
+            </a:r>
+          </a:p>
+        </p:txBody>
+      </p:sp>
+      <p:sp>
+        <p:nvSpPr>
+          <p:cNvPr id="56" name="Retângulo: Cantos Arredondados 55">
+            <a:extLst>
+              <a:ext uri="{FF2B5EF4-FFF2-40B4-BE49-F238E27FC236}">
+                <a16:creationId xmlns:a16="http://schemas.microsoft.com/office/drawing/2014/main" id="{F595D844-0F89-2048-AACE-2738058B0DE5}"/>
+              </a:ext>
+            </a:extLst>
+          </p:cNvPr>
+          <p:cNvSpPr/>
+          <p:nvPr/>
+        </p:nvSpPr>
+        <p:spPr>
+          <a:xfrm>
+            <a:off x="3008184" y="970568"/>
+            <a:ext cx="347291" cy="374036"/>
+          </a:xfrm>
+          <a:prstGeom prst="roundRect">
+            <a:avLst>
+              <a:gd name="adj" fmla="val 35127"/>
+            </a:avLst>
+          </a:prstGeom>
+          <a:solidFill>
+            <a:srgbClr val="2F3A5F">
+              <a:alpha val="18000"/>
+            </a:srgbClr>
+          </a:solidFill>
+          <a:ln>
+            <a:noFill/>
+          </a:ln>
+        </p:spPr>
+        <p:style>
+          <a:lnRef idx="2">
+            <a:schemeClr val="accent1">
+              <a:shade val="15000"/>
+            </a:schemeClr>
+          </a:lnRef>
+          <a:fillRef idx="1">
+            <a:schemeClr val="accent1"/>
+          </a:fillRef>
+          <a:effectRef idx="0">
+            <a:schemeClr val="accent1"/>
+          </a:effectRef>
+          <a:fontRef idx="minor">
+            <a:schemeClr val="lt1"/>
+          </a:fontRef>
+        </p:style>
+        <p:txBody>
+          <a:bodyPr rtlCol="0" anchor="ctr"/>
+          <a:lstStyle/>
+          <a:p>
+            <a:pPr algn="ctr"/>
+            <a:endParaRPr lang="pt-BR" dirty="0"/>
+          </a:p>
+        </p:txBody>
+      </p:sp>
+      <p:sp>
+        <p:nvSpPr>
+          <p:cNvPr id="57" name="Retângulo: Cantos Arredondados 56">
+            <a:extLst>
+              <a:ext uri="{FF2B5EF4-FFF2-40B4-BE49-F238E27FC236}">
+                <a16:creationId xmlns:a16="http://schemas.microsoft.com/office/drawing/2014/main" id="{96776456-D4CC-50D0-18CC-6B38E52727BB}"/>
+              </a:ext>
+            </a:extLst>
+          </p:cNvPr>
+          <p:cNvSpPr/>
+          <p:nvPr/>
+        </p:nvSpPr>
+        <p:spPr>
+          <a:xfrm>
+            <a:off x="5792658" y="973108"/>
+            <a:ext cx="372871" cy="362545"/>
+          </a:xfrm>
+          <a:prstGeom prst="roundRect">
+            <a:avLst>
+              <a:gd name="adj" fmla="val 35127"/>
+            </a:avLst>
+          </a:prstGeom>
+          <a:solidFill>
+            <a:srgbClr val="2F3A5F">
+              <a:alpha val="18000"/>
+            </a:srgbClr>
+          </a:solidFill>
+          <a:ln>
+            <a:noFill/>
+          </a:ln>
+        </p:spPr>
+        <p:style>
+          <a:lnRef idx="2">
+            <a:schemeClr val="accent1">
+              <a:shade val="15000"/>
+            </a:schemeClr>
+          </a:lnRef>
+          <a:fillRef idx="1">
+            <a:schemeClr val="accent1"/>
+          </a:fillRef>
+          <a:effectRef idx="0">
+            <a:schemeClr val="accent1"/>
+          </a:effectRef>
+          <a:fontRef idx="minor">
+            <a:schemeClr val="lt1"/>
+          </a:fontRef>
+        </p:style>
+        <p:txBody>
+          <a:bodyPr rtlCol="0" anchor="ctr"/>
+          <a:lstStyle/>
+          <a:p>
+            <a:pPr algn="ctr"/>
             <a:endParaRPr lang="pt-BR"/>
           </a:p>
         </p:txBody>
       </p:sp>
+      <p:pic>
+        <p:nvPicPr>
+          <p:cNvPr id="53" name="Imagem 52" descr="Ícone&#10;&#10;O conteúdo gerado por IA pode estar incorreto.">
+            <a:extLst>
+              <a:ext uri="{FF2B5EF4-FFF2-40B4-BE49-F238E27FC236}">
+                <a16:creationId xmlns:a16="http://schemas.microsoft.com/office/drawing/2014/main" id="{8A118298-34FC-7DE1-8F0F-A0EC0AE9565C}"/>
+              </a:ext>
+            </a:extLst>
+          </p:cNvPr>
+          <p:cNvPicPr>
+            <a:picLocks noChangeAspect="1"/>
+          </p:cNvPicPr>
+          <p:nvPr/>
+        </p:nvPicPr>
+        <p:blipFill>
+          <a:blip r:embed="rId3">
+            <a:extLst>
+              <a:ext uri="{28A0092B-C50C-407E-A947-70E740481C1C}">
+                <a14:useLocalDpi xmlns:a14="http://schemas.microsoft.com/office/drawing/2010/main" val="0"/>
+              </a:ext>
+            </a:extLst>
+          </a:blip>
+          <a:stretch>
+            <a:fillRect/>
+          </a:stretch>
+        </p:blipFill>
+        <p:spPr>
+          <a:xfrm>
+            <a:off x="3040137" y="999786"/>
+            <a:ext cx="291413" cy="291413"/>
+          </a:xfrm>
+          <a:prstGeom prst="rect">
+            <a:avLst/>
+          </a:prstGeom>
+        </p:spPr>
+      </p:pic>
+      <p:sp>
+        <p:nvSpPr>
+          <p:cNvPr id="58" name="Retângulo: Cantos Arredondados 57">
+            <a:extLst>
+              <a:ext uri="{FF2B5EF4-FFF2-40B4-BE49-F238E27FC236}">
+                <a16:creationId xmlns:a16="http://schemas.microsoft.com/office/drawing/2014/main" id="{2135EB59-0050-6A61-35E4-BBE49ADC4DC5}"/>
+              </a:ext>
+            </a:extLst>
+          </p:cNvPr>
+          <p:cNvSpPr/>
+          <p:nvPr/>
+        </p:nvSpPr>
+        <p:spPr>
+          <a:xfrm>
+            <a:off x="11418889" y="981926"/>
+            <a:ext cx="306401" cy="346436"/>
+          </a:xfrm>
+          <a:prstGeom prst="roundRect">
+            <a:avLst>
+              <a:gd name="adj" fmla="val 35127"/>
+            </a:avLst>
+          </a:prstGeom>
+          <a:solidFill>
+            <a:srgbClr val="2F3A5F">
+              <a:alpha val="18000"/>
+            </a:srgbClr>
+          </a:solidFill>
+          <a:ln>
+            <a:noFill/>
+          </a:ln>
+        </p:spPr>
+        <p:style>
+          <a:lnRef idx="2">
+            <a:schemeClr val="accent1">
+              <a:shade val="15000"/>
+            </a:schemeClr>
+          </a:lnRef>
+          <a:fillRef idx="1">
+            <a:schemeClr val="accent1"/>
+          </a:fillRef>
+          <a:effectRef idx="0">
+            <a:schemeClr val="accent1"/>
+          </a:effectRef>
+          <a:fontRef idx="minor">
+            <a:schemeClr val="lt1"/>
+          </a:fontRef>
+        </p:style>
+        <p:txBody>
+          <a:bodyPr rtlCol="0" anchor="ctr"/>
+          <a:lstStyle/>
+          <a:p>
+            <a:pPr algn="ctr"/>
+            <a:endParaRPr lang="pt-BR"/>
+          </a:p>
+        </p:txBody>
+      </p:sp>
+      <p:pic>
+        <p:nvPicPr>
+          <p:cNvPr id="67" name="Imagem 66" descr="Ícone&#10;&#10;O conteúdo gerado por IA pode estar incorreto.">
+            <a:extLst>
+              <a:ext uri="{FF2B5EF4-FFF2-40B4-BE49-F238E27FC236}">
+                <a16:creationId xmlns:a16="http://schemas.microsoft.com/office/drawing/2014/main" id="{7618B013-02CB-3CE9-780E-7385F1A3107F}"/>
+              </a:ext>
+            </a:extLst>
+          </p:cNvPr>
+          <p:cNvPicPr>
+            <a:picLocks noChangeAspect="1"/>
+          </p:cNvPicPr>
+          <p:nvPr/>
+        </p:nvPicPr>
+        <p:blipFill>
+          <a:blip r:embed="rId4">
+            <a:extLst>
+              <a:ext uri="{28A0092B-C50C-407E-A947-70E740481C1C}">
+                <a14:useLocalDpi xmlns:a14="http://schemas.microsoft.com/office/drawing/2010/main" val="0"/>
+              </a:ext>
+            </a:extLst>
+          </a:blip>
+          <a:stretch>
+            <a:fillRect/>
+          </a:stretch>
+        </p:blipFill>
+        <p:spPr>
+          <a:xfrm>
+            <a:off x="5828301" y="1011706"/>
+            <a:ext cx="291214" cy="291214"/>
+          </a:xfrm>
+          <a:prstGeom prst="rect">
+            <a:avLst/>
+          </a:prstGeom>
+        </p:spPr>
+      </p:pic>
+      <p:pic>
+        <p:nvPicPr>
+          <p:cNvPr id="71" name="Imagem 70" descr="Ícone&#10;&#10;O conteúdo gerado por IA pode estar incorreto.">
+            <a:extLst>
+              <a:ext uri="{FF2B5EF4-FFF2-40B4-BE49-F238E27FC236}">
+                <a16:creationId xmlns:a16="http://schemas.microsoft.com/office/drawing/2014/main" id="{70216CAD-FDC2-6DF6-2224-EB73CFCF0886}"/>
+              </a:ext>
+            </a:extLst>
+          </p:cNvPr>
+          <p:cNvPicPr>
+            <a:picLocks noChangeAspect="1"/>
+          </p:cNvPicPr>
+          <p:nvPr/>
+        </p:nvPicPr>
+        <p:blipFill>
+          <a:blip r:embed="rId5">
+            <a:extLst>
+              <a:ext uri="{28A0092B-C50C-407E-A947-70E740481C1C}">
+                <a14:useLocalDpi xmlns:a14="http://schemas.microsoft.com/office/drawing/2010/main" val="0"/>
+              </a:ext>
+            </a:extLst>
+          </a:blip>
+          <a:stretch>
+            <a:fillRect/>
+          </a:stretch>
+        </p:blipFill>
+        <p:spPr>
+          <a:xfrm>
+            <a:off x="11453662" y="1040043"/>
+            <a:ext cx="242848" cy="242848"/>
+          </a:xfrm>
+          <a:prstGeom prst="rect">
+            <a:avLst/>
+          </a:prstGeom>
+        </p:spPr>
+      </p:pic>
+      <p:pic>
+        <p:nvPicPr>
+          <p:cNvPr id="13" name="Imagem 12" descr="Ícone&#10;&#10;O conteúdo gerado por IA pode estar incorreto.">
+            <a:extLst>
+              <a:ext uri="{FF2B5EF4-FFF2-40B4-BE49-F238E27FC236}">
+                <a16:creationId xmlns:a16="http://schemas.microsoft.com/office/drawing/2014/main" id="{47DD43CA-2B21-F402-1F31-3460A357D01C}"/>
+              </a:ext>
+            </a:extLst>
+          </p:cNvPr>
+          <p:cNvPicPr>
+            <a:picLocks noChangeAspect="1"/>
+          </p:cNvPicPr>
+          <p:nvPr/>
+        </p:nvPicPr>
+        <p:blipFill>
+          <a:blip r:embed="rId6">
+            <a:extLst>
+              <a:ext uri="{28A0092B-C50C-407E-A947-70E740481C1C}">
+                <a14:useLocalDpi xmlns:a14="http://schemas.microsoft.com/office/drawing/2010/main" val="0"/>
+              </a:ext>
+            </a:extLst>
+          </a:blip>
+          <a:stretch>
+            <a:fillRect/>
+          </a:stretch>
+        </p:blipFill>
+        <p:spPr>
+          <a:xfrm>
+            <a:off x="88190" y="2818496"/>
+            <a:ext cx="351582" cy="351582"/>
+          </a:xfrm>
+          <a:prstGeom prst="rect">
+            <a:avLst/>
+          </a:prstGeom>
+        </p:spPr>
+      </p:pic>
+      <p:pic>
+        <p:nvPicPr>
+          <p:cNvPr id="22" name="Imagem 21" descr="Ícone&#10;&#10;O conteúdo gerado por IA pode estar incorreto.">
+            <a:extLst>
+              <a:ext uri="{FF2B5EF4-FFF2-40B4-BE49-F238E27FC236}">
+                <a16:creationId xmlns:a16="http://schemas.microsoft.com/office/drawing/2014/main" id="{DDB3037B-999A-7F96-069D-91515E17BA5D}"/>
+              </a:ext>
+            </a:extLst>
+          </p:cNvPr>
+          <p:cNvPicPr>
+            <a:picLocks noChangeAspect="1"/>
+          </p:cNvPicPr>
+          <p:nvPr/>
+        </p:nvPicPr>
+        <p:blipFill>
+          <a:blip r:embed="rId7">
+            <a:extLst>
+              <a:ext uri="{28A0092B-C50C-407E-A947-70E740481C1C}">
+                <a14:useLocalDpi xmlns:a14="http://schemas.microsoft.com/office/drawing/2010/main" val="0"/>
+              </a:ext>
+            </a:extLst>
+          </a:blip>
+          <a:stretch>
+            <a:fillRect/>
+          </a:stretch>
+        </p:blipFill>
+        <p:spPr>
+          <a:xfrm>
+            <a:off x="88190" y="4303881"/>
+            <a:ext cx="351582" cy="351582"/>
+          </a:xfrm>
+          <a:prstGeom prst="rect">
+            <a:avLst/>
+          </a:prstGeom>
+        </p:spPr>
+      </p:pic>
+      <p:pic>
+        <p:nvPicPr>
+          <p:cNvPr id="25" name="Imagem 24" descr="Uma imagem contendo Ícone&#10;&#10;O conteúdo gerado por IA pode estar incorreto.">
+            <a:extLst>
+              <a:ext uri="{FF2B5EF4-FFF2-40B4-BE49-F238E27FC236}">
+                <a16:creationId xmlns:a16="http://schemas.microsoft.com/office/drawing/2014/main" id="{9A1E47DD-DE7C-5DD9-E540-A5097FC1D798}"/>
+              </a:ext>
+            </a:extLst>
+          </p:cNvPr>
+          <p:cNvPicPr>
+            <a:picLocks noChangeAspect="1"/>
+          </p:cNvPicPr>
+          <p:nvPr/>
+        </p:nvPicPr>
+        <p:blipFill>
+          <a:blip r:embed="rId8">
+            <a:extLst>
+              <a:ext uri="{28A0092B-C50C-407E-A947-70E740481C1C}">
+                <a14:useLocalDpi xmlns:a14="http://schemas.microsoft.com/office/drawing/2010/main" val="0"/>
+              </a:ext>
+            </a:extLst>
+          </a:blip>
+          <a:stretch>
+            <a:fillRect/>
+          </a:stretch>
+        </p:blipFill>
+        <p:spPr>
+          <a:xfrm flipH="1">
+            <a:off x="106392" y="1383777"/>
+            <a:ext cx="316754" cy="316754"/>
+          </a:xfrm>
+          <a:prstGeom prst="rect">
+            <a:avLst/>
+          </a:prstGeom>
+        </p:spPr>
+      </p:pic>
+      <p:pic>
+        <p:nvPicPr>
+          <p:cNvPr id="2" name="Imagem 1" descr="Ícone&#10;&#10;O conteúdo gerado por IA pode estar incorreto.">
+            <a:extLst>
+              <a:ext uri="{FF2B5EF4-FFF2-40B4-BE49-F238E27FC236}">
+                <a16:creationId xmlns:a16="http://schemas.microsoft.com/office/drawing/2014/main" id="{7CD71D87-893B-7AA0-516F-712AAD250604}"/>
+              </a:ext>
+            </a:extLst>
+          </p:cNvPr>
+          <p:cNvPicPr>
+            <a:picLocks noChangeAspect="1"/>
+          </p:cNvPicPr>
+          <p:nvPr/>
+        </p:nvPicPr>
+        <p:blipFill>
+          <a:blip r:embed="rId9">
+            <a:extLst>
+              <a:ext uri="{28A0092B-C50C-407E-A947-70E740481C1C}">
+                <a14:useLocalDpi xmlns:a14="http://schemas.microsoft.com/office/drawing/2010/main" val="0"/>
+              </a:ext>
+            </a:extLst>
+          </a:blip>
+          <a:stretch>
+            <a:fillRect/>
+          </a:stretch>
+        </p:blipFill>
+        <p:spPr>
+          <a:xfrm>
+            <a:off x="89891" y="2011480"/>
+            <a:ext cx="349882" cy="349882"/>
+          </a:xfrm>
+          <a:prstGeom prst="rect">
+            <a:avLst/>
+          </a:prstGeom>
+        </p:spPr>
+      </p:pic>
+      <p:sp>
+        <p:nvSpPr>
+          <p:cNvPr id="14" name="Retângulo: Cantos Arredondados 13">
+            <a:extLst>
+              <a:ext uri="{FF2B5EF4-FFF2-40B4-BE49-F238E27FC236}">
+                <a16:creationId xmlns:a16="http://schemas.microsoft.com/office/drawing/2014/main" id="{C4B03BC2-6A25-2E9E-9746-FF7F301C93EE}"/>
+              </a:ext>
+            </a:extLst>
+          </p:cNvPr>
+          <p:cNvSpPr/>
+          <p:nvPr/>
+        </p:nvSpPr>
+        <p:spPr>
+          <a:xfrm>
+            <a:off x="44482" y="3547272"/>
+            <a:ext cx="446056" cy="453228"/>
+          </a:xfrm>
+          <a:prstGeom prst="roundRect">
+            <a:avLst/>
+          </a:prstGeom>
+          <a:solidFill>
+            <a:schemeClr val="bg1"/>
+          </a:solidFill>
+          <a:ln>
+            <a:noFill/>
+          </a:ln>
+          <a:effectLst/>
+        </p:spPr>
+        <p:style>
+          <a:lnRef idx="2">
+            <a:schemeClr val="accent1">
+              <a:shade val="15000"/>
+            </a:schemeClr>
+          </a:lnRef>
+          <a:fillRef idx="1">
+            <a:schemeClr val="accent1"/>
+          </a:fillRef>
+          <a:effectRef idx="0">
+            <a:schemeClr val="accent1"/>
+          </a:effectRef>
+          <a:fontRef idx="minor">
+            <a:schemeClr val="lt1"/>
+          </a:fontRef>
+        </p:style>
+        <p:txBody>
+          <a:bodyPr rtlCol="0" anchor="ctr"/>
+          <a:lstStyle/>
+          <a:p>
+            <a:pPr algn="ctr"/>
+            <a:endParaRPr lang="pt-BR"/>
+          </a:p>
+        </p:txBody>
+      </p:sp>
+      <p:pic>
+        <p:nvPicPr>
+          <p:cNvPr id="11" name="Imagem 10">
+            <a:extLst>
+              <a:ext uri="{FF2B5EF4-FFF2-40B4-BE49-F238E27FC236}">
+                <a16:creationId xmlns:a16="http://schemas.microsoft.com/office/drawing/2014/main" id="{A58F5543-2B64-AEFA-1305-E0962F0D005F}"/>
+              </a:ext>
+            </a:extLst>
+          </p:cNvPr>
+          <p:cNvPicPr>
+            <a:picLocks noChangeAspect="1"/>
+          </p:cNvPicPr>
+          <p:nvPr/>
+        </p:nvPicPr>
+        <p:blipFill>
+          <a:blip r:embed="rId10">
+            <a:extLst>
+              <a:ext uri="{28A0092B-C50C-407E-A947-70E740481C1C}">
+                <a14:useLocalDpi xmlns:a14="http://schemas.microsoft.com/office/drawing/2010/main" val="0"/>
+              </a:ext>
+            </a:extLst>
+          </a:blip>
+          <a:stretch>
+            <a:fillRect/>
+          </a:stretch>
+        </p:blipFill>
+        <p:spPr>
+          <a:xfrm>
+            <a:off x="84996" y="3579070"/>
+            <a:ext cx="381791" cy="381791"/>
+          </a:xfrm>
+          <a:prstGeom prst="rect">
+            <a:avLst/>
+          </a:prstGeom>
+        </p:spPr>
+      </p:pic>
+      <p:sp>
+        <p:nvSpPr>
+          <p:cNvPr id="15" name="Retângulo: Cantos Arredondados 14">
+            <a:extLst>
+              <a:ext uri="{FF2B5EF4-FFF2-40B4-BE49-F238E27FC236}">
+                <a16:creationId xmlns:a16="http://schemas.microsoft.com/office/drawing/2014/main" id="{D899D14D-4A07-9D45-94A5-D43BA7024CC3}"/>
+              </a:ext>
+            </a:extLst>
+          </p:cNvPr>
+          <p:cNvSpPr/>
+          <p:nvPr/>
+        </p:nvSpPr>
+        <p:spPr>
+          <a:xfrm>
+            <a:off x="6569276" y="956414"/>
+            <a:ext cx="2387600" cy="1030940"/>
+          </a:xfrm>
+          <a:prstGeom prst="roundRect">
+            <a:avLst>
+              <a:gd name="adj" fmla="val 7416"/>
+            </a:avLst>
+          </a:prstGeom>
+          <a:solidFill>
+            <a:schemeClr val="bg1"/>
+          </a:solidFill>
+          <a:ln>
+            <a:noFill/>
+          </a:ln>
+          <a:effectLst>
+            <a:outerShdw blurRad="101600" dist="38100" dir="5400000" algn="t" rotWithShape="0">
+              <a:prstClr val="black">
+                <a:alpha val="20000"/>
+              </a:prstClr>
+            </a:outerShdw>
+          </a:effectLst>
+        </p:spPr>
+        <p:style>
+          <a:lnRef idx="2">
+            <a:schemeClr val="accent1">
+              <a:shade val="15000"/>
+            </a:schemeClr>
+          </a:lnRef>
+          <a:fillRef idx="1">
+            <a:schemeClr val="accent1"/>
+          </a:fillRef>
+          <a:effectRef idx="0">
+            <a:schemeClr val="accent1"/>
+          </a:effectRef>
+          <a:fontRef idx="minor">
+            <a:schemeClr val="lt1"/>
+          </a:fontRef>
+        </p:style>
+        <p:txBody>
+          <a:bodyPr rtlCol="0" anchor="ctr"/>
+          <a:lstStyle/>
+          <a:p>
+            <a:pPr algn="ctr"/>
+            <a:endParaRPr lang="pt-BR"/>
+          </a:p>
+        </p:txBody>
+      </p:sp>
+      <p:sp>
+        <p:nvSpPr>
+          <p:cNvPr id="17" name="Retângulo: Cantos Arredondados 16">
+            <a:extLst>
+              <a:ext uri="{FF2B5EF4-FFF2-40B4-BE49-F238E27FC236}">
+                <a16:creationId xmlns:a16="http://schemas.microsoft.com/office/drawing/2014/main" id="{C17D2FD4-91EB-ED5B-58B4-E51EE5ED46B4}"/>
+              </a:ext>
+            </a:extLst>
+          </p:cNvPr>
+          <p:cNvSpPr/>
+          <p:nvPr/>
+        </p:nvSpPr>
+        <p:spPr>
+          <a:xfrm>
+            <a:off x="8631065" y="980374"/>
+            <a:ext cx="286414" cy="326345"/>
+          </a:xfrm>
+          <a:prstGeom prst="roundRect">
+            <a:avLst>
+              <a:gd name="adj" fmla="val 35127"/>
+            </a:avLst>
+          </a:prstGeom>
+          <a:solidFill>
+            <a:srgbClr val="2F3A5F">
+              <a:alpha val="18000"/>
+            </a:srgbClr>
+          </a:solidFill>
+          <a:ln>
+            <a:noFill/>
+          </a:ln>
+        </p:spPr>
+        <p:style>
+          <a:lnRef idx="2">
+            <a:schemeClr val="accent1">
+              <a:shade val="15000"/>
+            </a:schemeClr>
+          </a:lnRef>
+          <a:fillRef idx="1">
+            <a:schemeClr val="accent1"/>
+          </a:fillRef>
+          <a:effectRef idx="0">
+            <a:schemeClr val="accent1"/>
+          </a:effectRef>
+          <a:fontRef idx="minor">
+            <a:schemeClr val="lt1"/>
+          </a:fontRef>
+        </p:style>
+        <p:txBody>
+          <a:bodyPr rtlCol="0" anchor="ctr"/>
+          <a:lstStyle/>
+          <a:p>
+            <a:pPr algn="ctr"/>
+            <a:endParaRPr lang="pt-BR"/>
+          </a:p>
+        </p:txBody>
+      </p:sp>
+      <p:pic>
+        <p:nvPicPr>
+          <p:cNvPr id="26" name="Imagem 25">
+            <a:extLst>
+              <a:ext uri="{FF2B5EF4-FFF2-40B4-BE49-F238E27FC236}">
+                <a16:creationId xmlns:a16="http://schemas.microsoft.com/office/drawing/2014/main" id="{6BE433D8-C892-8287-703C-B58B427EAABC}"/>
+              </a:ext>
+            </a:extLst>
+          </p:cNvPr>
+          <p:cNvPicPr>
+            <a:picLocks noChangeAspect="1"/>
+          </p:cNvPicPr>
+          <p:nvPr/>
+        </p:nvPicPr>
+        <p:blipFill>
+          <a:blip r:embed="rId11">
+            <a:extLst>
+              <a:ext uri="{28A0092B-C50C-407E-A947-70E740481C1C}">
+                <a14:useLocalDpi xmlns:a14="http://schemas.microsoft.com/office/drawing/2010/main" val="0"/>
+              </a:ext>
+            </a:extLst>
+          </a:blip>
+          <a:stretch>
+            <a:fillRect/>
+          </a:stretch>
+        </p:blipFill>
+        <p:spPr>
+          <a:xfrm>
+            <a:off x="8680917" y="1030153"/>
+            <a:ext cx="206041" cy="206041"/>
+          </a:xfrm>
+          <a:prstGeom prst="rect">
+            <a:avLst/>
+          </a:prstGeom>
+        </p:spPr>
+      </p:pic>
     </p:spTree>
     <p:extLst>
       <p:ext uri="{BB962C8B-B14F-4D97-AF65-F5344CB8AC3E}">
-        <p14:creationId xmlns:p14="http://schemas.microsoft.com/office/powerpoint/2010/main" val="655971267"/>
+        <p14:creationId xmlns:p14="http://schemas.microsoft.com/office/powerpoint/2010/main" val="87027951"/>
       </p:ext>
     </p:extLst>
   </p:cSld>

</xml_diff>

<commit_message>
tooltips inclusos nas abas analiticas, botões de navegação entre paginas adicionados, readme atualizado e dashboard entregue.
</commit_message>
<xml_diff>
--- a/dashboards/Mockup dashboard (em construção).pptx
+++ b/dashboards/Mockup dashboard (em construção).pptx
@@ -9,6 +9,7 @@
     <p:sldId id="259" r:id="rId3"/>
     <p:sldId id="260" r:id="rId4"/>
     <p:sldId id="261" r:id="rId5"/>
+    <p:sldId id="262" r:id="rId6"/>
   </p:sldIdLst>
   <p:sldSz cx="12192000" cy="6858000"/>
   <p:notesSz cx="6858000" cy="9144000"/>
@@ -262,7 +263,7 @@
           <a:p>
             <a:fld id="{2DB56B22-234B-48A0-9B90-72A4AF419D03}" type="datetimeFigureOut">
               <a:rPr lang="pt-BR" smtClean="0"/>
-              <a:t>16/03/2026</a:t>
+              <a:t>22/03/2026</a:t>
             </a:fld>
             <a:endParaRPr lang="pt-BR"/>
           </a:p>
@@ -460,7 +461,7 @@
           <a:p>
             <a:fld id="{2DB56B22-234B-48A0-9B90-72A4AF419D03}" type="datetimeFigureOut">
               <a:rPr lang="pt-BR" smtClean="0"/>
-              <a:t>16/03/2026</a:t>
+              <a:t>22/03/2026</a:t>
             </a:fld>
             <a:endParaRPr lang="pt-BR"/>
           </a:p>
@@ -668,7 +669,7 @@
           <a:p>
             <a:fld id="{2DB56B22-234B-48A0-9B90-72A4AF419D03}" type="datetimeFigureOut">
               <a:rPr lang="pt-BR" smtClean="0"/>
-              <a:t>16/03/2026</a:t>
+              <a:t>22/03/2026</a:t>
             </a:fld>
             <a:endParaRPr lang="pt-BR"/>
           </a:p>
@@ -866,7 +867,7 @@
           <a:p>
             <a:fld id="{2DB56B22-234B-48A0-9B90-72A4AF419D03}" type="datetimeFigureOut">
               <a:rPr lang="pt-BR" smtClean="0"/>
-              <a:t>16/03/2026</a:t>
+              <a:t>22/03/2026</a:t>
             </a:fld>
             <a:endParaRPr lang="pt-BR"/>
           </a:p>
@@ -1141,7 +1142,7 @@
           <a:p>
             <a:fld id="{2DB56B22-234B-48A0-9B90-72A4AF419D03}" type="datetimeFigureOut">
               <a:rPr lang="pt-BR" smtClean="0"/>
-              <a:t>16/03/2026</a:t>
+              <a:t>22/03/2026</a:t>
             </a:fld>
             <a:endParaRPr lang="pt-BR"/>
           </a:p>
@@ -1406,7 +1407,7 @@
           <a:p>
             <a:fld id="{2DB56B22-234B-48A0-9B90-72A4AF419D03}" type="datetimeFigureOut">
               <a:rPr lang="pt-BR" smtClean="0"/>
-              <a:t>16/03/2026</a:t>
+              <a:t>22/03/2026</a:t>
             </a:fld>
             <a:endParaRPr lang="pt-BR"/>
           </a:p>
@@ -1818,7 +1819,7 @@
           <a:p>
             <a:fld id="{2DB56B22-234B-48A0-9B90-72A4AF419D03}" type="datetimeFigureOut">
               <a:rPr lang="pt-BR" smtClean="0"/>
-              <a:t>16/03/2026</a:t>
+              <a:t>22/03/2026</a:t>
             </a:fld>
             <a:endParaRPr lang="pt-BR"/>
           </a:p>
@@ -1959,7 +1960,7 @@
           <a:p>
             <a:fld id="{2DB56B22-234B-48A0-9B90-72A4AF419D03}" type="datetimeFigureOut">
               <a:rPr lang="pt-BR" smtClean="0"/>
-              <a:t>16/03/2026</a:t>
+              <a:t>22/03/2026</a:t>
             </a:fld>
             <a:endParaRPr lang="pt-BR"/>
           </a:p>
@@ -2072,7 +2073,7 @@
           <a:p>
             <a:fld id="{2DB56B22-234B-48A0-9B90-72A4AF419D03}" type="datetimeFigureOut">
               <a:rPr lang="pt-BR" smtClean="0"/>
-              <a:t>16/03/2026</a:t>
+              <a:t>22/03/2026</a:t>
             </a:fld>
             <a:endParaRPr lang="pt-BR"/>
           </a:p>
@@ -2383,7 +2384,7 @@
           <a:p>
             <a:fld id="{2DB56B22-234B-48A0-9B90-72A4AF419D03}" type="datetimeFigureOut">
               <a:rPr lang="pt-BR" smtClean="0"/>
-              <a:t>16/03/2026</a:t>
+              <a:t>22/03/2026</a:t>
             </a:fld>
             <a:endParaRPr lang="pt-BR"/>
           </a:p>
@@ -2671,7 +2672,7 @@
           <a:p>
             <a:fld id="{2DB56B22-234B-48A0-9B90-72A4AF419D03}" type="datetimeFigureOut">
               <a:rPr lang="pt-BR" smtClean="0"/>
-              <a:t>16/03/2026</a:t>
+              <a:t>22/03/2026</a:t>
             </a:fld>
             <a:endParaRPr lang="pt-BR"/>
           </a:p>
@@ -2912,7 +2913,7 @@
           <a:p>
             <a:fld id="{2DB56B22-234B-48A0-9B90-72A4AF419D03}" type="datetimeFigureOut">
               <a:rPr lang="pt-BR" smtClean="0"/>
-              <a:t>16/03/2026</a:t>
+              <a:t>22/03/2026</a:t>
             </a:fld>
             <a:endParaRPr lang="pt-BR"/>
           </a:p>
@@ -3411,7 +3412,7 @@
             <a:avLst/>
           </a:prstGeom>
           <a:solidFill>
-            <a:srgbClr val="2F3A5F"/>
+            <a:srgbClr val="010A52"/>
           </a:solidFill>
           <a:ln>
             <a:noFill/>
@@ -4410,7 +4411,7 @@
             </a:avLst>
           </a:prstGeom>
           <a:solidFill>
-            <a:srgbClr val="2F3A5F"/>
+            <a:srgbClr val="010A52"/>
           </a:solidFill>
           <a:ln>
             <a:noFill/>
@@ -5104,7 +5105,7 @@
             <a:avLst/>
           </a:prstGeom>
           <a:solidFill>
-            <a:srgbClr val="2F3A5F"/>
+            <a:srgbClr val="010A52"/>
           </a:solidFill>
           <a:ln>
             <a:noFill/>
@@ -6308,7 +6309,7 @@
             </a:avLst>
           </a:prstGeom>
           <a:solidFill>
-            <a:srgbClr val="2F3A5F"/>
+            <a:srgbClr val="010A52"/>
           </a:solidFill>
           <a:ln>
             <a:noFill/>
@@ -6864,7 +6865,7 @@
             <a:avLst/>
           </a:prstGeom>
           <a:solidFill>
-            <a:srgbClr val="2F3A5F"/>
+            <a:srgbClr val="010A52"/>
           </a:solidFill>
           <a:ln>
             <a:noFill/>
@@ -7749,7 +7750,7 @@
             </a:avLst>
           </a:prstGeom>
           <a:solidFill>
-            <a:srgbClr val="2F3A5F"/>
+            <a:srgbClr val="010A52"/>
           </a:solidFill>
           <a:ln>
             <a:noFill/>
@@ -8559,7 +8560,7 @@
             <a:avLst/>
           </a:prstGeom>
           <a:solidFill>
-            <a:srgbClr val="2F3A5F"/>
+            <a:srgbClr val="010A52"/>
           </a:solidFill>
           <a:ln>
             <a:noFill/>
@@ -9444,7 +9445,7 @@
             </a:avLst>
           </a:prstGeom>
           <a:solidFill>
-            <a:srgbClr val="2F3A5F"/>
+            <a:srgbClr val="010A52"/>
           </a:solidFill>
           <a:ln>
             <a:noFill/>
@@ -10209,6 +10210,1823 @@
     <p:extLst>
       <p:ext uri="{BB962C8B-B14F-4D97-AF65-F5344CB8AC3E}">
         <p14:creationId xmlns:p14="http://schemas.microsoft.com/office/powerpoint/2010/main" val="1380647514"/>
+      </p:ext>
+    </p:extLst>
+  </p:cSld>
+  <p:clrMapOvr>
+    <a:masterClrMapping/>
+  </p:clrMapOvr>
+</p:sld>
+</file>
+
+<file path=ppt/slides/slide5.xml><?xml version="1.0" encoding="utf-8"?>
+<p:sld xmlns:a="http://schemas.openxmlformats.org/drawingml/2006/main" xmlns:r="http://schemas.openxmlformats.org/officeDocument/2006/relationships" xmlns:p="http://schemas.openxmlformats.org/presentationml/2006/main">
+  <p:cSld>
+    <p:spTree>
+      <p:nvGrpSpPr>
+        <p:cNvPr id="1" name="">
+          <a:extLst>
+            <a:ext uri="{FF2B5EF4-FFF2-40B4-BE49-F238E27FC236}">
+              <a16:creationId xmlns:a16="http://schemas.microsoft.com/office/drawing/2014/main" id="{15DECBDB-F3F2-5610-5392-29AE714A762D}"/>
+            </a:ext>
+          </a:extLst>
+        </p:cNvPr>
+        <p:cNvGrpSpPr/>
+        <p:nvPr/>
+      </p:nvGrpSpPr>
+      <p:grpSpPr>
+        <a:xfrm>
+          <a:off x="0" y="0"/>
+          <a:ext cx="0" cy="0"/>
+          <a:chOff x="0" y="0"/>
+          <a:chExt cx="0" cy="0"/>
+        </a:xfrm>
+      </p:grpSpPr>
+      <p:sp>
+        <p:nvSpPr>
+          <p:cNvPr id="33" name="Retângulo: Cantos Arredondados 32">
+            <a:extLst>
+              <a:ext uri="{FF2B5EF4-FFF2-40B4-BE49-F238E27FC236}">
+                <a16:creationId xmlns:a16="http://schemas.microsoft.com/office/drawing/2014/main" id="{B2F546BD-164B-0210-2D43-A689121D62BC}"/>
+              </a:ext>
+            </a:extLst>
+          </p:cNvPr>
+          <p:cNvSpPr/>
+          <p:nvPr/>
+        </p:nvSpPr>
+        <p:spPr>
+          <a:xfrm>
+            <a:off x="0" y="0"/>
+            <a:ext cx="12192000" cy="6858000"/>
+          </a:xfrm>
+          <a:prstGeom prst="roundRect">
+            <a:avLst>
+              <a:gd name="adj" fmla="val 4058"/>
+            </a:avLst>
+          </a:prstGeom>
+          <a:solidFill>
+            <a:srgbClr val="F3F4F8"/>
+          </a:solidFill>
+          <a:ln>
+            <a:noFill/>
+          </a:ln>
+        </p:spPr>
+        <p:style>
+          <a:lnRef idx="2">
+            <a:schemeClr val="accent1">
+              <a:shade val="15000"/>
+            </a:schemeClr>
+          </a:lnRef>
+          <a:fillRef idx="1">
+            <a:schemeClr val="accent1"/>
+          </a:fillRef>
+          <a:effectRef idx="0">
+            <a:schemeClr val="accent1"/>
+          </a:effectRef>
+          <a:fontRef idx="minor">
+            <a:schemeClr val="lt1"/>
+          </a:fontRef>
+        </p:style>
+        <p:txBody>
+          <a:bodyPr rtlCol="0" anchor="ctr"/>
+          <a:lstStyle/>
+          <a:p>
+            <a:endParaRPr lang="pt-BR"/>
+          </a:p>
+        </p:txBody>
+      </p:sp>
+      <p:sp>
+        <p:nvSpPr>
+          <p:cNvPr id="5" name="Retângulo: Cantos Arredondados 4">
+            <a:extLst>
+              <a:ext uri="{FF2B5EF4-FFF2-40B4-BE49-F238E27FC236}">
+                <a16:creationId xmlns:a16="http://schemas.microsoft.com/office/drawing/2014/main" id="{E52B59DA-7444-A952-44E2-0A5A647FC95B}"/>
+              </a:ext>
+            </a:extLst>
+          </p:cNvPr>
+          <p:cNvSpPr/>
+          <p:nvPr/>
+        </p:nvSpPr>
+        <p:spPr>
+          <a:xfrm>
+            <a:off x="-177079" y="897622"/>
+            <a:ext cx="715733" cy="4337108"/>
+          </a:xfrm>
+          <a:prstGeom prst="roundRect">
+            <a:avLst/>
+          </a:prstGeom>
+          <a:solidFill>
+            <a:srgbClr val="010A52"/>
+          </a:solidFill>
+          <a:ln>
+            <a:noFill/>
+          </a:ln>
+          <a:effectLst>
+            <a:outerShdw blurRad="101600" dist="38100" dir="5400000" algn="t" rotWithShape="0">
+              <a:prstClr val="black">
+                <a:alpha val="20000"/>
+              </a:prstClr>
+            </a:outerShdw>
+          </a:effectLst>
+        </p:spPr>
+        <p:style>
+          <a:lnRef idx="2">
+            <a:schemeClr val="accent1">
+              <a:shade val="15000"/>
+            </a:schemeClr>
+          </a:lnRef>
+          <a:fillRef idx="1">
+            <a:schemeClr val="accent1"/>
+          </a:fillRef>
+          <a:effectRef idx="0">
+            <a:schemeClr val="accent1"/>
+          </a:effectRef>
+          <a:fontRef idx="minor">
+            <a:schemeClr val="lt1"/>
+          </a:fontRef>
+        </p:style>
+        <p:txBody>
+          <a:bodyPr rtlCol="0" anchor="ctr"/>
+          <a:lstStyle/>
+          <a:p>
+            <a:pPr algn="ctr"/>
+            <a:endParaRPr lang="pt-BR"/>
+          </a:p>
+        </p:txBody>
+      </p:sp>
+      <p:sp>
+        <p:nvSpPr>
+          <p:cNvPr id="43" name="Retângulo: Cantos Arredondados 42">
+            <a:extLst>
+              <a:ext uri="{FF2B5EF4-FFF2-40B4-BE49-F238E27FC236}">
+                <a16:creationId xmlns:a16="http://schemas.microsoft.com/office/drawing/2014/main" id="{34BB365B-6C57-DFDB-CEAE-61898CBB0450}"/>
+              </a:ext>
+            </a:extLst>
+          </p:cNvPr>
+          <p:cNvSpPr/>
+          <p:nvPr/>
+        </p:nvSpPr>
+        <p:spPr>
+          <a:xfrm>
+            <a:off x="-1170" y="-45343"/>
+            <a:ext cx="12233684" cy="853130"/>
+          </a:xfrm>
+          <a:custGeom>
+            <a:avLst/>
+            <a:gdLst>
+              <a:gd name="connsiteX0" fmla="*/ 0 w 12192000"/>
+              <a:gd name="connsiteY0" fmla="*/ 245786 h 491571"/>
+              <a:gd name="connsiteX1" fmla="*/ 245786 w 12192000"/>
+              <a:gd name="connsiteY1" fmla="*/ 0 h 491571"/>
+              <a:gd name="connsiteX2" fmla="*/ 11946215 w 12192000"/>
+              <a:gd name="connsiteY2" fmla="*/ 0 h 491571"/>
+              <a:gd name="connsiteX3" fmla="*/ 12192001 w 12192000"/>
+              <a:gd name="connsiteY3" fmla="*/ 245786 h 491571"/>
+              <a:gd name="connsiteX4" fmla="*/ 12192000 w 12192000"/>
+              <a:gd name="connsiteY4" fmla="*/ 245786 h 491571"/>
+              <a:gd name="connsiteX5" fmla="*/ 11946214 w 12192000"/>
+              <a:gd name="connsiteY5" fmla="*/ 491572 h 491571"/>
+              <a:gd name="connsiteX6" fmla="*/ 245786 w 12192000"/>
+              <a:gd name="connsiteY6" fmla="*/ 491571 h 491571"/>
+              <a:gd name="connsiteX7" fmla="*/ 0 w 12192000"/>
+              <a:gd name="connsiteY7" fmla="*/ 245785 h 491571"/>
+              <a:gd name="connsiteX8" fmla="*/ 0 w 12192000"/>
+              <a:gd name="connsiteY8" fmla="*/ 245786 h 491571"/>
+              <a:gd name="connsiteX0" fmla="*/ 8746 w 12200747"/>
+              <a:gd name="connsiteY0" fmla="*/ 245786 h 525126"/>
+              <a:gd name="connsiteX1" fmla="*/ 254532 w 12200747"/>
+              <a:gd name="connsiteY1" fmla="*/ 0 h 525126"/>
+              <a:gd name="connsiteX2" fmla="*/ 11954961 w 12200747"/>
+              <a:gd name="connsiteY2" fmla="*/ 0 h 525126"/>
+              <a:gd name="connsiteX3" fmla="*/ 12200747 w 12200747"/>
+              <a:gd name="connsiteY3" fmla="*/ 245786 h 525126"/>
+              <a:gd name="connsiteX4" fmla="*/ 12200746 w 12200747"/>
+              <a:gd name="connsiteY4" fmla="*/ 245786 h 525126"/>
+              <a:gd name="connsiteX5" fmla="*/ 11954960 w 12200747"/>
+              <a:gd name="connsiteY5" fmla="*/ 491572 h 525126"/>
+              <a:gd name="connsiteX6" fmla="*/ 95141 w 12200747"/>
+              <a:gd name="connsiteY6" fmla="*/ 525126 h 525126"/>
+              <a:gd name="connsiteX7" fmla="*/ 8746 w 12200747"/>
+              <a:gd name="connsiteY7" fmla="*/ 245785 h 525126"/>
+              <a:gd name="connsiteX8" fmla="*/ 8746 w 12200747"/>
+              <a:gd name="connsiteY8" fmla="*/ 245786 h 525126"/>
+              <a:gd name="connsiteX0" fmla="*/ 7009 w 12199010"/>
+              <a:gd name="connsiteY0" fmla="*/ 245786 h 539413"/>
+              <a:gd name="connsiteX1" fmla="*/ 252795 w 12199010"/>
+              <a:gd name="connsiteY1" fmla="*/ 0 h 539413"/>
+              <a:gd name="connsiteX2" fmla="*/ 11953224 w 12199010"/>
+              <a:gd name="connsiteY2" fmla="*/ 0 h 539413"/>
+              <a:gd name="connsiteX3" fmla="*/ 12199010 w 12199010"/>
+              <a:gd name="connsiteY3" fmla="*/ 245786 h 539413"/>
+              <a:gd name="connsiteX4" fmla="*/ 12199009 w 12199010"/>
+              <a:gd name="connsiteY4" fmla="*/ 245786 h 539413"/>
+              <a:gd name="connsiteX5" fmla="*/ 11953223 w 12199010"/>
+              <a:gd name="connsiteY5" fmla="*/ 491572 h 539413"/>
+              <a:gd name="connsiteX6" fmla="*/ 98167 w 12199010"/>
+              <a:gd name="connsiteY6" fmla="*/ 539413 h 539413"/>
+              <a:gd name="connsiteX7" fmla="*/ 7009 w 12199010"/>
+              <a:gd name="connsiteY7" fmla="*/ 245785 h 539413"/>
+              <a:gd name="connsiteX8" fmla="*/ 7009 w 12199010"/>
+              <a:gd name="connsiteY8" fmla="*/ 245786 h 539413"/>
+              <a:gd name="connsiteX0" fmla="*/ 4473 w 12196474"/>
+              <a:gd name="connsiteY0" fmla="*/ 245786 h 539439"/>
+              <a:gd name="connsiteX1" fmla="*/ 250259 w 12196474"/>
+              <a:gd name="connsiteY1" fmla="*/ 0 h 539439"/>
+              <a:gd name="connsiteX2" fmla="*/ 11950688 w 12196474"/>
+              <a:gd name="connsiteY2" fmla="*/ 0 h 539439"/>
+              <a:gd name="connsiteX3" fmla="*/ 12196474 w 12196474"/>
+              <a:gd name="connsiteY3" fmla="*/ 245786 h 539439"/>
+              <a:gd name="connsiteX4" fmla="*/ 12196473 w 12196474"/>
+              <a:gd name="connsiteY4" fmla="*/ 245786 h 539439"/>
+              <a:gd name="connsiteX5" fmla="*/ 11950687 w 12196474"/>
+              <a:gd name="connsiteY5" fmla="*/ 491572 h 539439"/>
+              <a:gd name="connsiteX6" fmla="*/ 95631 w 12196474"/>
+              <a:gd name="connsiteY6" fmla="*/ 539413 h 539439"/>
+              <a:gd name="connsiteX7" fmla="*/ 4473 w 12196474"/>
+              <a:gd name="connsiteY7" fmla="*/ 245785 h 539439"/>
+              <a:gd name="connsiteX8" fmla="*/ 4473 w 12196474"/>
+              <a:gd name="connsiteY8" fmla="*/ 245786 h 539439"/>
+              <a:gd name="connsiteX0" fmla="*/ 48673 w 12240674"/>
+              <a:gd name="connsiteY0" fmla="*/ 245786 h 539439"/>
+              <a:gd name="connsiteX1" fmla="*/ 294459 w 12240674"/>
+              <a:gd name="connsiteY1" fmla="*/ 0 h 539439"/>
+              <a:gd name="connsiteX2" fmla="*/ 11994888 w 12240674"/>
+              <a:gd name="connsiteY2" fmla="*/ 0 h 539439"/>
+              <a:gd name="connsiteX3" fmla="*/ 12240674 w 12240674"/>
+              <a:gd name="connsiteY3" fmla="*/ 245786 h 539439"/>
+              <a:gd name="connsiteX4" fmla="*/ 12240673 w 12240674"/>
+              <a:gd name="connsiteY4" fmla="*/ 245786 h 539439"/>
+              <a:gd name="connsiteX5" fmla="*/ 11994887 w 12240674"/>
+              <a:gd name="connsiteY5" fmla="*/ 491572 h 539439"/>
+              <a:gd name="connsiteX6" fmla="*/ 58868 w 12240674"/>
+              <a:gd name="connsiteY6" fmla="*/ 539413 h 539439"/>
+              <a:gd name="connsiteX7" fmla="*/ 48673 w 12240674"/>
+              <a:gd name="connsiteY7" fmla="*/ 245785 h 539439"/>
+              <a:gd name="connsiteX8" fmla="*/ 48673 w 12240674"/>
+              <a:gd name="connsiteY8" fmla="*/ 245786 h 539439"/>
+              <a:gd name="connsiteX0" fmla="*/ 0 w 12192001"/>
+              <a:gd name="connsiteY0" fmla="*/ 245786 h 540522"/>
+              <a:gd name="connsiteX1" fmla="*/ 245786 w 12192001"/>
+              <a:gd name="connsiteY1" fmla="*/ 0 h 540522"/>
+              <a:gd name="connsiteX2" fmla="*/ 11946215 w 12192001"/>
+              <a:gd name="connsiteY2" fmla="*/ 0 h 540522"/>
+              <a:gd name="connsiteX3" fmla="*/ 12192001 w 12192001"/>
+              <a:gd name="connsiteY3" fmla="*/ 245786 h 540522"/>
+              <a:gd name="connsiteX4" fmla="*/ 12192000 w 12192001"/>
+              <a:gd name="connsiteY4" fmla="*/ 245786 h 540522"/>
+              <a:gd name="connsiteX5" fmla="*/ 11946214 w 12192001"/>
+              <a:gd name="connsiteY5" fmla="*/ 491572 h 540522"/>
+              <a:gd name="connsiteX6" fmla="*/ 10195 w 12192001"/>
+              <a:gd name="connsiteY6" fmla="*/ 539413 h 540522"/>
+              <a:gd name="connsiteX7" fmla="*/ 0 w 12192001"/>
+              <a:gd name="connsiteY7" fmla="*/ 245785 h 540522"/>
+              <a:gd name="connsiteX8" fmla="*/ 0 w 12192001"/>
+              <a:gd name="connsiteY8" fmla="*/ 245786 h 540522"/>
+              <a:gd name="connsiteX0" fmla="*/ 1172 w 12193173"/>
+              <a:gd name="connsiteY0" fmla="*/ 245786 h 540522"/>
+              <a:gd name="connsiteX1" fmla="*/ 246958 w 12193173"/>
+              <a:gd name="connsiteY1" fmla="*/ 0 h 540522"/>
+              <a:gd name="connsiteX2" fmla="*/ 11947387 w 12193173"/>
+              <a:gd name="connsiteY2" fmla="*/ 0 h 540522"/>
+              <a:gd name="connsiteX3" fmla="*/ 12193173 w 12193173"/>
+              <a:gd name="connsiteY3" fmla="*/ 245786 h 540522"/>
+              <a:gd name="connsiteX4" fmla="*/ 12193172 w 12193173"/>
+              <a:gd name="connsiteY4" fmla="*/ 245786 h 540522"/>
+              <a:gd name="connsiteX5" fmla="*/ 11947386 w 12193173"/>
+              <a:gd name="connsiteY5" fmla="*/ 491572 h 540522"/>
+              <a:gd name="connsiteX6" fmla="*/ 4223 w 12193173"/>
+              <a:gd name="connsiteY6" fmla="*/ 539413 h 540522"/>
+              <a:gd name="connsiteX7" fmla="*/ 1172 w 12193173"/>
+              <a:gd name="connsiteY7" fmla="*/ 245785 h 540522"/>
+              <a:gd name="connsiteX8" fmla="*/ 1172 w 12193173"/>
+              <a:gd name="connsiteY8" fmla="*/ 245786 h 540522"/>
+              <a:gd name="connsiteX0" fmla="*/ 1172 w 12231428"/>
+              <a:gd name="connsiteY0" fmla="*/ 245786 h 540522"/>
+              <a:gd name="connsiteX1" fmla="*/ 246958 w 12231428"/>
+              <a:gd name="connsiteY1" fmla="*/ 0 h 540522"/>
+              <a:gd name="connsiteX2" fmla="*/ 11947387 w 12231428"/>
+              <a:gd name="connsiteY2" fmla="*/ 0 h 540522"/>
+              <a:gd name="connsiteX3" fmla="*/ 12193173 w 12231428"/>
+              <a:gd name="connsiteY3" fmla="*/ 245786 h 540522"/>
+              <a:gd name="connsiteX4" fmla="*/ 12193172 w 12231428"/>
+              <a:gd name="connsiteY4" fmla="*/ 245786 h 540522"/>
+              <a:gd name="connsiteX5" fmla="*/ 12161698 w 12231428"/>
+              <a:gd name="connsiteY5" fmla="*/ 486810 h 540522"/>
+              <a:gd name="connsiteX6" fmla="*/ 4223 w 12231428"/>
+              <a:gd name="connsiteY6" fmla="*/ 539413 h 540522"/>
+              <a:gd name="connsiteX7" fmla="*/ 1172 w 12231428"/>
+              <a:gd name="connsiteY7" fmla="*/ 245785 h 540522"/>
+              <a:gd name="connsiteX8" fmla="*/ 1172 w 12231428"/>
+              <a:gd name="connsiteY8" fmla="*/ 245786 h 540522"/>
+              <a:gd name="connsiteX0" fmla="*/ 1172 w 12195146"/>
+              <a:gd name="connsiteY0" fmla="*/ 245786 h 540522"/>
+              <a:gd name="connsiteX1" fmla="*/ 246958 w 12195146"/>
+              <a:gd name="connsiteY1" fmla="*/ 0 h 540522"/>
+              <a:gd name="connsiteX2" fmla="*/ 11947387 w 12195146"/>
+              <a:gd name="connsiteY2" fmla="*/ 0 h 540522"/>
+              <a:gd name="connsiteX3" fmla="*/ 12193173 w 12195146"/>
+              <a:gd name="connsiteY3" fmla="*/ 245786 h 540522"/>
+              <a:gd name="connsiteX4" fmla="*/ 12193172 w 12195146"/>
+              <a:gd name="connsiteY4" fmla="*/ 245786 h 540522"/>
+              <a:gd name="connsiteX5" fmla="*/ 12161698 w 12195146"/>
+              <a:gd name="connsiteY5" fmla="*/ 486810 h 540522"/>
+              <a:gd name="connsiteX6" fmla="*/ 4223 w 12195146"/>
+              <a:gd name="connsiteY6" fmla="*/ 539413 h 540522"/>
+              <a:gd name="connsiteX7" fmla="*/ 1172 w 12195146"/>
+              <a:gd name="connsiteY7" fmla="*/ 245785 h 540522"/>
+              <a:gd name="connsiteX8" fmla="*/ 1172 w 12195146"/>
+              <a:gd name="connsiteY8" fmla="*/ 245786 h 540522"/>
+              <a:gd name="connsiteX0" fmla="*/ 1172 w 12244277"/>
+              <a:gd name="connsiteY0" fmla="*/ 245786 h 540522"/>
+              <a:gd name="connsiteX1" fmla="*/ 246958 w 12244277"/>
+              <a:gd name="connsiteY1" fmla="*/ 0 h 540522"/>
+              <a:gd name="connsiteX2" fmla="*/ 11947387 w 12244277"/>
+              <a:gd name="connsiteY2" fmla="*/ 0 h 540522"/>
+              <a:gd name="connsiteX3" fmla="*/ 12193173 w 12244277"/>
+              <a:gd name="connsiteY3" fmla="*/ 245786 h 540522"/>
+              <a:gd name="connsiteX4" fmla="*/ 12193172 w 12244277"/>
+              <a:gd name="connsiteY4" fmla="*/ 245786 h 540522"/>
+              <a:gd name="connsiteX5" fmla="*/ 12230754 w 12244277"/>
+              <a:gd name="connsiteY5" fmla="*/ 484428 h 540522"/>
+              <a:gd name="connsiteX6" fmla="*/ 4223 w 12244277"/>
+              <a:gd name="connsiteY6" fmla="*/ 539413 h 540522"/>
+              <a:gd name="connsiteX7" fmla="*/ 1172 w 12244277"/>
+              <a:gd name="connsiteY7" fmla="*/ 245785 h 540522"/>
+              <a:gd name="connsiteX8" fmla="*/ 1172 w 12244277"/>
+              <a:gd name="connsiteY8" fmla="*/ 245786 h 540522"/>
+              <a:gd name="connsiteX0" fmla="*/ 1172 w 12222094"/>
+              <a:gd name="connsiteY0" fmla="*/ 245786 h 540522"/>
+              <a:gd name="connsiteX1" fmla="*/ 246958 w 12222094"/>
+              <a:gd name="connsiteY1" fmla="*/ 0 h 540522"/>
+              <a:gd name="connsiteX2" fmla="*/ 11947387 w 12222094"/>
+              <a:gd name="connsiteY2" fmla="*/ 0 h 540522"/>
+              <a:gd name="connsiteX3" fmla="*/ 12193173 w 12222094"/>
+              <a:gd name="connsiteY3" fmla="*/ 245786 h 540522"/>
+              <a:gd name="connsiteX4" fmla="*/ 12193172 w 12222094"/>
+              <a:gd name="connsiteY4" fmla="*/ 245786 h 540522"/>
+              <a:gd name="connsiteX5" fmla="*/ 12204561 w 12222094"/>
+              <a:gd name="connsiteY5" fmla="*/ 489190 h 540522"/>
+              <a:gd name="connsiteX6" fmla="*/ 4223 w 12222094"/>
+              <a:gd name="connsiteY6" fmla="*/ 539413 h 540522"/>
+              <a:gd name="connsiteX7" fmla="*/ 1172 w 12222094"/>
+              <a:gd name="connsiteY7" fmla="*/ 245785 h 540522"/>
+              <a:gd name="connsiteX8" fmla="*/ 1172 w 12222094"/>
+              <a:gd name="connsiteY8" fmla="*/ 245786 h 540522"/>
+              <a:gd name="connsiteX0" fmla="*/ 1172 w 12207823"/>
+              <a:gd name="connsiteY0" fmla="*/ 245786 h 540522"/>
+              <a:gd name="connsiteX1" fmla="*/ 246958 w 12207823"/>
+              <a:gd name="connsiteY1" fmla="*/ 0 h 540522"/>
+              <a:gd name="connsiteX2" fmla="*/ 11947387 w 12207823"/>
+              <a:gd name="connsiteY2" fmla="*/ 0 h 540522"/>
+              <a:gd name="connsiteX3" fmla="*/ 12193173 w 12207823"/>
+              <a:gd name="connsiteY3" fmla="*/ 245786 h 540522"/>
+              <a:gd name="connsiteX4" fmla="*/ 12193172 w 12207823"/>
+              <a:gd name="connsiteY4" fmla="*/ 245786 h 540522"/>
+              <a:gd name="connsiteX5" fmla="*/ 12185511 w 12207823"/>
+              <a:gd name="connsiteY5" fmla="*/ 491571 h 540522"/>
+              <a:gd name="connsiteX6" fmla="*/ 4223 w 12207823"/>
+              <a:gd name="connsiteY6" fmla="*/ 539413 h 540522"/>
+              <a:gd name="connsiteX7" fmla="*/ 1172 w 12207823"/>
+              <a:gd name="connsiteY7" fmla="*/ 245785 h 540522"/>
+              <a:gd name="connsiteX8" fmla="*/ 1172 w 12207823"/>
+              <a:gd name="connsiteY8" fmla="*/ 245786 h 540522"/>
+              <a:gd name="connsiteX0" fmla="*/ 1172 w 12202618"/>
+              <a:gd name="connsiteY0" fmla="*/ 245786 h 540522"/>
+              <a:gd name="connsiteX1" fmla="*/ 246958 w 12202618"/>
+              <a:gd name="connsiteY1" fmla="*/ 0 h 540522"/>
+              <a:gd name="connsiteX2" fmla="*/ 11947387 w 12202618"/>
+              <a:gd name="connsiteY2" fmla="*/ 0 h 540522"/>
+              <a:gd name="connsiteX3" fmla="*/ 12193173 w 12202618"/>
+              <a:gd name="connsiteY3" fmla="*/ 245786 h 540522"/>
+              <a:gd name="connsiteX4" fmla="*/ 12193172 w 12202618"/>
+              <a:gd name="connsiteY4" fmla="*/ 245786 h 540522"/>
+              <a:gd name="connsiteX5" fmla="*/ 12185511 w 12202618"/>
+              <a:gd name="connsiteY5" fmla="*/ 491571 h 540522"/>
+              <a:gd name="connsiteX6" fmla="*/ 4223 w 12202618"/>
+              <a:gd name="connsiteY6" fmla="*/ 539413 h 540522"/>
+              <a:gd name="connsiteX7" fmla="*/ 1172 w 12202618"/>
+              <a:gd name="connsiteY7" fmla="*/ 245785 h 540522"/>
+              <a:gd name="connsiteX8" fmla="*/ 1172 w 12202618"/>
+              <a:gd name="connsiteY8" fmla="*/ 245786 h 540522"/>
+              <a:gd name="connsiteX0" fmla="*/ 1172 w 12213078"/>
+              <a:gd name="connsiteY0" fmla="*/ 245786 h 540522"/>
+              <a:gd name="connsiteX1" fmla="*/ 246958 w 12213078"/>
+              <a:gd name="connsiteY1" fmla="*/ 0 h 540522"/>
+              <a:gd name="connsiteX2" fmla="*/ 11947387 w 12213078"/>
+              <a:gd name="connsiteY2" fmla="*/ 0 h 540522"/>
+              <a:gd name="connsiteX3" fmla="*/ 12193173 w 12213078"/>
+              <a:gd name="connsiteY3" fmla="*/ 245786 h 540522"/>
+              <a:gd name="connsiteX4" fmla="*/ 12193172 w 12213078"/>
+              <a:gd name="connsiteY4" fmla="*/ 245786 h 540522"/>
+              <a:gd name="connsiteX5" fmla="*/ 12199798 w 12213078"/>
+              <a:gd name="connsiteY5" fmla="*/ 491571 h 540522"/>
+              <a:gd name="connsiteX6" fmla="*/ 4223 w 12213078"/>
+              <a:gd name="connsiteY6" fmla="*/ 539413 h 540522"/>
+              <a:gd name="connsiteX7" fmla="*/ 1172 w 12213078"/>
+              <a:gd name="connsiteY7" fmla="*/ 245785 h 540522"/>
+              <a:gd name="connsiteX8" fmla="*/ 1172 w 12213078"/>
+              <a:gd name="connsiteY8" fmla="*/ 245786 h 540522"/>
+              <a:gd name="connsiteX0" fmla="*/ 1172 w 12198313"/>
+              <a:gd name="connsiteY0" fmla="*/ 245786 h 540522"/>
+              <a:gd name="connsiteX1" fmla="*/ 246958 w 12198313"/>
+              <a:gd name="connsiteY1" fmla="*/ 0 h 540522"/>
+              <a:gd name="connsiteX2" fmla="*/ 11947387 w 12198313"/>
+              <a:gd name="connsiteY2" fmla="*/ 0 h 540522"/>
+              <a:gd name="connsiteX3" fmla="*/ 12193173 w 12198313"/>
+              <a:gd name="connsiteY3" fmla="*/ 245786 h 540522"/>
+              <a:gd name="connsiteX4" fmla="*/ 12193172 w 12198313"/>
+              <a:gd name="connsiteY4" fmla="*/ 245786 h 540522"/>
+              <a:gd name="connsiteX5" fmla="*/ 12178366 w 12198313"/>
+              <a:gd name="connsiteY5" fmla="*/ 526990 h 540522"/>
+              <a:gd name="connsiteX6" fmla="*/ 4223 w 12198313"/>
+              <a:gd name="connsiteY6" fmla="*/ 539413 h 540522"/>
+              <a:gd name="connsiteX7" fmla="*/ 1172 w 12198313"/>
+              <a:gd name="connsiteY7" fmla="*/ 245785 h 540522"/>
+              <a:gd name="connsiteX8" fmla="*/ 1172 w 12198313"/>
+              <a:gd name="connsiteY8" fmla="*/ 245786 h 540522"/>
+              <a:gd name="connsiteX0" fmla="*/ 1172 w 12233684"/>
+              <a:gd name="connsiteY0" fmla="*/ 245786 h 551725"/>
+              <a:gd name="connsiteX1" fmla="*/ 246958 w 12233684"/>
+              <a:gd name="connsiteY1" fmla="*/ 0 h 551725"/>
+              <a:gd name="connsiteX2" fmla="*/ 11947387 w 12233684"/>
+              <a:gd name="connsiteY2" fmla="*/ 0 h 551725"/>
+              <a:gd name="connsiteX3" fmla="*/ 12193173 w 12233684"/>
+              <a:gd name="connsiteY3" fmla="*/ 245786 h 551725"/>
+              <a:gd name="connsiteX4" fmla="*/ 12193172 w 12233684"/>
+              <a:gd name="connsiteY4" fmla="*/ 245786 h 551725"/>
+              <a:gd name="connsiteX5" fmla="*/ 12224086 w 12233684"/>
+              <a:gd name="connsiteY5" fmla="*/ 551630 h 551725"/>
+              <a:gd name="connsiteX6" fmla="*/ 4223 w 12233684"/>
+              <a:gd name="connsiteY6" fmla="*/ 539413 h 551725"/>
+              <a:gd name="connsiteX7" fmla="*/ 1172 w 12233684"/>
+              <a:gd name="connsiteY7" fmla="*/ 245785 h 551725"/>
+              <a:gd name="connsiteX8" fmla="*/ 1172 w 12233684"/>
+              <a:gd name="connsiteY8" fmla="*/ 245786 h 551725"/>
+            </a:gdLst>
+            <a:ahLst/>
+            <a:cxnLst>
+              <a:cxn ang="0">
+                <a:pos x="connsiteX0" y="connsiteY0"/>
+              </a:cxn>
+              <a:cxn ang="0">
+                <a:pos x="connsiteX1" y="connsiteY1"/>
+              </a:cxn>
+              <a:cxn ang="0">
+                <a:pos x="connsiteX2" y="connsiteY2"/>
+              </a:cxn>
+              <a:cxn ang="0">
+                <a:pos x="connsiteX3" y="connsiteY3"/>
+              </a:cxn>
+              <a:cxn ang="0">
+                <a:pos x="connsiteX4" y="connsiteY4"/>
+              </a:cxn>
+              <a:cxn ang="0">
+                <a:pos x="connsiteX5" y="connsiteY5"/>
+              </a:cxn>
+              <a:cxn ang="0">
+                <a:pos x="connsiteX6" y="connsiteY6"/>
+              </a:cxn>
+              <a:cxn ang="0">
+                <a:pos x="connsiteX7" y="connsiteY7"/>
+              </a:cxn>
+              <a:cxn ang="0">
+                <a:pos x="connsiteX8" y="connsiteY8"/>
+              </a:cxn>
+            </a:cxnLst>
+            <a:rect l="l" t="t" r="r" b="b"/>
+            <a:pathLst>
+              <a:path w="12233684" h="551725">
+                <a:moveTo>
+                  <a:pt x="1172" y="245786"/>
+                </a:moveTo>
+                <a:cubicBezTo>
+                  <a:pt x="1172" y="110042"/>
+                  <a:pt x="111214" y="0"/>
+                  <a:pt x="246958" y="0"/>
+                </a:cubicBezTo>
+                <a:lnTo>
+                  <a:pt x="11947387" y="0"/>
+                </a:lnTo>
+                <a:cubicBezTo>
+                  <a:pt x="12083131" y="0"/>
+                  <a:pt x="12193173" y="110042"/>
+                  <a:pt x="12193173" y="245786"/>
+                </a:cubicBezTo>
+                <a:lnTo>
+                  <a:pt x="12193172" y="245786"/>
+                </a:lnTo>
+                <a:cubicBezTo>
+                  <a:pt x="12193172" y="381530"/>
+                  <a:pt x="12257437" y="556393"/>
+                  <a:pt x="12224086" y="551630"/>
+                </a:cubicBezTo>
+                <a:lnTo>
+                  <a:pt x="4223" y="539413"/>
+                </a:lnTo>
+                <a:cubicBezTo>
+                  <a:pt x="-2934" y="556082"/>
+                  <a:pt x="1172" y="381529"/>
+                  <a:pt x="1172" y="245785"/>
+                </a:cubicBezTo>
+                <a:lnTo>
+                  <a:pt x="1172" y="245786"/>
+                </a:lnTo>
+                <a:close/>
+              </a:path>
+            </a:pathLst>
+          </a:custGeom>
+          <a:solidFill>
+            <a:schemeClr val="bg1"/>
+          </a:solidFill>
+          <a:ln>
+            <a:noFill/>
+          </a:ln>
+          <a:effectLst/>
+        </p:spPr>
+        <p:style>
+          <a:lnRef idx="2">
+            <a:schemeClr val="accent1">
+              <a:shade val="15000"/>
+            </a:schemeClr>
+          </a:lnRef>
+          <a:fillRef idx="1">
+            <a:schemeClr val="accent1"/>
+          </a:fillRef>
+          <a:effectRef idx="0">
+            <a:schemeClr val="accent1"/>
+          </a:effectRef>
+          <a:fontRef idx="minor">
+            <a:schemeClr val="lt1"/>
+          </a:fontRef>
+        </p:style>
+        <p:txBody>
+          <a:bodyPr rtlCol="0" anchor="ctr"/>
+          <a:lstStyle/>
+          <a:p>
+            <a:pPr algn="ctr"/>
+            <a:endParaRPr lang="pt-BR"/>
+          </a:p>
+        </p:txBody>
+      </p:sp>
+      <p:sp>
+        <p:nvSpPr>
+          <p:cNvPr id="6" name="Retângulo: Cantos Arredondados 5">
+            <a:extLst>
+              <a:ext uri="{FF2B5EF4-FFF2-40B4-BE49-F238E27FC236}">
+                <a16:creationId xmlns:a16="http://schemas.microsoft.com/office/drawing/2014/main" id="{059EC8DE-693F-2D30-CDBC-C63E2A1AE36C}"/>
+              </a:ext>
+            </a:extLst>
+          </p:cNvPr>
+          <p:cNvSpPr/>
+          <p:nvPr/>
+        </p:nvSpPr>
+        <p:spPr>
+          <a:xfrm>
+            <a:off x="1049149" y="949534"/>
+            <a:ext cx="2387600" cy="853130"/>
+          </a:xfrm>
+          <a:prstGeom prst="roundRect">
+            <a:avLst>
+              <a:gd name="adj" fmla="val 8257"/>
+            </a:avLst>
+          </a:prstGeom>
+          <a:solidFill>
+            <a:schemeClr val="bg1"/>
+          </a:solidFill>
+          <a:ln>
+            <a:noFill/>
+          </a:ln>
+          <a:effectLst>
+            <a:outerShdw blurRad="101600" dist="38100" dir="5400000" algn="t" rotWithShape="0">
+              <a:prstClr val="black">
+                <a:alpha val="20000"/>
+              </a:prstClr>
+            </a:outerShdw>
+          </a:effectLst>
+        </p:spPr>
+        <p:style>
+          <a:lnRef idx="2">
+            <a:schemeClr val="accent1">
+              <a:shade val="15000"/>
+            </a:schemeClr>
+          </a:lnRef>
+          <a:fillRef idx="1">
+            <a:schemeClr val="accent1"/>
+          </a:fillRef>
+          <a:effectRef idx="0">
+            <a:schemeClr val="accent1"/>
+          </a:effectRef>
+          <a:fontRef idx="minor">
+            <a:schemeClr val="lt1"/>
+          </a:fontRef>
+        </p:style>
+        <p:txBody>
+          <a:bodyPr rtlCol="0" anchor="ctr"/>
+          <a:lstStyle/>
+          <a:p>
+            <a:pPr algn="ctr"/>
+            <a:endParaRPr lang="pt-BR"/>
+          </a:p>
+        </p:txBody>
+      </p:sp>
+      <p:sp>
+        <p:nvSpPr>
+          <p:cNvPr id="7" name="Retângulo: Cantos Arredondados 6">
+            <a:extLst>
+              <a:ext uri="{FF2B5EF4-FFF2-40B4-BE49-F238E27FC236}">
+                <a16:creationId xmlns:a16="http://schemas.microsoft.com/office/drawing/2014/main" id="{935B4D87-7F10-AB36-968D-D4D6730226AA}"/>
+              </a:ext>
+            </a:extLst>
+          </p:cNvPr>
+          <p:cNvSpPr/>
+          <p:nvPr/>
+        </p:nvSpPr>
+        <p:spPr>
+          <a:xfrm>
+            <a:off x="3813903" y="949534"/>
+            <a:ext cx="2387600" cy="853130"/>
+          </a:xfrm>
+          <a:prstGeom prst="roundRect">
+            <a:avLst>
+              <a:gd name="adj" fmla="val 7416"/>
+            </a:avLst>
+          </a:prstGeom>
+          <a:solidFill>
+            <a:schemeClr val="bg1"/>
+          </a:solidFill>
+          <a:ln>
+            <a:noFill/>
+          </a:ln>
+          <a:effectLst>
+            <a:outerShdw blurRad="101600" dist="38100" dir="5400000" algn="t" rotWithShape="0">
+              <a:prstClr val="black">
+                <a:alpha val="20000"/>
+              </a:prstClr>
+            </a:outerShdw>
+          </a:effectLst>
+        </p:spPr>
+        <p:style>
+          <a:lnRef idx="2">
+            <a:schemeClr val="accent1">
+              <a:shade val="15000"/>
+            </a:schemeClr>
+          </a:lnRef>
+          <a:fillRef idx="1">
+            <a:schemeClr val="accent1"/>
+          </a:fillRef>
+          <a:effectRef idx="0">
+            <a:schemeClr val="accent1"/>
+          </a:effectRef>
+          <a:fontRef idx="minor">
+            <a:schemeClr val="lt1"/>
+          </a:fontRef>
+        </p:style>
+        <p:txBody>
+          <a:bodyPr rtlCol="0" anchor="ctr"/>
+          <a:lstStyle/>
+          <a:p>
+            <a:pPr algn="ctr"/>
+            <a:endParaRPr lang="pt-BR"/>
+          </a:p>
+        </p:txBody>
+      </p:sp>
+      <p:sp>
+        <p:nvSpPr>
+          <p:cNvPr id="8" name="Retângulo: Cantos Arredondados 7">
+            <a:extLst>
+              <a:ext uri="{FF2B5EF4-FFF2-40B4-BE49-F238E27FC236}">
+                <a16:creationId xmlns:a16="http://schemas.microsoft.com/office/drawing/2014/main" id="{16B04D69-7B73-6177-C7B1-F20FA93BF3AF}"/>
+              </a:ext>
+            </a:extLst>
+          </p:cNvPr>
+          <p:cNvSpPr/>
+          <p:nvPr/>
+        </p:nvSpPr>
+        <p:spPr>
+          <a:xfrm>
+            <a:off x="9380638" y="950110"/>
+            <a:ext cx="2387600" cy="847474"/>
+          </a:xfrm>
+          <a:prstGeom prst="roundRect">
+            <a:avLst>
+              <a:gd name="adj" fmla="val 7416"/>
+            </a:avLst>
+          </a:prstGeom>
+          <a:solidFill>
+            <a:schemeClr val="bg1"/>
+          </a:solidFill>
+          <a:ln>
+            <a:noFill/>
+          </a:ln>
+          <a:effectLst>
+            <a:outerShdw blurRad="101600" dist="38100" dir="5400000" algn="t" rotWithShape="0">
+              <a:prstClr val="black">
+                <a:alpha val="20000"/>
+              </a:prstClr>
+            </a:outerShdw>
+          </a:effectLst>
+        </p:spPr>
+        <p:style>
+          <a:lnRef idx="2">
+            <a:schemeClr val="accent1">
+              <a:shade val="15000"/>
+            </a:schemeClr>
+          </a:lnRef>
+          <a:fillRef idx="1">
+            <a:schemeClr val="accent1"/>
+          </a:fillRef>
+          <a:effectRef idx="0">
+            <a:schemeClr val="accent1"/>
+          </a:effectRef>
+          <a:fontRef idx="minor">
+            <a:schemeClr val="lt1"/>
+          </a:fontRef>
+        </p:style>
+        <p:txBody>
+          <a:bodyPr rtlCol="0" anchor="ctr"/>
+          <a:lstStyle/>
+          <a:p>
+            <a:pPr algn="ctr"/>
+            <a:endParaRPr lang="pt-BR"/>
+          </a:p>
+        </p:txBody>
+      </p:sp>
+      <p:sp>
+        <p:nvSpPr>
+          <p:cNvPr id="10" name="Retângulo: Cantos Arredondados 9">
+            <a:extLst>
+              <a:ext uri="{FF2B5EF4-FFF2-40B4-BE49-F238E27FC236}">
+                <a16:creationId xmlns:a16="http://schemas.microsoft.com/office/drawing/2014/main" id="{E600486A-A0F4-6258-BBAA-18F2F9FE4F3A}"/>
+              </a:ext>
+            </a:extLst>
+          </p:cNvPr>
+          <p:cNvSpPr/>
+          <p:nvPr/>
+        </p:nvSpPr>
+        <p:spPr>
+          <a:xfrm>
+            <a:off x="1049149" y="1944411"/>
+            <a:ext cx="5266984" cy="2619127"/>
+          </a:xfrm>
+          <a:prstGeom prst="roundRect">
+            <a:avLst>
+              <a:gd name="adj" fmla="val 5297"/>
+            </a:avLst>
+          </a:prstGeom>
+          <a:solidFill>
+            <a:schemeClr val="bg1"/>
+          </a:solidFill>
+          <a:ln>
+            <a:noFill/>
+          </a:ln>
+          <a:effectLst>
+            <a:outerShdw blurRad="101600" dist="38100" dir="5400000" algn="t" rotWithShape="0">
+              <a:prstClr val="black">
+                <a:alpha val="20000"/>
+              </a:prstClr>
+            </a:outerShdw>
+          </a:effectLst>
+        </p:spPr>
+        <p:style>
+          <a:lnRef idx="2">
+            <a:schemeClr val="accent1">
+              <a:shade val="15000"/>
+            </a:schemeClr>
+          </a:lnRef>
+          <a:fillRef idx="1">
+            <a:schemeClr val="accent1"/>
+          </a:fillRef>
+          <a:effectRef idx="0">
+            <a:schemeClr val="accent1"/>
+          </a:effectRef>
+          <a:fontRef idx="minor">
+            <a:schemeClr val="lt1"/>
+          </a:fontRef>
+        </p:style>
+        <p:txBody>
+          <a:bodyPr rtlCol="0" anchor="ctr"/>
+          <a:lstStyle/>
+          <a:p>
+            <a:pPr algn="ctr"/>
+            <a:endParaRPr lang="pt-BR"/>
+          </a:p>
+        </p:txBody>
+      </p:sp>
+      <p:sp>
+        <p:nvSpPr>
+          <p:cNvPr id="12" name="Retângulo: Cantos Arredondados 11">
+            <a:extLst>
+              <a:ext uri="{FF2B5EF4-FFF2-40B4-BE49-F238E27FC236}">
+                <a16:creationId xmlns:a16="http://schemas.microsoft.com/office/drawing/2014/main" id="{8D72F93A-4356-D4B9-B706-F422863C2413}"/>
+              </a:ext>
+            </a:extLst>
+          </p:cNvPr>
+          <p:cNvSpPr/>
+          <p:nvPr/>
+        </p:nvSpPr>
+        <p:spPr>
+          <a:xfrm>
+            <a:off x="1049149" y="4820478"/>
+            <a:ext cx="10737908" cy="1921835"/>
+          </a:xfrm>
+          <a:prstGeom prst="roundRect">
+            <a:avLst>
+              <a:gd name="adj" fmla="val 4729"/>
+            </a:avLst>
+          </a:prstGeom>
+          <a:solidFill>
+            <a:schemeClr val="bg1"/>
+          </a:solidFill>
+          <a:ln>
+            <a:noFill/>
+          </a:ln>
+          <a:effectLst>
+            <a:outerShdw blurRad="101600" dist="38100" dir="5400000" algn="t" rotWithShape="0">
+              <a:prstClr val="black">
+                <a:alpha val="20000"/>
+              </a:prstClr>
+            </a:outerShdw>
+          </a:effectLst>
+        </p:spPr>
+        <p:style>
+          <a:lnRef idx="2">
+            <a:schemeClr val="accent1">
+              <a:shade val="15000"/>
+            </a:schemeClr>
+          </a:lnRef>
+          <a:fillRef idx="1">
+            <a:schemeClr val="accent1"/>
+          </a:fillRef>
+          <a:effectRef idx="0">
+            <a:schemeClr val="accent1"/>
+          </a:effectRef>
+          <a:fontRef idx="minor">
+            <a:schemeClr val="lt1"/>
+          </a:fontRef>
+        </p:style>
+        <p:txBody>
+          <a:bodyPr rtlCol="0" anchor="ctr"/>
+          <a:lstStyle/>
+          <a:p>
+            <a:pPr algn="ctr"/>
+            <a:endParaRPr lang="pt-BR"/>
+          </a:p>
+        </p:txBody>
+      </p:sp>
+      <p:sp>
+        <p:nvSpPr>
+          <p:cNvPr id="34" name="Rectangle 1">
+            <a:extLst>
+              <a:ext uri="{FF2B5EF4-FFF2-40B4-BE49-F238E27FC236}">
+                <a16:creationId xmlns:a16="http://schemas.microsoft.com/office/drawing/2014/main" id="{99360A99-0724-5818-A79E-82A878AD47FA}"/>
+              </a:ext>
+            </a:extLst>
+          </p:cNvPr>
+          <p:cNvSpPr>
+            <a:spLocks noChangeArrowheads="1"/>
+          </p:cNvSpPr>
+          <p:nvPr/>
+        </p:nvSpPr>
+        <p:spPr bwMode="auto">
+          <a:xfrm>
+            <a:off x="0" y="0"/>
+            <a:ext cx="12192000" cy="0"/>
+          </a:xfrm>
+          <a:prstGeom prst="rect">
+            <a:avLst/>
+          </a:prstGeom>
+          <a:noFill/>
+          <a:ln>
+            <a:noFill/>
+          </a:ln>
+          <a:effectLst/>
+          <a:extLst>
+            <a:ext uri="{909E8E84-426E-40DD-AFC4-6F175D3DCCD1}">
+              <a14:hiddenFill xmlns:a14="http://schemas.microsoft.com/office/drawing/2010/main">
+                <a:solidFill>
+                  <a:schemeClr val="accent1"/>
+                </a:solidFill>
+              </a14:hiddenFill>
+            </a:ext>
+            <a:ext uri="{91240B29-F687-4F45-9708-019B960494DF}">
+              <a14:hiddenLine xmlns:a14="http://schemas.microsoft.com/office/drawing/2010/main" w="9525">
+                <a:solidFill>
+                  <a:schemeClr val="tx1"/>
+                </a:solidFill>
+                <a:miter lim="800000"/>
+                <a:headEnd/>
+                <a:tailEnd/>
+              </a14:hiddenLine>
+            </a:ext>
+            <a:ext uri="{AF507438-7753-43E0-B8FC-AC1667EBCBE1}">
+              <a14:hiddenEffects xmlns:a14="http://schemas.microsoft.com/office/drawing/2010/main">
+                <a:effectLst>
+                  <a:outerShdw dist="35921" dir="2700000" algn="ctr" rotWithShape="0">
+                    <a:schemeClr val="bg2"/>
+                  </a:outerShdw>
+                </a:effectLst>
+              </a14:hiddenEffects>
+            </a:ext>
+          </a:extLst>
+        </p:spPr>
+        <p:txBody>
+          <a:bodyPr vert="horz" wrap="none" lIns="91440" tIns="45720" rIns="91440" bIns="45720" numCol="1" anchor="ctr" anchorCtr="0" compatLnSpc="1">
+            <a:prstTxWarp prst="textNoShape">
+              <a:avLst/>
+            </a:prstTxWarp>
+            <a:spAutoFit/>
+          </a:bodyPr>
+          <a:lstStyle/>
+          <a:p>
+            <a:endParaRPr lang="pt-BR"/>
+          </a:p>
+        </p:txBody>
+      </p:sp>
+      <p:pic>
+        <p:nvPicPr>
+          <p:cNvPr id="40" name="Imagem 39" descr="Logotipo&#10;&#10;O conteúdo gerado por IA pode estar incorreto.">
+            <a:extLst>
+              <a:ext uri="{FF2B5EF4-FFF2-40B4-BE49-F238E27FC236}">
+                <a16:creationId xmlns:a16="http://schemas.microsoft.com/office/drawing/2014/main" id="{8552B86D-A995-EDF7-59A3-BEB4F67C88E0}"/>
+              </a:ext>
+            </a:extLst>
+          </p:cNvPr>
+          <p:cNvPicPr>
+            <a:picLocks noChangeAspect="1"/>
+          </p:cNvPicPr>
+          <p:nvPr/>
+        </p:nvPicPr>
+        <p:blipFill>
+          <a:blip r:embed="rId2">
+            <a:extLst>
+              <a:ext uri="{28A0092B-C50C-407E-A947-70E740481C1C}">
+                <a14:useLocalDpi xmlns:a14="http://schemas.microsoft.com/office/drawing/2010/main" val="0"/>
+              </a:ext>
+            </a:extLst>
+          </a:blip>
+          <a:stretch>
+            <a:fillRect/>
+          </a:stretch>
+        </p:blipFill>
+        <p:spPr>
+          <a:xfrm>
+            <a:off x="-151400" y="-496476"/>
+            <a:ext cx="2342499" cy="1801131"/>
+          </a:xfrm>
+          <a:prstGeom prst="rect">
+            <a:avLst/>
+          </a:prstGeom>
+        </p:spPr>
+      </p:pic>
+      <p:sp>
+        <p:nvSpPr>
+          <p:cNvPr id="46" name="Retângulo: Cantos Arredondados 45">
+            <a:extLst>
+              <a:ext uri="{FF2B5EF4-FFF2-40B4-BE49-F238E27FC236}">
+                <a16:creationId xmlns:a16="http://schemas.microsoft.com/office/drawing/2014/main" id="{F0C0851D-FD33-9335-CB95-D188E50A92BB}"/>
+              </a:ext>
+            </a:extLst>
+          </p:cNvPr>
+          <p:cNvSpPr/>
+          <p:nvPr/>
+        </p:nvSpPr>
+        <p:spPr>
+          <a:xfrm>
+            <a:off x="1699975" y="227802"/>
+            <a:ext cx="3205399" cy="309954"/>
+          </a:xfrm>
+          <a:prstGeom prst="roundRect">
+            <a:avLst>
+              <a:gd name="adj" fmla="val 26287"/>
+            </a:avLst>
+          </a:prstGeom>
+          <a:solidFill>
+            <a:srgbClr val="010A52"/>
+          </a:solidFill>
+          <a:ln>
+            <a:noFill/>
+          </a:ln>
+        </p:spPr>
+        <p:style>
+          <a:lnRef idx="2">
+            <a:schemeClr val="accent1">
+              <a:shade val="15000"/>
+            </a:schemeClr>
+          </a:lnRef>
+          <a:fillRef idx="1">
+            <a:schemeClr val="accent1"/>
+          </a:fillRef>
+          <a:effectRef idx="0">
+            <a:schemeClr val="accent1"/>
+          </a:effectRef>
+          <a:fontRef idx="minor">
+            <a:schemeClr val="lt1"/>
+          </a:fontRef>
+        </p:style>
+        <p:txBody>
+          <a:bodyPr rtlCol="0" anchor="ctr"/>
+          <a:lstStyle/>
+          <a:p>
+            <a:pPr algn="ctr"/>
+            <a:r>
+              <a:rPr lang="pt-BR" sz="1400" dirty="0" err="1"/>
+              <a:t>Analytics</a:t>
+            </a:r>
+            <a:r>
+              <a:rPr lang="pt-BR" sz="1400" dirty="0"/>
+              <a:t> – Evolução e tendências</a:t>
+            </a:r>
+          </a:p>
+        </p:txBody>
+      </p:sp>
+      <p:sp>
+        <p:nvSpPr>
+          <p:cNvPr id="56" name="Retângulo: Cantos Arredondados 55">
+            <a:extLst>
+              <a:ext uri="{FF2B5EF4-FFF2-40B4-BE49-F238E27FC236}">
+                <a16:creationId xmlns:a16="http://schemas.microsoft.com/office/drawing/2014/main" id="{2C3FA40E-9CB1-71CD-9836-822ACBEBE4EA}"/>
+              </a:ext>
+            </a:extLst>
+          </p:cNvPr>
+          <p:cNvSpPr/>
+          <p:nvPr/>
+        </p:nvSpPr>
+        <p:spPr>
+          <a:xfrm>
+            <a:off x="3008184" y="970568"/>
+            <a:ext cx="347291" cy="374036"/>
+          </a:xfrm>
+          <a:prstGeom prst="roundRect">
+            <a:avLst>
+              <a:gd name="adj" fmla="val 35127"/>
+            </a:avLst>
+          </a:prstGeom>
+          <a:solidFill>
+            <a:srgbClr val="2F3A5F">
+              <a:alpha val="18000"/>
+            </a:srgbClr>
+          </a:solidFill>
+          <a:ln>
+            <a:noFill/>
+          </a:ln>
+        </p:spPr>
+        <p:style>
+          <a:lnRef idx="2">
+            <a:schemeClr val="accent1">
+              <a:shade val="15000"/>
+            </a:schemeClr>
+          </a:lnRef>
+          <a:fillRef idx="1">
+            <a:schemeClr val="accent1"/>
+          </a:fillRef>
+          <a:effectRef idx="0">
+            <a:schemeClr val="accent1"/>
+          </a:effectRef>
+          <a:fontRef idx="minor">
+            <a:schemeClr val="lt1"/>
+          </a:fontRef>
+        </p:style>
+        <p:txBody>
+          <a:bodyPr rtlCol="0" anchor="ctr"/>
+          <a:lstStyle/>
+          <a:p>
+            <a:pPr algn="ctr"/>
+            <a:endParaRPr lang="pt-BR" dirty="0"/>
+          </a:p>
+        </p:txBody>
+      </p:sp>
+      <p:sp>
+        <p:nvSpPr>
+          <p:cNvPr id="57" name="Retângulo: Cantos Arredondados 56">
+            <a:extLst>
+              <a:ext uri="{FF2B5EF4-FFF2-40B4-BE49-F238E27FC236}">
+                <a16:creationId xmlns:a16="http://schemas.microsoft.com/office/drawing/2014/main" id="{9E4B0F3A-E227-1D9A-01BB-EF7B2FF0CE2A}"/>
+              </a:ext>
+            </a:extLst>
+          </p:cNvPr>
+          <p:cNvSpPr/>
+          <p:nvPr/>
+        </p:nvSpPr>
+        <p:spPr>
+          <a:xfrm>
+            <a:off x="5762625" y="973108"/>
+            <a:ext cx="409575" cy="410669"/>
+          </a:xfrm>
+          <a:prstGeom prst="roundRect">
+            <a:avLst>
+              <a:gd name="adj" fmla="val 35127"/>
+            </a:avLst>
+          </a:prstGeom>
+          <a:solidFill>
+            <a:srgbClr val="2F3A5F">
+              <a:alpha val="18000"/>
+            </a:srgbClr>
+          </a:solidFill>
+          <a:ln>
+            <a:noFill/>
+          </a:ln>
+        </p:spPr>
+        <p:style>
+          <a:lnRef idx="2">
+            <a:schemeClr val="accent1">
+              <a:shade val="15000"/>
+            </a:schemeClr>
+          </a:lnRef>
+          <a:fillRef idx="1">
+            <a:schemeClr val="accent1"/>
+          </a:fillRef>
+          <a:effectRef idx="0">
+            <a:schemeClr val="accent1"/>
+          </a:effectRef>
+          <a:fontRef idx="minor">
+            <a:schemeClr val="lt1"/>
+          </a:fontRef>
+        </p:style>
+        <p:txBody>
+          <a:bodyPr rtlCol="0" anchor="ctr"/>
+          <a:lstStyle/>
+          <a:p>
+            <a:pPr algn="ctr"/>
+            <a:endParaRPr lang="pt-BR"/>
+          </a:p>
+        </p:txBody>
+      </p:sp>
+      <p:pic>
+        <p:nvPicPr>
+          <p:cNvPr id="53" name="Imagem 52" descr="Ícone&#10;&#10;O conteúdo gerado por IA pode estar incorreto.">
+            <a:extLst>
+              <a:ext uri="{FF2B5EF4-FFF2-40B4-BE49-F238E27FC236}">
+                <a16:creationId xmlns:a16="http://schemas.microsoft.com/office/drawing/2014/main" id="{950CF013-4988-B7C5-7BF7-05A356BAA32D}"/>
+              </a:ext>
+            </a:extLst>
+          </p:cNvPr>
+          <p:cNvPicPr>
+            <a:picLocks noChangeAspect="1"/>
+          </p:cNvPicPr>
+          <p:nvPr/>
+        </p:nvPicPr>
+        <p:blipFill>
+          <a:blip r:embed="rId3">
+            <a:extLst>
+              <a:ext uri="{28A0092B-C50C-407E-A947-70E740481C1C}">
+                <a14:useLocalDpi xmlns:a14="http://schemas.microsoft.com/office/drawing/2010/main" val="0"/>
+              </a:ext>
+            </a:extLst>
+          </a:blip>
+          <a:stretch>
+            <a:fillRect/>
+          </a:stretch>
+        </p:blipFill>
+        <p:spPr>
+          <a:xfrm>
+            <a:off x="3040137" y="999786"/>
+            <a:ext cx="291413" cy="291413"/>
+          </a:xfrm>
+          <a:prstGeom prst="rect">
+            <a:avLst/>
+          </a:prstGeom>
+        </p:spPr>
+      </p:pic>
+      <p:sp>
+        <p:nvSpPr>
+          <p:cNvPr id="58" name="Retângulo: Cantos Arredondados 57">
+            <a:extLst>
+              <a:ext uri="{FF2B5EF4-FFF2-40B4-BE49-F238E27FC236}">
+                <a16:creationId xmlns:a16="http://schemas.microsoft.com/office/drawing/2014/main" id="{EFC762EB-372D-47AD-5254-D8EA4DAD2395}"/>
+              </a:ext>
+            </a:extLst>
+          </p:cNvPr>
+          <p:cNvSpPr/>
+          <p:nvPr/>
+        </p:nvSpPr>
+        <p:spPr>
+          <a:xfrm>
+            <a:off x="11418889" y="981926"/>
+            <a:ext cx="306401" cy="346436"/>
+          </a:xfrm>
+          <a:prstGeom prst="roundRect">
+            <a:avLst>
+              <a:gd name="adj" fmla="val 35127"/>
+            </a:avLst>
+          </a:prstGeom>
+          <a:solidFill>
+            <a:srgbClr val="2F3A5F">
+              <a:alpha val="18000"/>
+            </a:srgbClr>
+          </a:solidFill>
+          <a:ln>
+            <a:noFill/>
+          </a:ln>
+        </p:spPr>
+        <p:style>
+          <a:lnRef idx="2">
+            <a:schemeClr val="accent1">
+              <a:shade val="15000"/>
+            </a:schemeClr>
+          </a:lnRef>
+          <a:fillRef idx="1">
+            <a:schemeClr val="accent1"/>
+          </a:fillRef>
+          <a:effectRef idx="0">
+            <a:schemeClr val="accent1"/>
+          </a:effectRef>
+          <a:fontRef idx="minor">
+            <a:schemeClr val="lt1"/>
+          </a:fontRef>
+        </p:style>
+        <p:txBody>
+          <a:bodyPr rtlCol="0" anchor="ctr"/>
+          <a:lstStyle/>
+          <a:p>
+            <a:pPr algn="ctr"/>
+            <a:endParaRPr lang="pt-BR"/>
+          </a:p>
+        </p:txBody>
+      </p:sp>
+      <p:pic>
+        <p:nvPicPr>
+          <p:cNvPr id="13" name="Imagem 12" descr="Ícone&#10;&#10;O conteúdo gerado por IA pode estar incorreto.">
+            <a:extLst>
+              <a:ext uri="{FF2B5EF4-FFF2-40B4-BE49-F238E27FC236}">
+                <a16:creationId xmlns:a16="http://schemas.microsoft.com/office/drawing/2014/main" id="{A85AB332-EA23-6336-D1A9-41735C913348}"/>
+              </a:ext>
+            </a:extLst>
+          </p:cNvPr>
+          <p:cNvPicPr>
+            <a:picLocks noChangeAspect="1"/>
+          </p:cNvPicPr>
+          <p:nvPr/>
+        </p:nvPicPr>
+        <p:blipFill>
+          <a:blip r:embed="rId4">
+            <a:extLst>
+              <a:ext uri="{28A0092B-C50C-407E-A947-70E740481C1C}">
+                <a14:useLocalDpi xmlns:a14="http://schemas.microsoft.com/office/drawing/2010/main" val="0"/>
+              </a:ext>
+            </a:extLst>
+          </a:blip>
+          <a:stretch>
+            <a:fillRect/>
+          </a:stretch>
+        </p:blipFill>
+        <p:spPr>
+          <a:xfrm>
+            <a:off x="88190" y="2818496"/>
+            <a:ext cx="351582" cy="351582"/>
+          </a:xfrm>
+          <a:prstGeom prst="rect">
+            <a:avLst/>
+          </a:prstGeom>
+        </p:spPr>
+      </p:pic>
+      <p:pic>
+        <p:nvPicPr>
+          <p:cNvPr id="25" name="Imagem 24" descr="Uma imagem contendo Ícone&#10;&#10;O conteúdo gerado por IA pode estar incorreto.">
+            <a:extLst>
+              <a:ext uri="{FF2B5EF4-FFF2-40B4-BE49-F238E27FC236}">
+                <a16:creationId xmlns:a16="http://schemas.microsoft.com/office/drawing/2014/main" id="{AD43D0B8-808C-878C-B969-BEFF564089D5}"/>
+              </a:ext>
+            </a:extLst>
+          </p:cNvPr>
+          <p:cNvPicPr>
+            <a:picLocks noChangeAspect="1"/>
+          </p:cNvPicPr>
+          <p:nvPr/>
+        </p:nvPicPr>
+        <p:blipFill>
+          <a:blip r:embed="rId5">
+            <a:extLst>
+              <a:ext uri="{28A0092B-C50C-407E-A947-70E740481C1C}">
+                <a14:useLocalDpi xmlns:a14="http://schemas.microsoft.com/office/drawing/2010/main" val="0"/>
+              </a:ext>
+            </a:extLst>
+          </a:blip>
+          <a:stretch>
+            <a:fillRect/>
+          </a:stretch>
+        </p:blipFill>
+        <p:spPr>
+          <a:xfrm flipH="1">
+            <a:off x="106392" y="1383777"/>
+            <a:ext cx="316754" cy="316754"/>
+          </a:xfrm>
+          <a:prstGeom prst="rect">
+            <a:avLst/>
+          </a:prstGeom>
+        </p:spPr>
+      </p:pic>
+      <p:pic>
+        <p:nvPicPr>
+          <p:cNvPr id="2" name="Imagem 1" descr="Ícone&#10;&#10;O conteúdo gerado por IA pode estar incorreto.">
+            <a:extLst>
+              <a:ext uri="{FF2B5EF4-FFF2-40B4-BE49-F238E27FC236}">
+                <a16:creationId xmlns:a16="http://schemas.microsoft.com/office/drawing/2014/main" id="{C63E402E-07E4-255C-3F1A-E943E8E8E8BC}"/>
+              </a:ext>
+            </a:extLst>
+          </p:cNvPr>
+          <p:cNvPicPr>
+            <a:picLocks noChangeAspect="1"/>
+          </p:cNvPicPr>
+          <p:nvPr/>
+        </p:nvPicPr>
+        <p:blipFill>
+          <a:blip r:embed="rId6">
+            <a:extLst>
+              <a:ext uri="{28A0092B-C50C-407E-A947-70E740481C1C}">
+                <a14:useLocalDpi xmlns:a14="http://schemas.microsoft.com/office/drawing/2010/main" val="0"/>
+              </a:ext>
+            </a:extLst>
+          </a:blip>
+          <a:stretch>
+            <a:fillRect/>
+          </a:stretch>
+        </p:blipFill>
+        <p:spPr>
+          <a:xfrm>
+            <a:off x="89891" y="2011480"/>
+            <a:ext cx="349882" cy="349882"/>
+          </a:xfrm>
+          <a:prstGeom prst="rect">
+            <a:avLst/>
+          </a:prstGeom>
+        </p:spPr>
+      </p:pic>
+      <p:sp>
+        <p:nvSpPr>
+          <p:cNvPr id="14" name="Retângulo: Cantos Arredondados 13">
+            <a:extLst>
+              <a:ext uri="{FF2B5EF4-FFF2-40B4-BE49-F238E27FC236}">
+                <a16:creationId xmlns:a16="http://schemas.microsoft.com/office/drawing/2014/main" id="{6A744BAB-5441-2972-7047-17F824A68ECF}"/>
+              </a:ext>
+            </a:extLst>
+          </p:cNvPr>
+          <p:cNvSpPr/>
+          <p:nvPr/>
+        </p:nvSpPr>
+        <p:spPr>
+          <a:xfrm>
+            <a:off x="37037" y="4166760"/>
+            <a:ext cx="446056" cy="453228"/>
+          </a:xfrm>
+          <a:prstGeom prst="roundRect">
+            <a:avLst/>
+          </a:prstGeom>
+          <a:solidFill>
+            <a:schemeClr val="bg1"/>
+          </a:solidFill>
+          <a:ln>
+            <a:noFill/>
+          </a:ln>
+          <a:effectLst/>
+        </p:spPr>
+        <p:style>
+          <a:lnRef idx="2">
+            <a:schemeClr val="accent1">
+              <a:shade val="15000"/>
+            </a:schemeClr>
+          </a:lnRef>
+          <a:fillRef idx="1">
+            <a:schemeClr val="accent1"/>
+          </a:fillRef>
+          <a:effectRef idx="0">
+            <a:schemeClr val="accent1"/>
+          </a:effectRef>
+          <a:fontRef idx="minor">
+            <a:schemeClr val="lt1"/>
+          </a:fontRef>
+        </p:style>
+        <p:txBody>
+          <a:bodyPr rtlCol="0" anchor="ctr"/>
+          <a:lstStyle/>
+          <a:p>
+            <a:pPr algn="ctr"/>
+            <a:endParaRPr lang="pt-BR"/>
+          </a:p>
+        </p:txBody>
+      </p:sp>
+      <p:sp>
+        <p:nvSpPr>
+          <p:cNvPr id="15" name="Retângulo: Cantos Arredondados 14">
+            <a:extLst>
+              <a:ext uri="{FF2B5EF4-FFF2-40B4-BE49-F238E27FC236}">
+                <a16:creationId xmlns:a16="http://schemas.microsoft.com/office/drawing/2014/main" id="{74AAAE5A-AE9D-A6FF-C723-9C4186761A63}"/>
+              </a:ext>
+            </a:extLst>
+          </p:cNvPr>
+          <p:cNvSpPr/>
+          <p:nvPr/>
+        </p:nvSpPr>
+        <p:spPr>
+          <a:xfrm>
+            <a:off x="6569276" y="956414"/>
+            <a:ext cx="2387600" cy="847474"/>
+          </a:xfrm>
+          <a:prstGeom prst="roundRect">
+            <a:avLst>
+              <a:gd name="adj" fmla="val 7416"/>
+            </a:avLst>
+          </a:prstGeom>
+          <a:solidFill>
+            <a:schemeClr val="bg1"/>
+          </a:solidFill>
+          <a:ln>
+            <a:noFill/>
+          </a:ln>
+          <a:effectLst>
+            <a:outerShdw blurRad="101600" dist="38100" dir="5400000" algn="t" rotWithShape="0">
+              <a:prstClr val="black">
+                <a:alpha val="20000"/>
+              </a:prstClr>
+            </a:outerShdw>
+          </a:effectLst>
+        </p:spPr>
+        <p:style>
+          <a:lnRef idx="2">
+            <a:schemeClr val="accent1">
+              <a:shade val="15000"/>
+            </a:schemeClr>
+          </a:lnRef>
+          <a:fillRef idx="1">
+            <a:schemeClr val="accent1"/>
+          </a:fillRef>
+          <a:effectRef idx="0">
+            <a:schemeClr val="accent1"/>
+          </a:effectRef>
+          <a:fontRef idx="minor">
+            <a:schemeClr val="lt1"/>
+          </a:fontRef>
+        </p:style>
+        <p:txBody>
+          <a:bodyPr rtlCol="0" anchor="ctr"/>
+          <a:lstStyle/>
+          <a:p>
+            <a:pPr algn="ctr"/>
+            <a:endParaRPr lang="pt-BR"/>
+          </a:p>
+        </p:txBody>
+      </p:sp>
+      <p:sp>
+        <p:nvSpPr>
+          <p:cNvPr id="17" name="Retângulo: Cantos Arredondados 16">
+            <a:extLst>
+              <a:ext uri="{FF2B5EF4-FFF2-40B4-BE49-F238E27FC236}">
+                <a16:creationId xmlns:a16="http://schemas.microsoft.com/office/drawing/2014/main" id="{381F28CD-9C02-F84D-0065-AB825DA6ABDA}"/>
+              </a:ext>
+            </a:extLst>
+          </p:cNvPr>
+          <p:cNvSpPr/>
+          <p:nvPr/>
+        </p:nvSpPr>
+        <p:spPr>
+          <a:xfrm>
+            <a:off x="8595360" y="980374"/>
+            <a:ext cx="322119" cy="342633"/>
+          </a:xfrm>
+          <a:prstGeom prst="roundRect">
+            <a:avLst>
+              <a:gd name="adj" fmla="val 35127"/>
+            </a:avLst>
+          </a:prstGeom>
+          <a:solidFill>
+            <a:srgbClr val="2F3A5F">
+              <a:alpha val="18000"/>
+            </a:srgbClr>
+          </a:solidFill>
+          <a:ln>
+            <a:noFill/>
+          </a:ln>
+        </p:spPr>
+        <p:style>
+          <a:lnRef idx="2">
+            <a:schemeClr val="accent1">
+              <a:shade val="15000"/>
+            </a:schemeClr>
+          </a:lnRef>
+          <a:fillRef idx="1">
+            <a:schemeClr val="accent1"/>
+          </a:fillRef>
+          <a:effectRef idx="0">
+            <a:schemeClr val="accent1"/>
+          </a:effectRef>
+          <a:fontRef idx="minor">
+            <a:schemeClr val="lt1"/>
+          </a:fontRef>
+        </p:style>
+        <p:txBody>
+          <a:bodyPr rtlCol="0" anchor="ctr"/>
+          <a:lstStyle/>
+          <a:p>
+            <a:pPr algn="ctr"/>
+            <a:endParaRPr lang="pt-BR"/>
+          </a:p>
+        </p:txBody>
+      </p:sp>
+      <p:pic>
+        <p:nvPicPr>
+          <p:cNvPr id="9" name="Imagem 8">
+            <a:extLst>
+              <a:ext uri="{FF2B5EF4-FFF2-40B4-BE49-F238E27FC236}">
+                <a16:creationId xmlns:a16="http://schemas.microsoft.com/office/drawing/2014/main" id="{B584C077-A436-F2E7-4064-0630C1C30F3B}"/>
+              </a:ext>
+            </a:extLst>
+          </p:cNvPr>
+          <p:cNvPicPr>
+            <a:picLocks noChangeAspect="1"/>
+          </p:cNvPicPr>
+          <p:nvPr/>
+        </p:nvPicPr>
+        <p:blipFill>
+          <a:blip r:embed="rId7">
+            <a:extLst>
+              <a:ext uri="{28A0092B-C50C-407E-A947-70E740481C1C}">
+                <a14:useLocalDpi xmlns:a14="http://schemas.microsoft.com/office/drawing/2010/main" val="0"/>
+              </a:ext>
+            </a:extLst>
+          </a:blip>
+          <a:stretch>
+            <a:fillRect/>
+          </a:stretch>
+        </p:blipFill>
+        <p:spPr>
+          <a:xfrm>
+            <a:off x="5807887" y="1003957"/>
+            <a:ext cx="319050" cy="319050"/>
+          </a:xfrm>
+          <a:prstGeom prst="rect">
+            <a:avLst/>
+          </a:prstGeom>
+        </p:spPr>
+      </p:pic>
+      <p:pic>
+        <p:nvPicPr>
+          <p:cNvPr id="18" name="Imagem 17">
+            <a:extLst>
+              <a:ext uri="{FF2B5EF4-FFF2-40B4-BE49-F238E27FC236}">
+                <a16:creationId xmlns:a16="http://schemas.microsoft.com/office/drawing/2014/main" id="{E70D398A-BB60-2EE5-0230-284976BECEA5}"/>
+              </a:ext>
+            </a:extLst>
+          </p:cNvPr>
+          <p:cNvPicPr>
+            <a:picLocks noChangeAspect="1"/>
+          </p:cNvPicPr>
+          <p:nvPr/>
+        </p:nvPicPr>
+        <p:blipFill>
+          <a:blip r:embed="rId8">
+            <a:extLst>
+              <a:ext uri="{28A0092B-C50C-407E-A947-70E740481C1C}">
+                <a14:useLocalDpi xmlns:a14="http://schemas.microsoft.com/office/drawing/2010/main" val="0"/>
+              </a:ext>
+            </a:extLst>
+          </a:blip>
+          <a:stretch>
+            <a:fillRect/>
+          </a:stretch>
+        </p:blipFill>
+        <p:spPr>
+          <a:xfrm>
+            <a:off x="8620355" y="1009428"/>
+            <a:ext cx="272128" cy="272128"/>
+          </a:xfrm>
+          <a:prstGeom prst="rect">
+            <a:avLst/>
+          </a:prstGeom>
+        </p:spPr>
+      </p:pic>
+      <p:pic>
+        <p:nvPicPr>
+          <p:cNvPr id="20" name="Imagem 19">
+            <a:extLst>
+              <a:ext uri="{FF2B5EF4-FFF2-40B4-BE49-F238E27FC236}">
+                <a16:creationId xmlns:a16="http://schemas.microsoft.com/office/drawing/2014/main" id="{EE47AA3D-06B8-12F8-BC35-86F908E5E70D}"/>
+              </a:ext>
+            </a:extLst>
+          </p:cNvPr>
+          <p:cNvPicPr>
+            <a:picLocks noChangeAspect="1"/>
+          </p:cNvPicPr>
+          <p:nvPr/>
+        </p:nvPicPr>
+        <p:blipFill>
+          <a:blip r:embed="rId9">
+            <a:extLst>
+              <a:ext uri="{28A0092B-C50C-407E-A947-70E740481C1C}">
+                <a14:useLocalDpi xmlns:a14="http://schemas.microsoft.com/office/drawing/2010/main" val="0"/>
+              </a:ext>
+            </a:extLst>
+          </a:blip>
+          <a:stretch>
+            <a:fillRect/>
+          </a:stretch>
+        </p:blipFill>
+        <p:spPr>
+          <a:xfrm>
+            <a:off x="11418889" y="999785"/>
+            <a:ext cx="306401" cy="299621"/>
+          </a:xfrm>
+          <a:prstGeom prst="rect">
+            <a:avLst/>
+          </a:prstGeom>
+        </p:spPr>
+      </p:pic>
+      <p:pic>
+        <p:nvPicPr>
+          <p:cNvPr id="27" name="Imagem 26">
+            <a:extLst>
+              <a:ext uri="{FF2B5EF4-FFF2-40B4-BE49-F238E27FC236}">
+                <a16:creationId xmlns:a16="http://schemas.microsoft.com/office/drawing/2014/main" id="{385CBBB1-3410-5B2A-DC4E-2EAC4D29F4E0}"/>
+              </a:ext>
+            </a:extLst>
+          </p:cNvPr>
+          <p:cNvPicPr>
+            <a:picLocks noChangeAspect="1"/>
+          </p:cNvPicPr>
+          <p:nvPr/>
+        </p:nvPicPr>
+        <p:blipFill>
+          <a:blip r:embed="rId10">
+            <a:extLst>
+              <a:ext uri="{28A0092B-C50C-407E-A947-70E740481C1C}">
+                <a14:useLocalDpi xmlns:a14="http://schemas.microsoft.com/office/drawing/2010/main" val="0"/>
+              </a:ext>
+            </a:extLst>
+          </a:blip>
+          <a:stretch>
+            <a:fillRect/>
+          </a:stretch>
+        </p:blipFill>
+        <p:spPr>
+          <a:xfrm>
+            <a:off x="73061" y="4194810"/>
+            <a:ext cx="350085" cy="350085"/>
+          </a:xfrm>
+          <a:prstGeom prst="rect">
+            <a:avLst/>
+          </a:prstGeom>
+        </p:spPr>
+      </p:pic>
+      <p:pic>
+        <p:nvPicPr>
+          <p:cNvPr id="28" name="Imagem 27" descr="Logotipo, Ícone&#10;&#10;O conteúdo gerado por IA pode estar incorreto.">
+            <a:extLst>
+              <a:ext uri="{FF2B5EF4-FFF2-40B4-BE49-F238E27FC236}">
+                <a16:creationId xmlns:a16="http://schemas.microsoft.com/office/drawing/2014/main" id="{F186C68F-02D8-4275-BB76-D7433A9961F1}"/>
+              </a:ext>
+            </a:extLst>
+          </p:cNvPr>
+          <p:cNvPicPr>
+            <a:picLocks noChangeAspect="1"/>
+          </p:cNvPicPr>
+          <p:nvPr/>
+        </p:nvPicPr>
+        <p:blipFill>
+          <a:blip r:embed="rId11">
+            <a:extLst>
+              <a:ext uri="{28A0092B-C50C-407E-A947-70E740481C1C}">
+                <a14:useLocalDpi xmlns:a14="http://schemas.microsoft.com/office/drawing/2010/main" val="0"/>
+              </a:ext>
+            </a:extLst>
+          </a:blip>
+          <a:stretch>
+            <a:fillRect/>
+          </a:stretch>
+        </p:blipFill>
+        <p:spPr>
+          <a:xfrm>
+            <a:off x="88190" y="3505929"/>
+            <a:ext cx="351582" cy="351582"/>
+          </a:xfrm>
+          <a:prstGeom prst="rect">
+            <a:avLst/>
+          </a:prstGeom>
+        </p:spPr>
+      </p:pic>
+      <p:sp>
+        <p:nvSpPr>
+          <p:cNvPr id="4" name="Retângulo: Cantos Arredondados 3">
+            <a:extLst>
+              <a:ext uri="{FF2B5EF4-FFF2-40B4-BE49-F238E27FC236}">
+                <a16:creationId xmlns:a16="http://schemas.microsoft.com/office/drawing/2014/main" id="{87978006-0E6D-F0DD-EE48-22EA0BD19B5F}"/>
+              </a:ext>
+            </a:extLst>
+          </p:cNvPr>
+          <p:cNvSpPr/>
+          <p:nvPr/>
+        </p:nvSpPr>
+        <p:spPr>
+          <a:xfrm>
+            <a:off x="9088315" y="1933872"/>
+            <a:ext cx="2698742" cy="2611022"/>
+          </a:xfrm>
+          <a:prstGeom prst="roundRect">
+            <a:avLst>
+              <a:gd name="adj" fmla="val 5297"/>
+            </a:avLst>
+          </a:prstGeom>
+          <a:solidFill>
+            <a:schemeClr val="bg1"/>
+          </a:solidFill>
+          <a:ln>
+            <a:noFill/>
+          </a:ln>
+          <a:effectLst>
+            <a:outerShdw blurRad="101600" dist="38100" dir="5400000" algn="t" rotWithShape="0">
+              <a:prstClr val="black">
+                <a:alpha val="20000"/>
+              </a:prstClr>
+            </a:outerShdw>
+          </a:effectLst>
+        </p:spPr>
+        <p:style>
+          <a:lnRef idx="2">
+            <a:schemeClr val="accent1">
+              <a:shade val="15000"/>
+            </a:schemeClr>
+          </a:lnRef>
+          <a:fillRef idx="1">
+            <a:schemeClr val="accent1"/>
+          </a:fillRef>
+          <a:effectRef idx="0">
+            <a:schemeClr val="accent1"/>
+          </a:effectRef>
+          <a:fontRef idx="minor">
+            <a:schemeClr val="lt1"/>
+          </a:fontRef>
+        </p:style>
+        <p:txBody>
+          <a:bodyPr rtlCol="0" anchor="ctr"/>
+          <a:lstStyle/>
+          <a:p>
+            <a:pPr algn="ctr"/>
+            <a:endParaRPr lang="pt-BR"/>
+          </a:p>
+        </p:txBody>
+      </p:sp>
+      <p:sp>
+        <p:nvSpPr>
+          <p:cNvPr id="3" name="Retângulo: Cantos Arredondados 2">
+            <a:extLst>
+              <a:ext uri="{FF2B5EF4-FFF2-40B4-BE49-F238E27FC236}">
+                <a16:creationId xmlns:a16="http://schemas.microsoft.com/office/drawing/2014/main" id="{24A7A8FD-64AD-A9D6-6A7E-8D550A96EEE1}"/>
+              </a:ext>
+            </a:extLst>
+          </p:cNvPr>
+          <p:cNvSpPr/>
+          <p:nvPr/>
+        </p:nvSpPr>
+        <p:spPr>
+          <a:xfrm>
+            <a:off x="6418103" y="1952516"/>
+            <a:ext cx="2568242" cy="2611022"/>
+          </a:xfrm>
+          <a:prstGeom prst="roundRect">
+            <a:avLst>
+              <a:gd name="adj" fmla="val 5297"/>
+            </a:avLst>
+          </a:prstGeom>
+          <a:solidFill>
+            <a:schemeClr val="bg1"/>
+          </a:solidFill>
+          <a:ln>
+            <a:noFill/>
+          </a:ln>
+          <a:effectLst>
+            <a:outerShdw blurRad="101600" dist="38100" dir="5400000" algn="t" rotWithShape="0">
+              <a:prstClr val="black">
+                <a:alpha val="20000"/>
+              </a:prstClr>
+            </a:outerShdw>
+          </a:effectLst>
+        </p:spPr>
+        <p:style>
+          <a:lnRef idx="2">
+            <a:schemeClr val="accent1">
+              <a:shade val="15000"/>
+            </a:schemeClr>
+          </a:lnRef>
+          <a:fillRef idx="1">
+            <a:schemeClr val="accent1"/>
+          </a:fillRef>
+          <a:effectRef idx="0">
+            <a:schemeClr val="accent1"/>
+          </a:effectRef>
+          <a:fontRef idx="minor">
+            <a:schemeClr val="lt1"/>
+          </a:fontRef>
+        </p:style>
+        <p:txBody>
+          <a:bodyPr rtlCol="0" anchor="ctr"/>
+          <a:lstStyle/>
+          <a:p>
+            <a:pPr algn="ctr"/>
+            <a:endParaRPr lang="pt-BR"/>
+          </a:p>
+        </p:txBody>
+      </p:sp>
+    </p:spTree>
+    <p:extLst>
+      <p:ext uri="{BB962C8B-B14F-4D97-AF65-F5344CB8AC3E}">
+        <p14:creationId xmlns:p14="http://schemas.microsoft.com/office/powerpoint/2010/main" val="1361002499"/>
       </p:ext>
     </p:extLst>
   </p:cSld>

</xml_diff>

<commit_message>
bronze  e criacao de tabelas na silver refatorada
</commit_message>
<xml_diff>
--- a/dashboards/Mockup dashboard (em construção).pptx
+++ b/dashboards/Mockup dashboard (em construção).pptx
@@ -5,10 +5,10 @@
     <p:sldMasterId id="2147483648" r:id="rId1"/>
   </p:sldMasterIdLst>
   <p:sldIdLst>
-    <p:sldId id="258" r:id="rId2"/>
-    <p:sldId id="259" r:id="rId3"/>
-    <p:sldId id="260" r:id="rId4"/>
-    <p:sldId id="261" r:id="rId5"/>
+    <p:sldId id="265" r:id="rId2"/>
+    <p:sldId id="258" r:id="rId3"/>
+    <p:sldId id="259" r:id="rId4"/>
+    <p:sldId id="260" r:id="rId5"/>
     <p:sldId id="262" r:id="rId6"/>
   </p:sldIdLst>
   <p:sldSz cx="12192000" cy="6858000"/>
@@ -3314,6 +3314,1075 @@
 </file>
 
 <file path=ppt/slides/slide1.xml><?xml version="1.0" encoding="utf-8"?>
+<p:sld xmlns:a="http://schemas.openxmlformats.org/drawingml/2006/main" xmlns:r="http://schemas.openxmlformats.org/officeDocument/2006/relationships" xmlns:p="http://schemas.openxmlformats.org/presentationml/2006/main">
+  <p:cSld>
+    <p:bg>
+      <p:bgPr>
+        <a:gradFill>
+          <a:gsLst>
+            <a:gs pos="0">
+              <a:srgbClr val="F5F7FA"/>
+            </a:gs>
+            <a:gs pos="23000">
+              <a:srgbClr val="F5F7FA"/>
+            </a:gs>
+            <a:gs pos="57000">
+              <a:schemeClr val="bg1">
+                <a:lumMod val="95000"/>
+              </a:schemeClr>
+            </a:gs>
+            <a:gs pos="100000">
+              <a:schemeClr val="bg1"/>
+            </a:gs>
+          </a:gsLst>
+          <a:lin ang="5400000" scaled="1"/>
+        </a:gradFill>
+        <a:effectLst/>
+      </p:bgPr>
+    </p:bg>
+    <p:spTree>
+      <p:nvGrpSpPr>
+        <p:cNvPr id="1" name=""/>
+        <p:cNvGrpSpPr/>
+        <p:nvPr/>
+      </p:nvGrpSpPr>
+      <p:grpSpPr>
+        <a:xfrm>
+          <a:off x="0" y="0"/>
+          <a:ext cx="0" cy="0"/>
+          <a:chOff x="0" y="0"/>
+          <a:chExt cx="0" cy="0"/>
+        </a:xfrm>
+      </p:grpSpPr>
+      <p:sp>
+        <p:nvSpPr>
+          <p:cNvPr id="4" name="Retângulo: Cantos Arredondados 3">
+            <a:extLst>
+              <a:ext uri="{FF2B5EF4-FFF2-40B4-BE49-F238E27FC236}">
+                <a16:creationId xmlns:a16="http://schemas.microsoft.com/office/drawing/2014/main" id="{FA77190B-F94D-E8B5-D9E4-63A28F2E5F17}"/>
+              </a:ext>
+            </a:extLst>
+          </p:cNvPr>
+          <p:cNvSpPr/>
+          <p:nvPr/>
+        </p:nvSpPr>
+        <p:spPr>
+          <a:xfrm>
+            <a:off x="1406013" y="2900515"/>
+            <a:ext cx="4345858" cy="1632155"/>
+          </a:xfrm>
+          <a:prstGeom prst="roundRect">
+            <a:avLst/>
+          </a:prstGeom>
+          <a:solidFill>
+            <a:schemeClr val="bg1"/>
+          </a:solidFill>
+          <a:ln>
+            <a:noFill/>
+          </a:ln>
+          <a:effectLst>
+            <a:outerShdw blurRad="215900" sx="104000" sy="104000" algn="ctr" rotWithShape="0">
+              <a:prstClr val="black">
+                <a:alpha val="5000"/>
+              </a:prstClr>
+            </a:outerShdw>
+            <a:reflection stA="45000" endPos="0" dist="50800" dir="5400000" sy="-100000" algn="bl" rotWithShape="0"/>
+          </a:effectLst>
+        </p:spPr>
+        <p:style>
+          <a:lnRef idx="2">
+            <a:schemeClr val="accent1">
+              <a:shade val="15000"/>
+            </a:schemeClr>
+          </a:lnRef>
+          <a:fillRef idx="1">
+            <a:schemeClr val="accent1"/>
+          </a:fillRef>
+          <a:effectRef idx="0">
+            <a:schemeClr val="accent1"/>
+          </a:effectRef>
+          <a:fontRef idx="minor">
+            <a:schemeClr val="lt1"/>
+          </a:fontRef>
+        </p:style>
+        <p:txBody>
+          <a:bodyPr rtlCol="0" anchor="ctr"/>
+          <a:lstStyle/>
+          <a:p>
+            <a:pPr algn="ctr"/>
+            <a:endParaRPr lang="pt-BR"/>
+          </a:p>
+        </p:txBody>
+      </p:sp>
+      <p:sp>
+        <p:nvSpPr>
+          <p:cNvPr id="5" name="Retângulo: Cantos Arredondados 4">
+            <a:extLst>
+              <a:ext uri="{FF2B5EF4-FFF2-40B4-BE49-F238E27FC236}">
+                <a16:creationId xmlns:a16="http://schemas.microsoft.com/office/drawing/2014/main" id="{F5D0FD68-31F1-AA60-EB25-B0430C9E2BFE}"/>
+              </a:ext>
+            </a:extLst>
+          </p:cNvPr>
+          <p:cNvSpPr/>
+          <p:nvPr/>
+        </p:nvSpPr>
+        <p:spPr>
+          <a:xfrm>
+            <a:off x="1406013" y="4891547"/>
+            <a:ext cx="4345858" cy="1632155"/>
+          </a:xfrm>
+          <a:prstGeom prst="roundRect">
+            <a:avLst/>
+          </a:prstGeom>
+          <a:solidFill>
+            <a:schemeClr val="bg1"/>
+          </a:solidFill>
+          <a:ln>
+            <a:noFill/>
+          </a:ln>
+          <a:effectLst>
+            <a:outerShdw blurRad="215900" sx="104000" sy="104000" algn="ctr" rotWithShape="0">
+              <a:prstClr val="black">
+                <a:alpha val="5000"/>
+              </a:prstClr>
+            </a:outerShdw>
+            <a:reflection stA="45000" endPos="0" dist="50800" dir="5400000" sy="-100000" algn="bl" rotWithShape="0"/>
+          </a:effectLst>
+        </p:spPr>
+        <p:style>
+          <a:lnRef idx="2">
+            <a:schemeClr val="accent1">
+              <a:shade val="15000"/>
+            </a:schemeClr>
+          </a:lnRef>
+          <a:fillRef idx="1">
+            <a:schemeClr val="accent1"/>
+          </a:fillRef>
+          <a:effectRef idx="0">
+            <a:schemeClr val="accent1"/>
+          </a:effectRef>
+          <a:fontRef idx="minor">
+            <a:schemeClr val="lt1"/>
+          </a:fontRef>
+        </p:style>
+        <p:txBody>
+          <a:bodyPr rtlCol="0" anchor="ctr"/>
+          <a:lstStyle/>
+          <a:p>
+            <a:pPr algn="ctr"/>
+            <a:endParaRPr lang="pt-BR"/>
+          </a:p>
+        </p:txBody>
+      </p:sp>
+      <p:sp>
+        <p:nvSpPr>
+          <p:cNvPr id="6" name="Retângulo: Cantos Arredondados 5">
+            <a:extLst>
+              <a:ext uri="{FF2B5EF4-FFF2-40B4-BE49-F238E27FC236}">
+                <a16:creationId xmlns:a16="http://schemas.microsoft.com/office/drawing/2014/main" id="{AB69F5BA-90CD-973A-91EF-08E6EA23C09A}"/>
+              </a:ext>
+            </a:extLst>
+          </p:cNvPr>
+          <p:cNvSpPr/>
+          <p:nvPr/>
+        </p:nvSpPr>
+        <p:spPr>
+          <a:xfrm>
+            <a:off x="6440130" y="2900515"/>
+            <a:ext cx="4345858" cy="1632155"/>
+          </a:xfrm>
+          <a:prstGeom prst="roundRect">
+            <a:avLst/>
+          </a:prstGeom>
+          <a:solidFill>
+            <a:schemeClr val="bg1"/>
+          </a:solidFill>
+          <a:ln>
+            <a:noFill/>
+          </a:ln>
+          <a:effectLst>
+            <a:outerShdw blurRad="215900" sx="104000" sy="104000" algn="ctr" rotWithShape="0">
+              <a:prstClr val="black">
+                <a:alpha val="5000"/>
+              </a:prstClr>
+            </a:outerShdw>
+            <a:reflection stA="45000" endPos="0" dist="50800" dir="5400000" sy="-100000" algn="bl" rotWithShape="0"/>
+          </a:effectLst>
+        </p:spPr>
+        <p:style>
+          <a:lnRef idx="2">
+            <a:schemeClr val="accent1">
+              <a:shade val="15000"/>
+            </a:schemeClr>
+          </a:lnRef>
+          <a:fillRef idx="1">
+            <a:schemeClr val="accent1"/>
+          </a:fillRef>
+          <a:effectRef idx="0">
+            <a:schemeClr val="accent1"/>
+          </a:effectRef>
+          <a:fontRef idx="minor">
+            <a:schemeClr val="lt1"/>
+          </a:fontRef>
+        </p:style>
+        <p:txBody>
+          <a:bodyPr rtlCol="0" anchor="ctr"/>
+          <a:lstStyle/>
+          <a:p>
+            <a:pPr algn="ctr"/>
+            <a:endParaRPr lang="pt-BR"/>
+          </a:p>
+        </p:txBody>
+      </p:sp>
+      <p:sp>
+        <p:nvSpPr>
+          <p:cNvPr id="7" name="Retângulo: Cantos Arredondados 6">
+            <a:extLst>
+              <a:ext uri="{FF2B5EF4-FFF2-40B4-BE49-F238E27FC236}">
+                <a16:creationId xmlns:a16="http://schemas.microsoft.com/office/drawing/2014/main" id="{656748CF-E6DF-36F7-C2D4-5986B54B51D3}"/>
+              </a:ext>
+            </a:extLst>
+          </p:cNvPr>
+          <p:cNvSpPr/>
+          <p:nvPr/>
+        </p:nvSpPr>
+        <p:spPr>
+          <a:xfrm>
+            <a:off x="6440130" y="4891547"/>
+            <a:ext cx="4345857" cy="1632155"/>
+          </a:xfrm>
+          <a:prstGeom prst="roundRect">
+            <a:avLst/>
+          </a:prstGeom>
+          <a:solidFill>
+            <a:schemeClr val="bg1"/>
+          </a:solidFill>
+          <a:ln>
+            <a:noFill/>
+          </a:ln>
+          <a:effectLst>
+            <a:outerShdw blurRad="215900" sx="104000" sy="104000" algn="ctr" rotWithShape="0">
+              <a:prstClr val="black">
+                <a:alpha val="5000"/>
+              </a:prstClr>
+            </a:outerShdw>
+            <a:reflection stA="45000" endPos="0" dist="50800" dir="5400000" sy="-100000" algn="bl" rotWithShape="0"/>
+          </a:effectLst>
+        </p:spPr>
+        <p:style>
+          <a:lnRef idx="2">
+            <a:schemeClr val="accent1">
+              <a:shade val="15000"/>
+            </a:schemeClr>
+          </a:lnRef>
+          <a:fillRef idx="1">
+            <a:schemeClr val="accent1"/>
+          </a:fillRef>
+          <a:effectRef idx="0">
+            <a:schemeClr val="accent1"/>
+          </a:effectRef>
+          <a:fontRef idx="minor">
+            <a:schemeClr val="lt1"/>
+          </a:fontRef>
+        </p:style>
+        <p:txBody>
+          <a:bodyPr rtlCol="0" anchor="ctr"/>
+          <a:lstStyle/>
+          <a:p>
+            <a:pPr algn="ctr"/>
+            <a:endParaRPr lang="pt-BR"/>
+          </a:p>
+        </p:txBody>
+      </p:sp>
+      <p:sp>
+        <p:nvSpPr>
+          <p:cNvPr id="10" name="CaixaDeTexto 9">
+            <a:extLst>
+              <a:ext uri="{FF2B5EF4-FFF2-40B4-BE49-F238E27FC236}">
+                <a16:creationId xmlns:a16="http://schemas.microsoft.com/office/drawing/2014/main" id="{7F2B2F22-5407-9A2C-78D8-06D94D9189DA}"/>
+              </a:ext>
+            </a:extLst>
+          </p:cNvPr>
+          <p:cNvSpPr txBox="1"/>
+          <p:nvPr/>
+        </p:nvSpPr>
+        <p:spPr>
+          <a:xfrm>
+            <a:off x="1533832" y="3057832"/>
+            <a:ext cx="4119716" cy="369332"/>
+          </a:xfrm>
+          <a:prstGeom prst="rect">
+            <a:avLst/>
+          </a:prstGeom>
+          <a:noFill/>
+        </p:spPr>
+        <p:txBody>
+          <a:bodyPr wrap="square" rtlCol="0">
+            <a:spAutoFit/>
+          </a:bodyPr>
+          <a:lstStyle/>
+          <a:p>
+            <a:r>
+              <a:rPr lang="pt-BR" dirty="0">
+                <a:solidFill>
+                  <a:srgbClr val="002060"/>
+                </a:solidFill>
+                <a:latin typeface="Aptos SemiBold" panose="020F0502020204030204" pitchFamily="34" charset="0"/>
+                <a:cs typeface="Aharoni" panose="020F0502020204030204" pitchFamily="2" charset="-79"/>
+              </a:rPr>
+              <a:t>Operacional - Monitoramento</a:t>
+            </a:r>
+          </a:p>
+        </p:txBody>
+      </p:sp>
+      <p:sp>
+        <p:nvSpPr>
+          <p:cNvPr id="11" name="CaixaDeTexto 10">
+            <a:extLst>
+              <a:ext uri="{FF2B5EF4-FFF2-40B4-BE49-F238E27FC236}">
+                <a16:creationId xmlns:a16="http://schemas.microsoft.com/office/drawing/2014/main" id="{8EF274FA-A70A-E361-F86B-BAE9FFA224A2}"/>
+              </a:ext>
+            </a:extLst>
+          </p:cNvPr>
+          <p:cNvSpPr txBox="1"/>
+          <p:nvPr/>
+        </p:nvSpPr>
+        <p:spPr>
+          <a:xfrm>
+            <a:off x="1533832" y="5048864"/>
+            <a:ext cx="4119716" cy="369332"/>
+          </a:xfrm>
+          <a:prstGeom prst="rect">
+            <a:avLst/>
+          </a:prstGeom>
+          <a:noFill/>
+        </p:spPr>
+        <p:txBody>
+          <a:bodyPr wrap="square" rtlCol="0">
+            <a:spAutoFit/>
+          </a:bodyPr>
+          <a:lstStyle/>
+          <a:p>
+            <a:r>
+              <a:rPr lang="pt-BR" dirty="0">
+                <a:solidFill>
+                  <a:srgbClr val="002060"/>
+                </a:solidFill>
+                <a:latin typeface="Aptos SemiBold" panose="020F0502020204030204" pitchFamily="34" charset="0"/>
+                <a:cs typeface="Aharoni" panose="020F0502020204030204" pitchFamily="2" charset="-79"/>
+              </a:rPr>
+              <a:t>Analytics – Performance orçamentária</a:t>
+            </a:r>
+          </a:p>
+        </p:txBody>
+      </p:sp>
+      <p:sp>
+        <p:nvSpPr>
+          <p:cNvPr id="12" name="CaixaDeTexto 11">
+            <a:extLst>
+              <a:ext uri="{FF2B5EF4-FFF2-40B4-BE49-F238E27FC236}">
+                <a16:creationId xmlns:a16="http://schemas.microsoft.com/office/drawing/2014/main" id="{78DF0ED0-657C-C279-92EB-5315FB534ACA}"/>
+              </a:ext>
+            </a:extLst>
+          </p:cNvPr>
+          <p:cNvSpPr txBox="1"/>
+          <p:nvPr/>
+        </p:nvSpPr>
+        <p:spPr>
+          <a:xfrm>
+            <a:off x="6577782" y="3057832"/>
+            <a:ext cx="4119716" cy="369332"/>
+          </a:xfrm>
+          <a:prstGeom prst="rect">
+            <a:avLst/>
+          </a:prstGeom>
+          <a:noFill/>
+        </p:spPr>
+        <p:txBody>
+          <a:bodyPr wrap="square" rtlCol="0">
+            <a:spAutoFit/>
+          </a:bodyPr>
+          <a:lstStyle/>
+          <a:p>
+            <a:r>
+              <a:rPr lang="pt-BR" dirty="0">
+                <a:solidFill>
+                  <a:srgbClr val="002060"/>
+                </a:solidFill>
+                <a:latin typeface="Aptos SemiBold" panose="020F0502020204030204" pitchFamily="34" charset="0"/>
+                <a:cs typeface="Aharoni" panose="020F0502020204030204" pitchFamily="2" charset="-79"/>
+              </a:rPr>
+              <a:t>Operacional - Detalhamento</a:t>
+            </a:r>
+          </a:p>
+        </p:txBody>
+      </p:sp>
+      <p:sp>
+        <p:nvSpPr>
+          <p:cNvPr id="13" name="CaixaDeTexto 12">
+            <a:extLst>
+              <a:ext uri="{FF2B5EF4-FFF2-40B4-BE49-F238E27FC236}">
+                <a16:creationId xmlns:a16="http://schemas.microsoft.com/office/drawing/2014/main" id="{5316F2D2-4260-0039-58A5-49A38ADE7762}"/>
+              </a:ext>
+            </a:extLst>
+          </p:cNvPr>
+          <p:cNvSpPr txBox="1"/>
+          <p:nvPr/>
+        </p:nvSpPr>
+        <p:spPr>
+          <a:xfrm>
+            <a:off x="6577782" y="5048864"/>
+            <a:ext cx="4119716" cy="369332"/>
+          </a:xfrm>
+          <a:prstGeom prst="rect">
+            <a:avLst/>
+          </a:prstGeom>
+          <a:noFill/>
+        </p:spPr>
+        <p:txBody>
+          <a:bodyPr wrap="square" rtlCol="0">
+            <a:spAutoFit/>
+          </a:bodyPr>
+          <a:lstStyle/>
+          <a:p>
+            <a:r>
+              <a:rPr lang="pt-BR" dirty="0">
+                <a:solidFill>
+                  <a:srgbClr val="002060"/>
+                </a:solidFill>
+                <a:latin typeface="Aptos SemiBold" panose="020F0502020204030204" pitchFamily="34" charset="0"/>
+                <a:cs typeface="Aharoni" panose="020F0502020204030204" pitchFamily="2" charset="-79"/>
+              </a:rPr>
+              <a:t>Analytics – Evolução e tendências</a:t>
+            </a:r>
+          </a:p>
+        </p:txBody>
+      </p:sp>
+      <p:sp>
+        <p:nvSpPr>
+          <p:cNvPr id="18" name="Retângulo: Cantos Arredondados 17">
+            <a:extLst>
+              <a:ext uri="{FF2B5EF4-FFF2-40B4-BE49-F238E27FC236}">
+                <a16:creationId xmlns:a16="http://schemas.microsoft.com/office/drawing/2014/main" id="{A014EA3C-D8B3-C243-8F54-03A0F619A490}"/>
+              </a:ext>
+            </a:extLst>
+          </p:cNvPr>
+          <p:cNvSpPr/>
+          <p:nvPr/>
+        </p:nvSpPr>
+        <p:spPr>
+          <a:xfrm>
+            <a:off x="1533832" y="3427164"/>
+            <a:ext cx="825910" cy="840036"/>
+          </a:xfrm>
+          <a:prstGeom prst="roundRect">
+            <a:avLst/>
+          </a:prstGeom>
+          <a:solidFill>
+            <a:schemeClr val="bg1">
+              <a:lumMod val="95000"/>
+            </a:schemeClr>
+          </a:solidFill>
+          <a:ln>
+            <a:noFill/>
+          </a:ln>
+        </p:spPr>
+        <p:style>
+          <a:lnRef idx="2">
+            <a:schemeClr val="accent1">
+              <a:shade val="15000"/>
+            </a:schemeClr>
+          </a:lnRef>
+          <a:fillRef idx="1">
+            <a:schemeClr val="accent1"/>
+          </a:fillRef>
+          <a:effectRef idx="0">
+            <a:schemeClr val="accent1"/>
+          </a:effectRef>
+          <a:fontRef idx="minor">
+            <a:schemeClr val="lt1"/>
+          </a:fontRef>
+        </p:style>
+        <p:txBody>
+          <a:bodyPr rtlCol="0" anchor="ctr"/>
+          <a:lstStyle/>
+          <a:p>
+            <a:pPr algn="ctr"/>
+            <a:endParaRPr lang="pt-BR"/>
+          </a:p>
+        </p:txBody>
+      </p:sp>
+      <p:pic>
+        <p:nvPicPr>
+          <p:cNvPr id="14" name="Imagem 13" descr="Ícone&#10;&#10;O conteúdo gerado por IA pode estar incorreto.">
+            <a:extLst>
+              <a:ext uri="{FF2B5EF4-FFF2-40B4-BE49-F238E27FC236}">
+                <a16:creationId xmlns:a16="http://schemas.microsoft.com/office/drawing/2014/main" id="{48B8CCAC-41E4-574C-85C9-70BF530202EC}"/>
+              </a:ext>
+            </a:extLst>
+          </p:cNvPr>
+          <p:cNvPicPr>
+            <a:picLocks noChangeAspect="1"/>
+          </p:cNvPicPr>
+          <p:nvPr/>
+        </p:nvPicPr>
+        <p:blipFill>
+          <a:blip r:embed="rId2">
+            <a:extLst>
+              <a:ext uri="{28A0092B-C50C-407E-A947-70E740481C1C}">
+                <a14:useLocalDpi xmlns:a14="http://schemas.microsoft.com/office/drawing/2010/main" val="0"/>
+              </a:ext>
+            </a:extLst>
+          </a:blip>
+          <a:stretch>
+            <a:fillRect/>
+          </a:stretch>
+        </p:blipFill>
+        <p:spPr>
+          <a:xfrm>
+            <a:off x="1622976" y="3517526"/>
+            <a:ext cx="618780" cy="618780"/>
+          </a:xfrm>
+          <a:prstGeom prst="rect">
+            <a:avLst/>
+          </a:prstGeom>
+        </p:spPr>
+      </p:pic>
+      <p:sp>
+        <p:nvSpPr>
+          <p:cNvPr id="19" name="Retângulo: Cantos Arredondados 18">
+            <a:extLst>
+              <a:ext uri="{FF2B5EF4-FFF2-40B4-BE49-F238E27FC236}">
+                <a16:creationId xmlns:a16="http://schemas.microsoft.com/office/drawing/2014/main" id="{BC9B12BF-1C9F-0924-8E02-87D2E29318A6}"/>
+              </a:ext>
+            </a:extLst>
+          </p:cNvPr>
+          <p:cNvSpPr/>
+          <p:nvPr/>
+        </p:nvSpPr>
+        <p:spPr>
+          <a:xfrm>
+            <a:off x="1573161" y="5422827"/>
+            <a:ext cx="786581" cy="840036"/>
+          </a:xfrm>
+          <a:prstGeom prst="roundRect">
+            <a:avLst/>
+          </a:prstGeom>
+          <a:solidFill>
+            <a:schemeClr val="bg1">
+              <a:lumMod val="95000"/>
+            </a:schemeClr>
+          </a:solidFill>
+          <a:ln>
+            <a:noFill/>
+          </a:ln>
+        </p:spPr>
+        <p:style>
+          <a:lnRef idx="2">
+            <a:schemeClr val="accent1">
+              <a:shade val="15000"/>
+            </a:schemeClr>
+          </a:lnRef>
+          <a:fillRef idx="1">
+            <a:schemeClr val="accent1"/>
+          </a:fillRef>
+          <a:effectRef idx="0">
+            <a:schemeClr val="accent1"/>
+          </a:effectRef>
+          <a:fontRef idx="minor">
+            <a:schemeClr val="lt1"/>
+          </a:fontRef>
+        </p:style>
+        <p:txBody>
+          <a:bodyPr rtlCol="0" anchor="ctr"/>
+          <a:lstStyle/>
+          <a:p>
+            <a:pPr algn="ctr"/>
+            <a:endParaRPr lang="pt-BR"/>
+          </a:p>
+        </p:txBody>
+      </p:sp>
+      <p:sp>
+        <p:nvSpPr>
+          <p:cNvPr id="21" name="Retângulo: Cantos Arredondados 20">
+            <a:extLst>
+              <a:ext uri="{FF2B5EF4-FFF2-40B4-BE49-F238E27FC236}">
+                <a16:creationId xmlns:a16="http://schemas.microsoft.com/office/drawing/2014/main" id="{7A4ECCD4-1CF4-DE6A-C094-BE4F5B551DFE}"/>
+              </a:ext>
+            </a:extLst>
+          </p:cNvPr>
+          <p:cNvSpPr/>
+          <p:nvPr/>
+        </p:nvSpPr>
+        <p:spPr>
+          <a:xfrm>
+            <a:off x="6574982" y="3391214"/>
+            <a:ext cx="825910" cy="840036"/>
+          </a:xfrm>
+          <a:prstGeom prst="roundRect">
+            <a:avLst/>
+          </a:prstGeom>
+          <a:solidFill>
+            <a:schemeClr val="bg1">
+              <a:lumMod val="95000"/>
+            </a:schemeClr>
+          </a:solidFill>
+          <a:ln>
+            <a:noFill/>
+          </a:ln>
+        </p:spPr>
+        <p:style>
+          <a:lnRef idx="2">
+            <a:schemeClr val="accent1">
+              <a:shade val="15000"/>
+            </a:schemeClr>
+          </a:lnRef>
+          <a:fillRef idx="1">
+            <a:schemeClr val="accent1"/>
+          </a:fillRef>
+          <a:effectRef idx="0">
+            <a:schemeClr val="accent1"/>
+          </a:effectRef>
+          <a:fontRef idx="minor">
+            <a:schemeClr val="lt1"/>
+          </a:fontRef>
+        </p:style>
+        <p:txBody>
+          <a:bodyPr rtlCol="0" anchor="ctr"/>
+          <a:lstStyle/>
+          <a:p>
+            <a:pPr algn="ctr"/>
+            <a:endParaRPr lang="pt-BR"/>
+          </a:p>
+        </p:txBody>
+      </p:sp>
+      <p:pic>
+        <p:nvPicPr>
+          <p:cNvPr id="15" name="Imagem 14" descr="Ícone&#10;&#10;O conteúdo gerado por IA pode estar incorreto.">
+            <a:extLst>
+              <a:ext uri="{FF2B5EF4-FFF2-40B4-BE49-F238E27FC236}">
+                <a16:creationId xmlns:a16="http://schemas.microsoft.com/office/drawing/2014/main" id="{33573B1C-B4A5-F450-C89D-954F0E3B2EED}"/>
+              </a:ext>
+            </a:extLst>
+          </p:cNvPr>
+          <p:cNvPicPr>
+            <a:picLocks noChangeAspect="1"/>
+          </p:cNvPicPr>
+          <p:nvPr/>
+        </p:nvPicPr>
+        <p:blipFill>
+          <a:blip r:embed="rId3">
+            <a:extLst>
+              <a:ext uri="{28A0092B-C50C-407E-A947-70E740481C1C}">
+                <a14:useLocalDpi xmlns:a14="http://schemas.microsoft.com/office/drawing/2010/main" val="0"/>
+              </a:ext>
+            </a:extLst>
+          </a:blip>
+          <a:stretch>
+            <a:fillRect/>
+          </a:stretch>
+        </p:blipFill>
+        <p:spPr>
+          <a:xfrm>
+            <a:off x="6678547" y="3517526"/>
+            <a:ext cx="618780" cy="618780"/>
+          </a:xfrm>
+          <a:prstGeom prst="rect">
+            <a:avLst/>
+          </a:prstGeom>
+        </p:spPr>
+      </p:pic>
+      <p:sp>
+        <p:nvSpPr>
+          <p:cNvPr id="20" name="Retângulo: Cantos Arredondados 19">
+            <a:extLst>
+              <a:ext uri="{FF2B5EF4-FFF2-40B4-BE49-F238E27FC236}">
+                <a16:creationId xmlns:a16="http://schemas.microsoft.com/office/drawing/2014/main" id="{CE108E38-362D-28B1-EE34-D04C0DF5AC09}"/>
+              </a:ext>
+            </a:extLst>
+          </p:cNvPr>
+          <p:cNvSpPr/>
+          <p:nvPr/>
+        </p:nvSpPr>
+        <p:spPr>
+          <a:xfrm>
+            <a:off x="6574982" y="5422827"/>
+            <a:ext cx="825910" cy="840036"/>
+          </a:xfrm>
+          <a:prstGeom prst="roundRect">
+            <a:avLst/>
+          </a:prstGeom>
+          <a:solidFill>
+            <a:schemeClr val="bg1">
+              <a:lumMod val="95000"/>
+            </a:schemeClr>
+          </a:solidFill>
+          <a:ln>
+            <a:noFill/>
+          </a:ln>
+        </p:spPr>
+        <p:style>
+          <a:lnRef idx="2">
+            <a:schemeClr val="accent1">
+              <a:shade val="15000"/>
+            </a:schemeClr>
+          </a:lnRef>
+          <a:fillRef idx="1">
+            <a:schemeClr val="accent1"/>
+          </a:fillRef>
+          <a:effectRef idx="0">
+            <a:schemeClr val="accent1"/>
+          </a:effectRef>
+          <a:fontRef idx="minor">
+            <a:schemeClr val="lt1"/>
+          </a:fontRef>
+        </p:style>
+        <p:txBody>
+          <a:bodyPr rtlCol="0" anchor="ctr"/>
+          <a:lstStyle/>
+          <a:p>
+            <a:pPr algn="ctr"/>
+            <a:endParaRPr lang="pt-BR"/>
+          </a:p>
+        </p:txBody>
+      </p:sp>
+      <p:pic>
+        <p:nvPicPr>
+          <p:cNvPr id="16" name="Imagem 15">
+            <a:extLst>
+              <a:ext uri="{FF2B5EF4-FFF2-40B4-BE49-F238E27FC236}">
+                <a16:creationId xmlns:a16="http://schemas.microsoft.com/office/drawing/2014/main" id="{D5C52D20-C110-3E6B-7978-ADC79D15E494}"/>
+              </a:ext>
+            </a:extLst>
+          </p:cNvPr>
+          <p:cNvPicPr>
+            <a:picLocks noChangeAspect="1"/>
+          </p:cNvPicPr>
+          <p:nvPr/>
+        </p:nvPicPr>
+        <p:blipFill>
+          <a:blip r:embed="rId4">
+            <a:extLst>
+              <a:ext uri="{28A0092B-C50C-407E-A947-70E740481C1C}">
+                <a14:useLocalDpi xmlns:a14="http://schemas.microsoft.com/office/drawing/2010/main" val="0"/>
+              </a:ext>
+            </a:extLst>
+          </a:blip>
+          <a:stretch>
+            <a:fillRect/>
+          </a:stretch>
+        </p:blipFill>
+        <p:spPr>
+          <a:xfrm>
+            <a:off x="1642640" y="5531266"/>
+            <a:ext cx="654526" cy="654526"/>
+          </a:xfrm>
+          <a:prstGeom prst="rect">
+            <a:avLst/>
+          </a:prstGeom>
+        </p:spPr>
+      </p:pic>
+      <p:pic>
+        <p:nvPicPr>
+          <p:cNvPr id="17" name="Imagem 16">
+            <a:extLst>
+              <a:ext uri="{FF2B5EF4-FFF2-40B4-BE49-F238E27FC236}">
+                <a16:creationId xmlns:a16="http://schemas.microsoft.com/office/drawing/2014/main" id="{2B482ABD-0785-9FD7-4737-3CD508A4966D}"/>
+              </a:ext>
+            </a:extLst>
+          </p:cNvPr>
+          <p:cNvPicPr>
+            <a:picLocks noChangeAspect="1"/>
+          </p:cNvPicPr>
+          <p:nvPr/>
+        </p:nvPicPr>
+        <p:blipFill>
+          <a:blip r:embed="rId5">
+            <a:extLst>
+              <a:ext uri="{28A0092B-C50C-407E-A947-70E740481C1C}">
+                <a14:useLocalDpi xmlns:a14="http://schemas.microsoft.com/office/drawing/2010/main" val="0"/>
+              </a:ext>
+            </a:extLst>
+          </a:blip>
+          <a:stretch>
+            <a:fillRect/>
+          </a:stretch>
+        </p:blipFill>
+        <p:spPr>
+          <a:xfrm>
+            <a:off x="6660674" y="5531266"/>
+            <a:ext cx="654526" cy="654526"/>
+          </a:xfrm>
+          <a:prstGeom prst="rect">
+            <a:avLst/>
+          </a:prstGeom>
+        </p:spPr>
+      </p:pic>
+      <p:sp>
+        <p:nvSpPr>
+          <p:cNvPr id="22" name="CaixaDeTexto 21">
+            <a:extLst>
+              <a:ext uri="{FF2B5EF4-FFF2-40B4-BE49-F238E27FC236}">
+                <a16:creationId xmlns:a16="http://schemas.microsoft.com/office/drawing/2014/main" id="{587BA0FE-D58E-C674-9279-704389F31AA2}"/>
+              </a:ext>
+            </a:extLst>
+          </p:cNvPr>
+          <p:cNvSpPr txBox="1"/>
+          <p:nvPr/>
+        </p:nvSpPr>
+        <p:spPr>
+          <a:xfrm>
+            <a:off x="2669458" y="3524016"/>
+            <a:ext cx="1818968" cy="646331"/>
+          </a:xfrm>
+          <a:prstGeom prst="rect">
+            <a:avLst/>
+          </a:prstGeom>
+          <a:noFill/>
+        </p:spPr>
+        <p:txBody>
+          <a:bodyPr wrap="square" rtlCol="0">
+            <a:spAutoFit/>
+          </a:bodyPr>
+          <a:lstStyle/>
+          <a:p>
+            <a:r>
+              <a:rPr lang="pt-BR" dirty="0">
+                <a:solidFill>
+                  <a:schemeClr val="bg1">
+                    <a:lumMod val="50000"/>
+                  </a:schemeClr>
+                </a:solidFill>
+              </a:rPr>
+              <a:t>Visão do mês em curso</a:t>
+            </a:r>
+          </a:p>
+        </p:txBody>
+      </p:sp>
+      <p:sp>
+        <p:nvSpPr>
+          <p:cNvPr id="23" name="CaixaDeTexto 22">
+            <a:extLst>
+              <a:ext uri="{FF2B5EF4-FFF2-40B4-BE49-F238E27FC236}">
+                <a16:creationId xmlns:a16="http://schemas.microsoft.com/office/drawing/2014/main" id="{B1F441E7-B94C-CF51-DB45-42DE51AC3989}"/>
+              </a:ext>
+            </a:extLst>
+          </p:cNvPr>
+          <p:cNvSpPr txBox="1"/>
+          <p:nvPr/>
+        </p:nvSpPr>
+        <p:spPr>
+          <a:xfrm>
+            <a:off x="2684206" y="5519678"/>
+            <a:ext cx="1818968" cy="646331"/>
+          </a:xfrm>
+          <a:prstGeom prst="rect">
+            <a:avLst/>
+          </a:prstGeom>
+          <a:noFill/>
+        </p:spPr>
+        <p:txBody>
+          <a:bodyPr wrap="square" rtlCol="0">
+            <a:spAutoFit/>
+          </a:bodyPr>
+          <a:lstStyle/>
+          <a:p>
+            <a:r>
+              <a:rPr lang="pt-BR" dirty="0">
+                <a:solidFill>
+                  <a:schemeClr val="bg1">
+                    <a:lumMod val="50000"/>
+                  </a:schemeClr>
+                </a:solidFill>
+              </a:rPr>
+              <a:t>Orçado vs realizado YTD</a:t>
+            </a:r>
+          </a:p>
+        </p:txBody>
+      </p:sp>
+      <p:sp>
+        <p:nvSpPr>
+          <p:cNvPr id="24" name="CaixaDeTexto 23">
+            <a:extLst>
+              <a:ext uri="{FF2B5EF4-FFF2-40B4-BE49-F238E27FC236}">
+                <a16:creationId xmlns:a16="http://schemas.microsoft.com/office/drawing/2014/main" id="{AB4DA6C2-5AAE-3D90-1B45-1D85CC1D4BA7}"/>
+              </a:ext>
+            </a:extLst>
+          </p:cNvPr>
+          <p:cNvSpPr txBox="1"/>
+          <p:nvPr/>
+        </p:nvSpPr>
+        <p:spPr>
+          <a:xfrm>
+            <a:off x="7591425" y="5519679"/>
+            <a:ext cx="1818968" cy="646331"/>
+          </a:xfrm>
+          <a:prstGeom prst="rect">
+            <a:avLst/>
+          </a:prstGeom>
+          <a:noFill/>
+        </p:spPr>
+        <p:txBody>
+          <a:bodyPr wrap="square" rtlCol="0">
+            <a:spAutoFit/>
+          </a:bodyPr>
+          <a:lstStyle/>
+          <a:p>
+            <a:r>
+              <a:rPr lang="pt-BR" dirty="0">
+                <a:solidFill>
+                  <a:schemeClr val="bg1">
+                    <a:lumMod val="50000"/>
+                  </a:schemeClr>
+                </a:solidFill>
+              </a:rPr>
+              <a:t>Crescimento MoM e YoY</a:t>
+            </a:r>
+          </a:p>
+        </p:txBody>
+      </p:sp>
+      <p:sp>
+        <p:nvSpPr>
+          <p:cNvPr id="25" name="CaixaDeTexto 24">
+            <a:extLst>
+              <a:ext uri="{FF2B5EF4-FFF2-40B4-BE49-F238E27FC236}">
+                <a16:creationId xmlns:a16="http://schemas.microsoft.com/office/drawing/2014/main" id="{585FCD3F-DEC5-BF38-6457-1FFE9317E07B}"/>
+              </a:ext>
+            </a:extLst>
+          </p:cNvPr>
+          <p:cNvSpPr txBox="1"/>
+          <p:nvPr/>
+        </p:nvSpPr>
+        <p:spPr>
+          <a:xfrm>
+            <a:off x="7591425" y="3524016"/>
+            <a:ext cx="1818968" cy="646331"/>
+          </a:xfrm>
+          <a:prstGeom prst="rect">
+            <a:avLst/>
+          </a:prstGeom>
+          <a:noFill/>
+        </p:spPr>
+        <p:txBody>
+          <a:bodyPr wrap="square" rtlCol="0">
+            <a:spAutoFit/>
+          </a:bodyPr>
+          <a:lstStyle/>
+          <a:p>
+            <a:r>
+              <a:rPr lang="pt-BR" dirty="0">
+                <a:solidFill>
+                  <a:schemeClr val="bg1">
+                    <a:lumMod val="50000"/>
+                  </a:schemeClr>
+                </a:solidFill>
+              </a:rPr>
+              <a:t>Lançamentos detalhados</a:t>
+            </a:r>
+          </a:p>
+        </p:txBody>
+      </p:sp>
+      <p:sp>
+        <p:nvSpPr>
+          <p:cNvPr id="26" name="Retângulo: Cantos Arredondados 25">
+            <a:extLst>
+              <a:ext uri="{FF2B5EF4-FFF2-40B4-BE49-F238E27FC236}">
+                <a16:creationId xmlns:a16="http://schemas.microsoft.com/office/drawing/2014/main" id="{6477A151-9237-E1BF-961A-FAADED150654}"/>
+              </a:ext>
+            </a:extLst>
+          </p:cNvPr>
+          <p:cNvSpPr/>
+          <p:nvPr/>
+        </p:nvSpPr>
+        <p:spPr>
+          <a:xfrm>
+            <a:off x="4374604" y="1855231"/>
+            <a:ext cx="3442791" cy="510668"/>
+          </a:xfrm>
+          <a:prstGeom prst="roundRect">
+            <a:avLst>
+              <a:gd name="adj" fmla="val 26287"/>
+            </a:avLst>
+          </a:prstGeom>
+          <a:solidFill>
+            <a:srgbClr val="2F3A5F"/>
+          </a:solidFill>
+          <a:ln>
+            <a:noFill/>
+          </a:ln>
+        </p:spPr>
+        <p:style>
+          <a:lnRef idx="2">
+            <a:schemeClr val="accent1">
+              <a:shade val="15000"/>
+            </a:schemeClr>
+          </a:lnRef>
+          <a:fillRef idx="1">
+            <a:schemeClr val="accent1"/>
+          </a:fillRef>
+          <a:effectRef idx="0">
+            <a:schemeClr val="accent1"/>
+          </a:effectRef>
+          <a:fontRef idx="minor">
+            <a:schemeClr val="lt1"/>
+          </a:fontRef>
+        </p:style>
+        <p:txBody>
+          <a:bodyPr rtlCol="0" anchor="ctr"/>
+          <a:lstStyle/>
+          <a:p>
+            <a:pPr algn="ctr"/>
+            <a:r>
+              <a:rPr lang="pt-BR" sz="2800" dirty="0"/>
+              <a:t>Gestão financeira</a:t>
+            </a:r>
+          </a:p>
+        </p:txBody>
+      </p:sp>
+      <p:pic>
+        <p:nvPicPr>
+          <p:cNvPr id="9" name="Imagem 8">
+            <a:extLst>
+              <a:ext uri="{FF2B5EF4-FFF2-40B4-BE49-F238E27FC236}">
+                <a16:creationId xmlns:a16="http://schemas.microsoft.com/office/drawing/2014/main" id="{4AC5C046-8FB0-7A42-0775-8707E75004BC}"/>
+              </a:ext>
+            </a:extLst>
+          </p:cNvPr>
+          <p:cNvPicPr>
+            <a:picLocks noChangeAspect="1"/>
+          </p:cNvPicPr>
+          <p:nvPr/>
+        </p:nvPicPr>
+        <p:blipFill>
+          <a:blip r:embed="rId6"/>
+          <a:stretch>
+            <a:fillRect/>
+          </a:stretch>
+        </p:blipFill>
+        <p:spPr>
+          <a:xfrm>
+            <a:off x="4600575" y="400666"/>
+            <a:ext cx="2990850" cy="1219200"/>
+          </a:xfrm>
+          <a:prstGeom prst="rect">
+            <a:avLst/>
+          </a:prstGeom>
+        </p:spPr>
+      </p:pic>
+    </p:spTree>
+    <p:extLst>
+      <p:ext uri="{BB962C8B-B14F-4D97-AF65-F5344CB8AC3E}">
+        <p14:creationId xmlns:p14="http://schemas.microsoft.com/office/powerpoint/2010/main" val="1130321801"/>
+      </p:ext>
+    </p:extLst>
+  </p:cSld>
+  <p:clrMapOvr>
+    <a:masterClrMapping/>
+  </p:clrMapOvr>
+</p:sld>
+</file>
+
+<file path=ppt/slides/slide2.xml><?xml version="1.0" encoding="utf-8"?>
 <p:sld xmlns:a="http://schemas.openxmlformats.org/drawingml/2006/main" xmlns:r="http://schemas.openxmlformats.org/officeDocument/2006/relationships" xmlns:p="http://schemas.openxmlformats.org/presentationml/2006/main">
   <p:cSld>
     <p:bg>
@@ -5006,7 +6075,7 @@
 </p:sld>
 </file>
 
-<file path=ppt/slides/slide2.xml><?xml version="1.0" encoding="utf-8"?>
+<file path=ppt/slides/slide3.xml><?xml version="1.0" encoding="utf-8"?>
 <p:sld xmlns:a="http://schemas.openxmlformats.org/drawingml/2006/main" xmlns:r="http://schemas.openxmlformats.org/officeDocument/2006/relationships" xmlns:p="http://schemas.openxmlformats.org/presentationml/2006/main">
   <p:cSld>
     <p:bg>
@@ -6760,7 +7829,7 @@
 </p:sld>
 </file>
 
-<file path=ppt/slides/slide3.xml><?xml version="1.0" encoding="utf-8"?>
+<file path=ppt/slides/slide4.xml><?xml version="1.0" encoding="utf-8"?>
 <p:sld xmlns:a="http://schemas.openxmlformats.org/drawingml/2006/main" xmlns:r="http://schemas.openxmlformats.org/officeDocument/2006/relationships" xmlns:p="http://schemas.openxmlformats.org/presentationml/2006/main">
   <p:cSld>
     <p:bg>
@@ -7778,12 +8847,8 @@
           <a:p>
             <a:pPr algn="ctr"/>
             <a:r>
-              <a:rPr lang="pt-BR" sz="1400" dirty="0" err="1"/>
-              <a:t>Analytics</a:t>
-            </a:r>
-            <a:r>
               <a:rPr lang="pt-BR" sz="1400" dirty="0"/>
-              <a:t> – Performance Orçamentária</a:t>
+              <a:t>Analytics – Performance Orçamentária</a:t>
             </a:r>
           </a:p>
         </p:txBody>
@@ -8463,7 +9528,7 @@
 </p:sld>
 </file>
 
-<file path=ppt/slides/slide4.xml><?xml version="1.0" encoding="utf-8"?>
+<file path=ppt/slides/slide5.xml><?xml version="1.0" encoding="utf-8"?>
 <p:sld xmlns:a="http://schemas.openxmlformats.org/drawingml/2006/main" xmlns:r="http://schemas.openxmlformats.org/officeDocument/2006/relationships" xmlns:p="http://schemas.openxmlformats.org/presentationml/2006/main">
   <p:cSld>
     <p:spTree>
@@ -8471,7 +9536,7 @@
         <p:cNvPr id="1" name="">
           <a:extLst>
             <a:ext uri="{FF2B5EF4-FFF2-40B4-BE49-F238E27FC236}">
-              <a16:creationId xmlns:a16="http://schemas.microsoft.com/office/drawing/2014/main" id="{F9E3C501-4A0B-34C6-AE71-E6189A84D5DF}"/>
+              <a16:creationId xmlns:a16="http://schemas.microsoft.com/office/drawing/2014/main" id="{15DECBDB-F3F2-5610-5392-29AE714A762D}"/>
             </a:ext>
           </a:extLst>
         </p:cNvPr>
@@ -8491,7 +9556,7 @@
           <p:cNvPr id="33" name="Retângulo: Cantos Arredondados 32">
             <a:extLst>
               <a:ext uri="{FF2B5EF4-FFF2-40B4-BE49-F238E27FC236}">
-                <a16:creationId xmlns:a16="http://schemas.microsoft.com/office/drawing/2014/main" id="{46ED9FE1-6C82-0C25-A797-E42DA195FDCE}"/>
+                <a16:creationId xmlns:a16="http://schemas.microsoft.com/office/drawing/2014/main" id="{B2F546BD-164B-0210-2D43-A689121D62BC}"/>
               </a:ext>
             </a:extLst>
           </p:cNvPr>
@@ -8544,7 +9609,7 @@
           <p:cNvPr id="5" name="Retângulo: Cantos Arredondados 4">
             <a:extLst>
               <a:ext uri="{FF2B5EF4-FFF2-40B4-BE49-F238E27FC236}">
-                <a16:creationId xmlns:a16="http://schemas.microsoft.com/office/drawing/2014/main" id="{F7BB5804-DD34-9B1C-426F-6FE7A1CCCB54}"/>
+                <a16:creationId xmlns:a16="http://schemas.microsoft.com/office/drawing/2014/main" id="{E52B59DA-7444-A952-44E2-0A5A647FC95B}"/>
               </a:ext>
             </a:extLst>
           </p:cNvPr>
@@ -8603,7 +9668,7 @@
           <p:cNvPr id="43" name="Retângulo: Cantos Arredondados 42">
             <a:extLst>
               <a:ext uri="{FF2B5EF4-FFF2-40B4-BE49-F238E27FC236}">
-                <a16:creationId xmlns:a16="http://schemas.microsoft.com/office/drawing/2014/main" id="{B3E48184-A8F2-7992-8184-278B0A83C29C}"/>
+                <a16:creationId xmlns:a16="http://schemas.microsoft.com/office/drawing/2014/main" id="{34BB365B-6C57-DFDB-CEAE-61898CBB0450}"/>
               </a:ext>
             </a:extLst>
           </p:cNvPr>
@@ -9017,7 +10082,7 @@
           <p:cNvPr id="6" name="Retângulo: Cantos Arredondados 5">
             <a:extLst>
               <a:ext uri="{FF2B5EF4-FFF2-40B4-BE49-F238E27FC236}">
-                <a16:creationId xmlns:a16="http://schemas.microsoft.com/office/drawing/2014/main" id="{F69775F6-4B9D-38D2-7ECD-19510D09D8FB}"/>
+                <a16:creationId xmlns:a16="http://schemas.microsoft.com/office/drawing/2014/main" id="{059EC8DE-693F-2D30-CDBC-C63E2A1AE36C}"/>
               </a:ext>
             </a:extLst>
           </p:cNvPr>
@@ -9027,7 +10092,7 @@
         <p:spPr>
           <a:xfrm>
             <a:off x="1049149" y="949534"/>
-            <a:ext cx="2387600" cy="1037820"/>
+            <a:ext cx="2387600" cy="853130"/>
           </a:xfrm>
           <a:prstGeom prst="roundRect">
             <a:avLst>
@@ -9078,7 +10143,7 @@
           <p:cNvPr id="7" name="Retângulo: Cantos Arredondados 6">
             <a:extLst>
               <a:ext uri="{FF2B5EF4-FFF2-40B4-BE49-F238E27FC236}">
-                <a16:creationId xmlns:a16="http://schemas.microsoft.com/office/drawing/2014/main" id="{95AC2916-C324-DE69-5F47-0421D27CFAFF}"/>
+                <a16:creationId xmlns:a16="http://schemas.microsoft.com/office/drawing/2014/main" id="{935B4D87-7F10-AB36-968D-D4D6730226AA}"/>
               </a:ext>
             </a:extLst>
           </p:cNvPr>
@@ -9088,7 +10153,7 @@
         <p:spPr>
           <a:xfrm>
             <a:off x="3813903" y="949534"/>
-            <a:ext cx="2387600" cy="1037820"/>
+            <a:ext cx="2387600" cy="853130"/>
           </a:xfrm>
           <a:prstGeom prst="roundRect">
             <a:avLst>
@@ -9139,7 +10204,7 @@
           <p:cNvPr id="8" name="Retângulo: Cantos Arredondados 7">
             <a:extLst>
               <a:ext uri="{FF2B5EF4-FFF2-40B4-BE49-F238E27FC236}">
-                <a16:creationId xmlns:a16="http://schemas.microsoft.com/office/drawing/2014/main" id="{567E0E8C-73C1-8652-64E0-9A61BBB20E64}"/>
+                <a16:creationId xmlns:a16="http://schemas.microsoft.com/office/drawing/2014/main" id="{16B04D69-7B73-6177-C7B1-F20FA93BF3AF}"/>
               </a:ext>
             </a:extLst>
           </p:cNvPr>
@@ -9149,7 +10214,7 @@
         <p:spPr>
           <a:xfrm>
             <a:off x="9380638" y="950110"/>
-            <a:ext cx="2387600" cy="1030940"/>
+            <a:ext cx="2387600" cy="847474"/>
           </a:xfrm>
           <a:prstGeom prst="roundRect">
             <a:avLst>
@@ -9200,7 +10265,7 @@
           <p:cNvPr id="10" name="Retângulo: Cantos Arredondados 9">
             <a:extLst>
               <a:ext uri="{FF2B5EF4-FFF2-40B4-BE49-F238E27FC236}">
-                <a16:creationId xmlns:a16="http://schemas.microsoft.com/office/drawing/2014/main" id="{5FEA9C15-CDDD-AFE9-0FFC-AABDA491FA86}"/>
+                <a16:creationId xmlns:a16="http://schemas.microsoft.com/office/drawing/2014/main" id="{E600486A-A0F4-6258-BBAA-18F2F9FE4F3A}"/>
               </a:ext>
             </a:extLst>
           </p:cNvPr>
@@ -9209,8 +10274,8 @@
         </p:nvSpPr>
         <p:spPr>
           <a:xfrm>
-            <a:off x="1049149" y="2144577"/>
-            <a:ext cx="10737908" cy="2418961"/>
+            <a:off x="1049149" y="1944411"/>
+            <a:ext cx="5266984" cy="2619127"/>
           </a:xfrm>
           <a:prstGeom prst="roundRect">
             <a:avLst>
@@ -9261,7 +10326,7 @@
           <p:cNvPr id="12" name="Retângulo: Cantos Arredondados 11">
             <a:extLst>
               <a:ext uri="{FF2B5EF4-FFF2-40B4-BE49-F238E27FC236}">
-                <a16:creationId xmlns:a16="http://schemas.microsoft.com/office/drawing/2014/main" id="{FC9F9452-9579-722C-09FC-D45807E4F80A}"/>
+                <a16:creationId xmlns:a16="http://schemas.microsoft.com/office/drawing/2014/main" id="{8D72F93A-4356-D4B9-B706-F422863C2413}"/>
               </a:ext>
             </a:extLst>
           </p:cNvPr>
@@ -9271,7 +10336,7 @@
         <p:spPr>
           <a:xfrm>
             <a:off x="1049149" y="4820478"/>
-            <a:ext cx="5266984" cy="1921835"/>
+            <a:ext cx="10737908" cy="1921835"/>
           </a:xfrm>
           <a:prstGeom prst="roundRect">
             <a:avLst>
@@ -9322,7 +10387,7 @@
           <p:cNvPr id="34" name="Rectangle 1">
             <a:extLst>
               <a:ext uri="{FF2B5EF4-FFF2-40B4-BE49-F238E27FC236}">
-                <a16:creationId xmlns:a16="http://schemas.microsoft.com/office/drawing/2014/main" id="{EAFEA4D9-7945-C794-C1E9-B2D388E8ECFB}"/>
+                <a16:creationId xmlns:a16="http://schemas.microsoft.com/office/drawing/2014/main" id="{99360A99-0724-5818-A79E-82A878AD47FA}"/>
               </a:ext>
             </a:extLst>
           </p:cNvPr>
@@ -9391,7 +10456,7 @@
           <p:cNvPr id="40" name="Imagem 39" descr="Logotipo&#10;&#10;O conteúdo gerado por IA pode estar incorreto.">
             <a:extLst>
               <a:ext uri="{FF2B5EF4-FFF2-40B4-BE49-F238E27FC236}">
-                <a16:creationId xmlns:a16="http://schemas.microsoft.com/office/drawing/2014/main" id="{33CE1AA8-0668-096E-9C0F-8F993A1533AE}"/>
+                <a16:creationId xmlns:a16="http://schemas.microsoft.com/office/drawing/2014/main" id="{8552B86D-A995-EDF7-59A3-BEB4F67C88E0}"/>
               </a:ext>
             </a:extLst>
           </p:cNvPr>
@@ -9427,7 +10492,7 @@
           <p:cNvPr id="46" name="Retângulo: Cantos Arredondados 45">
             <a:extLst>
               <a:ext uri="{FF2B5EF4-FFF2-40B4-BE49-F238E27FC236}">
-                <a16:creationId xmlns:a16="http://schemas.microsoft.com/office/drawing/2014/main" id="{B957FC01-4CC7-1D98-3596-C154C9C76003}"/>
+                <a16:creationId xmlns:a16="http://schemas.microsoft.com/office/drawing/2014/main" id="{F0C0851D-FD33-9335-CB95-D188E50A92BB}"/>
               </a:ext>
             </a:extLst>
           </p:cNvPr>
@@ -9473,1768 +10538,8 @@
           <a:p>
             <a:pPr algn="ctr"/>
             <a:r>
-              <a:rPr lang="pt-BR" sz="1400" dirty="0" err="1"/>
-              <a:t>Analytics</a:t>
-            </a:r>
-            <a:r>
               <a:rPr lang="pt-BR" sz="1400" dirty="0"/>
-              <a:t> – Evolução e tendências</a:t>
-            </a:r>
-          </a:p>
-        </p:txBody>
-      </p:sp>
-      <p:sp>
-        <p:nvSpPr>
-          <p:cNvPr id="56" name="Retângulo: Cantos Arredondados 55">
-            <a:extLst>
-              <a:ext uri="{FF2B5EF4-FFF2-40B4-BE49-F238E27FC236}">
-                <a16:creationId xmlns:a16="http://schemas.microsoft.com/office/drawing/2014/main" id="{DCF7B23A-BA43-12FB-2C9A-519B41BC719F}"/>
-              </a:ext>
-            </a:extLst>
-          </p:cNvPr>
-          <p:cNvSpPr/>
-          <p:nvPr/>
-        </p:nvSpPr>
-        <p:spPr>
-          <a:xfrm>
-            <a:off x="3008184" y="970568"/>
-            <a:ext cx="347291" cy="374036"/>
-          </a:xfrm>
-          <a:prstGeom prst="roundRect">
-            <a:avLst>
-              <a:gd name="adj" fmla="val 35127"/>
-            </a:avLst>
-          </a:prstGeom>
-          <a:solidFill>
-            <a:srgbClr val="2F3A5F">
-              <a:alpha val="18000"/>
-            </a:srgbClr>
-          </a:solidFill>
-          <a:ln>
-            <a:noFill/>
-          </a:ln>
-        </p:spPr>
-        <p:style>
-          <a:lnRef idx="2">
-            <a:schemeClr val="accent1">
-              <a:shade val="15000"/>
-            </a:schemeClr>
-          </a:lnRef>
-          <a:fillRef idx="1">
-            <a:schemeClr val="accent1"/>
-          </a:fillRef>
-          <a:effectRef idx="0">
-            <a:schemeClr val="accent1"/>
-          </a:effectRef>
-          <a:fontRef idx="minor">
-            <a:schemeClr val="lt1"/>
-          </a:fontRef>
-        </p:style>
-        <p:txBody>
-          <a:bodyPr rtlCol="0" anchor="ctr"/>
-          <a:lstStyle/>
-          <a:p>
-            <a:pPr algn="ctr"/>
-            <a:endParaRPr lang="pt-BR" dirty="0"/>
-          </a:p>
-        </p:txBody>
-      </p:sp>
-      <p:sp>
-        <p:nvSpPr>
-          <p:cNvPr id="57" name="Retângulo: Cantos Arredondados 56">
-            <a:extLst>
-              <a:ext uri="{FF2B5EF4-FFF2-40B4-BE49-F238E27FC236}">
-                <a16:creationId xmlns:a16="http://schemas.microsoft.com/office/drawing/2014/main" id="{CA427C9E-3A2F-C9C0-A7B7-036C61A8E6F7}"/>
-              </a:ext>
-            </a:extLst>
-          </p:cNvPr>
-          <p:cNvSpPr/>
-          <p:nvPr/>
-        </p:nvSpPr>
-        <p:spPr>
-          <a:xfrm>
-            <a:off x="5762625" y="973108"/>
-            <a:ext cx="409575" cy="410669"/>
-          </a:xfrm>
-          <a:prstGeom prst="roundRect">
-            <a:avLst>
-              <a:gd name="adj" fmla="val 35127"/>
-            </a:avLst>
-          </a:prstGeom>
-          <a:solidFill>
-            <a:srgbClr val="2F3A5F">
-              <a:alpha val="18000"/>
-            </a:srgbClr>
-          </a:solidFill>
-          <a:ln>
-            <a:noFill/>
-          </a:ln>
-        </p:spPr>
-        <p:style>
-          <a:lnRef idx="2">
-            <a:schemeClr val="accent1">
-              <a:shade val="15000"/>
-            </a:schemeClr>
-          </a:lnRef>
-          <a:fillRef idx="1">
-            <a:schemeClr val="accent1"/>
-          </a:fillRef>
-          <a:effectRef idx="0">
-            <a:schemeClr val="accent1"/>
-          </a:effectRef>
-          <a:fontRef idx="minor">
-            <a:schemeClr val="lt1"/>
-          </a:fontRef>
-        </p:style>
-        <p:txBody>
-          <a:bodyPr rtlCol="0" anchor="ctr"/>
-          <a:lstStyle/>
-          <a:p>
-            <a:pPr algn="ctr"/>
-            <a:endParaRPr lang="pt-BR"/>
-          </a:p>
-        </p:txBody>
-      </p:sp>
-      <p:pic>
-        <p:nvPicPr>
-          <p:cNvPr id="53" name="Imagem 52" descr="Ícone&#10;&#10;O conteúdo gerado por IA pode estar incorreto.">
-            <a:extLst>
-              <a:ext uri="{FF2B5EF4-FFF2-40B4-BE49-F238E27FC236}">
-                <a16:creationId xmlns:a16="http://schemas.microsoft.com/office/drawing/2014/main" id="{5EFC8A99-5B7C-CBAD-791F-F32C460026CE}"/>
-              </a:ext>
-            </a:extLst>
-          </p:cNvPr>
-          <p:cNvPicPr>
-            <a:picLocks noChangeAspect="1"/>
-          </p:cNvPicPr>
-          <p:nvPr/>
-        </p:nvPicPr>
-        <p:blipFill>
-          <a:blip r:embed="rId3">
-            <a:extLst>
-              <a:ext uri="{28A0092B-C50C-407E-A947-70E740481C1C}">
-                <a14:useLocalDpi xmlns:a14="http://schemas.microsoft.com/office/drawing/2010/main" val="0"/>
-              </a:ext>
-            </a:extLst>
-          </a:blip>
-          <a:stretch>
-            <a:fillRect/>
-          </a:stretch>
-        </p:blipFill>
-        <p:spPr>
-          <a:xfrm>
-            <a:off x="3040137" y="999786"/>
-            <a:ext cx="291413" cy="291413"/>
-          </a:xfrm>
-          <a:prstGeom prst="rect">
-            <a:avLst/>
-          </a:prstGeom>
-        </p:spPr>
-      </p:pic>
-      <p:sp>
-        <p:nvSpPr>
-          <p:cNvPr id="58" name="Retângulo: Cantos Arredondados 57">
-            <a:extLst>
-              <a:ext uri="{FF2B5EF4-FFF2-40B4-BE49-F238E27FC236}">
-                <a16:creationId xmlns:a16="http://schemas.microsoft.com/office/drawing/2014/main" id="{0172DA5A-1FAB-20CE-97CF-84D6FD63A02F}"/>
-              </a:ext>
-            </a:extLst>
-          </p:cNvPr>
-          <p:cNvSpPr/>
-          <p:nvPr/>
-        </p:nvSpPr>
-        <p:spPr>
-          <a:xfrm>
-            <a:off x="11418889" y="981926"/>
-            <a:ext cx="306401" cy="346436"/>
-          </a:xfrm>
-          <a:prstGeom prst="roundRect">
-            <a:avLst>
-              <a:gd name="adj" fmla="val 35127"/>
-            </a:avLst>
-          </a:prstGeom>
-          <a:solidFill>
-            <a:srgbClr val="2F3A5F">
-              <a:alpha val="18000"/>
-            </a:srgbClr>
-          </a:solidFill>
-          <a:ln>
-            <a:noFill/>
-          </a:ln>
-        </p:spPr>
-        <p:style>
-          <a:lnRef idx="2">
-            <a:schemeClr val="accent1">
-              <a:shade val="15000"/>
-            </a:schemeClr>
-          </a:lnRef>
-          <a:fillRef idx="1">
-            <a:schemeClr val="accent1"/>
-          </a:fillRef>
-          <a:effectRef idx="0">
-            <a:schemeClr val="accent1"/>
-          </a:effectRef>
-          <a:fontRef idx="minor">
-            <a:schemeClr val="lt1"/>
-          </a:fontRef>
-        </p:style>
-        <p:txBody>
-          <a:bodyPr rtlCol="0" anchor="ctr"/>
-          <a:lstStyle/>
-          <a:p>
-            <a:pPr algn="ctr"/>
-            <a:endParaRPr lang="pt-BR"/>
-          </a:p>
-        </p:txBody>
-      </p:sp>
-      <p:pic>
-        <p:nvPicPr>
-          <p:cNvPr id="13" name="Imagem 12" descr="Ícone&#10;&#10;O conteúdo gerado por IA pode estar incorreto.">
-            <a:extLst>
-              <a:ext uri="{FF2B5EF4-FFF2-40B4-BE49-F238E27FC236}">
-                <a16:creationId xmlns:a16="http://schemas.microsoft.com/office/drawing/2014/main" id="{CF74667C-53DD-9736-07DC-2B34B7D80D0B}"/>
-              </a:ext>
-            </a:extLst>
-          </p:cNvPr>
-          <p:cNvPicPr>
-            <a:picLocks noChangeAspect="1"/>
-          </p:cNvPicPr>
-          <p:nvPr/>
-        </p:nvPicPr>
-        <p:blipFill>
-          <a:blip r:embed="rId4">
-            <a:extLst>
-              <a:ext uri="{28A0092B-C50C-407E-A947-70E740481C1C}">
-                <a14:useLocalDpi xmlns:a14="http://schemas.microsoft.com/office/drawing/2010/main" val="0"/>
-              </a:ext>
-            </a:extLst>
-          </a:blip>
-          <a:stretch>
-            <a:fillRect/>
-          </a:stretch>
-        </p:blipFill>
-        <p:spPr>
-          <a:xfrm>
-            <a:off x="88190" y="2818496"/>
-            <a:ext cx="351582" cy="351582"/>
-          </a:xfrm>
-          <a:prstGeom prst="rect">
-            <a:avLst/>
-          </a:prstGeom>
-        </p:spPr>
-      </p:pic>
-      <p:pic>
-        <p:nvPicPr>
-          <p:cNvPr id="25" name="Imagem 24" descr="Uma imagem contendo Ícone&#10;&#10;O conteúdo gerado por IA pode estar incorreto.">
-            <a:extLst>
-              <a:ext uri="{FF2B5EF4-FFF2-40B4-BE49-F238E27FC236}">
-                <a16:creationId xmlns:a16="http://schemas.microsoft.com/office/drawing/2014/main" id="{051AAF28-BE64-2963-26C1-A9BAE042C436}"/>
-              </a:ext>
-            </a:extLst>
-          </p:cNvPr>
-          <p:cNvPicPr>
-            <a:picLocks noChangeAspect="1"/>
-          </p:cNvPicPr>
-          <p:nvPr/>
-        </p:nvPicPr>
-        <p:blipFill>
-          <a:blip r:embed="rId5">
-            <a:extLst>
-              <a:ext uri="{28A0092B-C50C-407E-A947-70E740481C1C}">
-                <a14:useLocalDpi xmlns:a14="http://schemas.microsoft.com/office/drawing/2010/main" val="0"/>
-              </a:ext>
-            </a:extLst>
-          </a:blip>
-          <a:stretch>
-            <a:fillRect/>
-          </a:stretch>
-        </p:blipFill>
-        <p:spPr>
-          <a:xfrm flipH="1">
-            <a:off x="106392" y="1383777"/>
-            <a:ext cx="316754" cy="316754"/>
-          </a:xfrm>
-          <a:prstGeom prst="rect">
-            <a:avLst/>
-          </a:prstGeom>
-        </p:spPr>
-      </p:pic>
-      <p:pic>
-        <p:nvPicPr>
-          <p:cNvPr id="2" name="Imagem 1" descr="Ícone&#10;&#10;O conteúdo gerado por IA pode estar incorreto.">
-            <a:extLst>
-              <a:ext uri="{FF2B5EF4-FFF2-40B4-BE49-F238E27FC236}">
-                <a16:creationId xmlns:a16="http://schemas.microsoft.com/office/drawing/2014/main" id="{F84772A2-6E6B-2046-CC14-87C453A08288}"/>
-              </a:ext>
-            </a:extLst>
-          </p:cNvPr>
-          <p:cNvPicPr>
-            <a:picLocks noChangeAspect="1"/>
-          </p:cNvPicPr>
-          <p:nvPr/>
-        </p:nvPicPr>
-        <p:blipFill>
-          <a:blip r:embed="rId6">
-            <a:extLst>
-              <a:ext uri="{28A0092B-C50C-407E-A947-70E740481C1C}">
-                <a14:useLocalDpi xmlns:a14="http://schemas.microsoft.com/office/drawing/2010/main" val="0"/>
-              </a:ext>
-            </a:extLst>
-          </a:blip>
-          <a:stretch>
-            <a:fillRect/>
-          </a:stretch>
-        </p:blipFill>
-        <p:spPr>
-          <a:xfrm>
-            <a:off x="89891" y="2011480"/>
-            <a:ext cx="349882" cy="349882"/>
-          </a:xfrm>
-          <a:prstGeom prst="rect">
-            <a:avLst/>
-          </a:prstGeom>
-        </p:spPr>
-      </p:pic>
-      <p:sp>
-        <p:nvSpPr>
-          <p:cNvPr id="14" name="Retângulo: Cantos Arredondados 13">
-            <a:extLst>
-              <a:ext uri="{FF2B5EF4-FFF2-40B4-BE49-F238E27FC236}">
-                <a16:creationId xmlns:a16="http://schemas.microsoft.com/office/drawing/2014/main" id="{EFF8553D-EAEF-F549-5E1F-CDC7FB835C37}"/>
-              </a:ext>
-            </a:extLst>
-          </p:cNvPr>
-          <p:cNvSpPr/>
-          <p:nvPr/>
-        </p:nvSpPr>
-        <p:spPr>
-          <a:xfrm>
-            <a:off x="37037" y="4166760"/>
-            <a:ext cx="446056" cy="453228"/>
-          </a:xfrm>
-          <a:prstGeom prst="roundRect">
-            <a:avLst/>
-          </a:prstGeom>
-          <a:solidFill>
-            <a:schemeClr val="bg1"/>
-          </a:solidFill>
-          <a:ln>
-            <a:noFill/>
-          </a:ln>
-          <a:effectLst/>
-        </p:spPr>
-        <p:style>
-          <a:lnRef idx="2">
-            <a:schemeClr val="accent1">
-              <a:shade val="15000"/>
-            </a:schemeClr>
-          </a:lnRef>
-          <a:fillRef idx="1">
-            <a:schemeClr val="accent1"/>
-          </a:fillRef>
-          <a:effectRef idx="0">
-            <a:schemeClr val="accent1"/>
-          </a:effectRef>
-          <a:fontRef idx="minor">
-            <a:schemeClr val="lt1"/>
-          </a:fontRef>
-        </p:style>
-        <p:txBody>
-          <a:bodyPr rtlCol="0" anchor="ctr"/>
-          <a:lstStyle/>
-          <a:p>
-            <a:pPr algn="ctr"/>
-            <a:endParaRPr lang="pt-BR"/>
-          </a:p>
-        </p:txBody>
-      </p:sp>
-      <p:sp>
-        <p:nvSpPr>
-          <p:cNvPr id="15" name="Retângulo: Cantos Arredondados 14">
-            <a:extLst>
-              <a:ext uri="{FF2B5EF4-FFF2-40B4-BE49-F238E27FC236}">
-                <a16:creationId xmlns:a16="http://schemas.microsoft.com/office/drawing/2014/main" id="{EBB551E1-4917-9894-DB1D-5741D5A153E8}"/>
-              </a:ext>
-            </a:extLst>
-          </p:cNvPr>
-          <p:cNvSpPr/>
-          <p:nvPr/>
-        </p:nvSpPr>
-        <p:spPr>
-          <a:xfrm>
-            <a:off x="6569276" y="956414"/>
-            <a:ext cx="2387600" cy="1030940"/>
-          </a:xfrm>
-          <a:prstGeom prst="roundRect">
-            <a:avLst>
-              <a:gd name="adj" fmla="val 7416"/>
-            </a:avLst>
-          </a:prstGeom>
-          <a:solidFill>
-            <a:schemeClr val="bg1"/>
-          </a:solidFill>
-          <a:ln>
-            <a:noFill/>
-          </a:ln>
-          <a:effectLst>
-            <a:outerShdw blurRad="101600" dist="38100" dir="5400000" algn="t" rotWithShape="0">
-              <a:prstClr val="black">
-                <a:alpha val="20000"/>
-              </a:prstClr>
-            </a:outerShdw>
-          </a:effectLst>
-        </p:spPr>
-        <p:style>
-          <a:lnRef idx="2">
-            <a:schemeClr val="accent1">
-              <a:shade val="15000"/>
-            </a:schemeClr>
-          </a:lnRef>
-          <a:fillRef idx="1">
-            <a:schemeClr val="accent1"/>
-          </a:fillRef>
-          <a:effectRef idx="0">
-            <a:schemeClr val="accent1"/>
-          </a:effectRef>
-          <a:fontRef idx="minor">
-            <a:schemeClr val="lt1"/>
-          </a:fontRef>
-        </p:style>
-        <p:txBody>
-          <a:bodyPr rtlCol="0" anchor="ctr"/>
-          <a:lstStyle/>
-          <a:p>
-            <a:pPr algn="ctr"/>
-            <a:endParaRPr lang="pt-BR"/>
-          </a:p>
-        </p:txBody>
-      </p:sp>
-      <p:sp>
-        <p:nvSpPr>
-          <p:cNvPr id="17" name="Retângulo: Cantos Arredondados 16">
-            <a:extLst>
-              <a:ext uri="{FF2B5EF4-FFF2-40B4-BE49-F238E27FC236}">
-                <a16:creationId xmlns:a16="http://schemas.microsoft.com/office/drawing/2014/main" id="{AA5E8FD0-03A6-7583-06CB-B7BBA41C78BB}"/>
-              </a:ext>
-            </a:extLst>
-          </p:cNvPr>
-          <p:cNvSpPr/>
-          <p:nvPr/>
-        </p:nvSpPr>
-        <p:spPr>
-          <a:xfrm>
-            <a:off x="8595360" y="980374"/>
-            <a:ext cx="322119" cy="342633"/>
-          </a:xfrm>
-          <a:prstGeom prst="roundRect">
-            <a:avLst>
-              <a:gd name="adj" fmla="val 35127"/>
-            </a:avLst>
-          </a:prstGeom>
-          <a:solidFill>
-            <a:srgbClr val="2F3A5F">
-              <a:alpha val="18000"/>
-            </a:srgbClr>
-          </a:solidFill>
-          <a:ln>
-            <a:noFill/>
-          </a:ln>
-        </p:spPr>
-        <p:style>
-          <a:lnRef idx="2">
-            <a:schemeClr val="accent1">
-              <a:shade val="15000"/>
-            </a:schemeClr>
-          </a:lnRef>
-          <a:fillRef idx="1">
-            <a:schemeClr val="accent1"/>
-          </a:fillRef>
-          <a:effectRef idx="0">
-            <a:schemeClr val="accent1"/>
-          </a:effectRef>
-          <a:fontRef idx="minor">
-            <a:schemeClr val="lt1"/>
-          </a:fontRef>
-        </p:style>
-        <p:txBody>
-          <a:bodyPr rtlCol="0" anchor="ctr"/>
-          <a:lstStyle/>
-          <a:p>
-            <a:pPr algn="ctr"/>
-            <a:endParaRPr lang="pt-BR"/>
-          </a:p>
-        </p:txBody>
-      </p:sp>
-      <p:sp>
-        <p:nvSpPr>
-          <p:cNvPr id="3" name="Retângulo: Cantos Arredondados 2">
-            <a:extLst>
-              <a:ext uri="{FF2B5EF4-FFF2-40B4-BE49-F238E27FC236}">
-                <a16:creationId xmlns:a16="http://schemas.microsoft.com/office/drawing/2014/main" id="{5E061774-4590-B555-8F7E-EE1C9230BAAF}"/>
-              </a:ext>
-            </a:extLst>
-          </p:cNvPr>
-          <p:cNvSpPr/>
-          <p:nvPr/>
-        </p:nvSpPr>
-        <p:spPr>
-          <a:xfrm>
-            <a:off x="6520073" y="4820477"/>
-            <a:ext cx="5266984" cy="1921835"/>
-          </a:xfrm>
-          <a:prstGeom prst="roundRect">
-            <a:avLst>
-              <a:gd name="adj" fmla="val 4729"/>
-            </a:avLst>
-          </a:prstGeom>
-          <a:solidFill>
-            <a:schemeClr val="bg1"/>
-          </a:solidFill>
-          <a:ln>
-            <a:noFill/>
-          </a:ln>
-          <a:effectLst>
-            <a:outerShdw blurRad="101600" dist="38100" dir="5400000" algn="t" rotWithShape="0">
-              <a:prstClr val="black">
-                <a:alpha val="20000"/>
-              </a:prstClr>
-            </a:outerShdw>
-          </a:effectLst>
-        </p:spPr>
-        <p:style>
-          <a:lnRef idx="2">
-            <a:schemeClr val="accent1">
-              <a:shade val="15000"/>
-            </a:schemeClr>
-          </a:lnRef>
-          <a:fillRef idx="1">
-            <a:schemeClr val="accent1"/>
-          </a:fillRef>
-          <a:effectRef idx="0">
-            <a:schemeClr val="accent1"/>
-          </a:effectRef>
-          <a:fontRef idx="minor">
-            <a:schemeClr val="lt1"/>
-          </a:fontRef>
-        </p:style>
-        <p:txBody>
-          <a:bodyPr rtlCol="0" anchor="ctr"/>
-          <a:lstStyle/>
-          <a:p>
-            <a:pPr algn="ctr"/>
-            <a:endParaRPr lang="pt-BR"/>
-          </a:p>
-        </p:txBody>
-      </p:sp>
-      <p:pic>
-        <p:nvPicPr>
-          <p:cNvPr id="9" name="Imagem 8">
-            <a:extLst>
-              <a:ext uri="{FF2B5EF4-FFF2-40B4-BE49-F238E27FC236}">
-                <a16:creationId xmlns:a16="http://schemas.microsoft.com/office/drawing/2014/main" id="{4F6AB766-79D7-D63F-3486-A71C2CFE23F7}"/>
-              </a:ext>
-            </a:extLst>
-          </p:cNvPr>
-          <p:cNvPicPr>
-            <a:picLocks noChangeAspect="1"/>
-          </p:cNvPicPr>
-          <p:nvPr/>
-        </p:nvPicPr>
-        <p:blipFill>
-          <a:blip r:embed="rId7">
-            <a:extLst>
-              <a:ext uri="{28A0092B-C50C-407E-A947-70E740481C1C}">
-                <a14:useLocalDpi xmlns:a14="http://schemas.microsoft.com/office/drawing/2010/main" val="0"/>
-              </a:ext>
-            </a:extLst>
-          </a:blip>
-          <a:stretch>
-            <a:fillRect/>
-          </a:stretch>
-        </p:blipFill>
-        <p:spPr>
-          <a:xfrm>
-            <a:off x="5807887" y="1003957"/>
-            <a:ext cx="319050" cy="319050"/>
-          </a:xfrm>
-          <a:prstGeom prst="rect">
-            <a:avLst/>
-          </a:prstGeom>
-        </p:spPr>
-      </p:pic>
-      <p:pic>
-        <p:nvPicPr>
-          <p:cNvPr id="18" name="Imagem 17">
-            <a:extLst>
-              <a:ext uri="{FF2B5EF4-FFF2-40B4-BE49-F238E27FC236}">
-                <a16:creationId xmlns:a16="http://schemas.microsoft.com/office/drawing/2014/main" id="{BE3E089E-5C06-397F-5F29-0638F03EA5C7}"/>
-              </a:ext>
-            </a:extLst>
-          </p:cNvPr>
-          <p:cNvPicPr>
-            <a:picLocks noChangeAspect="1"/>
-          </p:cNvPicPr>
-          <p:nvPr/>
-        </p:nvPicPr>
-        <p:blipFill>
-          <a:blip r:embed="rId8">
-            <a:extLst>
-              <a:ext uri="{28A0092B-C50C-407E-A947-70E740481C1C}">
-                <a14:useLocalDpi xmlns:a14="http://schemas.microsoft.com/office/drawing/2010/main" val="0"/>
-              </a:ext>
-            </a:extLst>
-          </a:blip>
-          <a:stretch>
-            <a:fillRect/>
-          </a:stretch>
-        </p:blipFill>
-        <p:spPr>
-          <a:xfrm>
-            <a:off x="8620355" y="1009428"/>
-            <a:ext cx="272128" cy="272128"/>
-          </a:xfrm>
-          <a:prstGeom prst="rect">
-            <a:avLst/>
-          </a:prstGeom>
-        </p:spPr>
-      </p:pic>
-      <p:pic>
-        <p:nvPicPr>
-          <p:cNvPr id="20" name="Imagem 19">
-            <a:extLst>
-              <a:ext uri="{FF2B5EF4-FFF2-40B4-BE49-F238E27FC236}">
-                <a16:creationId xmlns:a16="http://schemas.microsoft.com/office/drawing/2014/main" id="{7BF3E331-A1F1-7DEF-DE71-54409DD4BA07}"/>
-              </a:ext>
-            </a:extLst>
-          </p:cNvPr>
-          <p:cNvPicPr>
-            <a:picLocks noChangeAspect="1"/>
-          </p:cNvPicPr>
-          <p:nvPr/>
-        </p:nvPicPr>
-        <p:blipFill>
-          <a:blip r:embed="rId9">
-            <a:extLst>
-              <a:ext uri="{28A0092B-C50C-407E-A947-70E740481C1C}">
-                <a14:useLocalDpi xmlns:a14="http://schemas.microsoft.com/office/drawing/2010/main" val="0"/>
-              </a:ext>
-            </a:extLst>
-          </a:blip>
-          <a:stretch>
-            <a:fillRect/>
-          </a:stretch>
-        </p:blipFill>
-        <p:spPr>
-          <a:xfrm>
-            <a:off x="11418889" y="999785"/>
-            <a:ext cx="306401" cy="299621"/>
-          </a:xfrm>
-          <a:prstGeom prst="rect">
-            <a:avLst/>
-          </a:prstGeom>
-        </p:spPr>
-      </p:pic>
-      <p:pic>
-        <p:nvPicPr>
-          <p:cNvPr id="27" name="Imagem 26">
-            <a:extLst>
-              <a:ext uri="{FF2B5EF4-FFF2-40B4-BE49-F238E27FC236}">
-                <a16:creationId xmlns:a16="http://schemas.microsoft.com/office/drawing/2014/main" id="{91E82AE5-3936-2E6B-DD4B-7FA515020CA7}"/>
-              </a:ext>
-            </a:extLst>
-          </p:cNvPr>
-          <p:cNvPicPr>
-            <a:picLocks noChangeAspect="1"/>
-          </p:cNvPicPr>
-          <p:nvPr/>
-        </p:nvPicPr>
-        <p:blipFill>
-          <a:blip r:embed="rId10">
-            <a:extLst>
-              <a:ext uri="{28A0092B-C50C-407E-A947-70E740481C1C}">
-                <a14:useLocalDpi xmlns:a14="http://schemas.microsoft.com/office/drawing/2010/main" val="0"/>
-              </a:ext>
-            </a:extLst>
-          </a:blip>
-          <a:stretch>
-            <a:fillRect/>
-          </a:stretch>
-        </p:blipFill>
-        <p:spPr>
-          <a:xfrm>
-            <a:off x="73061" y="4194810"/>
-            <a:ext cx="350085" cy="350085"/>
-          </a:xfrm>
-          <a:prstGeom prst="rect">
-            <a:avLst/>
-          </a:prstGeom>
-        </p:spPr>
-      </p:pic>
-      <p:pic>
-        <p:nvPicPr>
-          <p:cNvPr id="28" name="Imagem 27" descr="Logotipo, Ícone&#10;&#10;O conteúdo gerado por IA pode estar incorreto.">
-            <a:extLst>
-              <a:ext uri="{FF2B5EF4-FFF2-40B4-BE49-F238E27FC236}">
-                <a16:creationId xmlns:a16="http://schemas.microsoft.com/office/drawing/2014/main" id="{F2CAEE1F-0FA9-0834-8978-90FC2BDBAD9D}"/>
-              </a:ext>
-            </a:extLst>
-          </p:cNvPr>
-          <p:cNvPicPr>
-            <a:picLocks noChangeAspect="1"/>
-          </p:cNvPicPr>
-          <p:nvPr/>
-        </p:nvPicPr>
-        <p:blipFill>
-          <a:blip r:embed="rId11">
-            <a:extLst>
-              <a:ext uri="{28A0092B-C50C-407E-A947-70E740481C1C}">
-                <a14:useLocalDpi xmlns:a14="http://schemas.microsoft.com/office/drawing/2010/main" val="0"/>
-              </a:ext>
-            </a:extLst>
-          </a:blip>
-          <a:stretch>
-            <a:fillRect/>
-          </a:stretch>
-        </p:blipFill>
-        <p:spPr>
-          <a:xfrm>
-            <a:off x="88190" y="3505929"/>
-            <a:ext cx="351582" cy="351582"/>
-          </a:xfrm>
-          <a:prstGeom prst="rect">
-            <a:avLst/>
-          </a:prstGeom>
-        </p:spPr>
-      </p:pic>
-    </p:spTree>
-    <p:extLst>
-      <p:ext uri="{BB962C8B-B14F-4D97-AF65-F5344CB8AC3E}">
-        <p14:creationId xmlns:p14="http://schemas.microsoft.com/office/powerpoint/2010/main" val="1380647514"/>
-      </p:ext>
-    </p:extLst>
-  </p:cSld>
-  <p:clrMapOvr>
-    <a:masterClrMapping/>
-  </p:clrMapOvr>
-</p:sld>
-</file>
-
-<file path=ppt/slides/slide5.xml><?xml version="1.0" encoding="utf-8"?>
-<p:sld xmlns:a="http://schemas.openxmlformats.org/drawingml/2006/main" xmlns:r="http://schemas.openxmlformats.org/officeDocument/2006/relationships" xmlns:p="http://schemas.openxmlformats.org/presentationml/2006/main">
-  <p:cSld>
-    <p:spTree>
-      <p:nvGrpSpPr>
-        <p:cNvPr id="1" name="">
-          <a:extLst>
-            <a:ext uri="{FF2B5EF4-FFF2-40B4-BE49-F238E27FC236}">
-              <a16:creationId xmlns:a16="http://schemas.microsoft.com/office/drawing/2014/main" id="{15DECBDB-F3F2-5610-5392-29AE714A762D}"/>
-            </a:ext>
-          </a:extLst>
-        </p:cNvPr>
-        <p:cNvGrpSpPr/>
-        <p:nvPr/>
-      </p:nvGrpSpPr>
-      <p:grpSpPr>
-        <a:xfrm>
-          <a:off x="0" y="0"/>
-          <a:ext cx="0" cy="0"/>
-          <a:chOff x="0" y="0"/>
-          <a:chExt cx="0" cy="0"/>
-        </a:xfrm>
-      </p:grpSpPr>
-      <p:sp>
-        <p:nvSpPr>
-          <p:cNvPr id="33" name="Retângulo: Cantos Arredondados 32">
-            <a:extLst>
-              <a:ext uri="{FF2B5EF4-FFF2-40B4-BE49-F238E27FC236}">
-                <a16:creationId xmlns:a16="http://schemas.microsoft.com/office/drawing/2014/main" id="{B2F546BD-164B-0210-2D43-A689121D62BC}"/>
-              </a:ext>
-            </a:extLst>
-          </p:cNvPr>
-          <p:cNvSpPr/>
-          <p:nvPr/>
-        </p:nvSpPr>
-        <p:spPr>
-          <a:xfrm>
-            <a:off x="0" y="0"/>
-            <a:ext cx="12192000" cy="6858000"/>
-          </a:xfrm>
-          <a:prstGeom prst="roundRect">
-            <a:avLst>
-              <a:gd name="adj" fmla="val 4058"/>
-            </a:avLst>
-          </a:prstGeom>
-          <a:solidFill>
-            <a:srgbClr val="F3F4F8"/>
-          </a:solidFill>
-          <a:ln>
-            <a:noFill/>
-          </a:ln>
-        </p:spPr>
-        <p:style>
-          <a:lnRef idx="2">
-            <a:schemeClr val="accent1">
-              <a:shade val="15000"/>
-            </a:schemeClr>
-          </a:lnRef>
-          <a:fillRef idx="1">
-            <a:schemeClr val="accent1"/>
-          </a:fillRef>
-          <a:effectRef idx="0">
-            <a:schemeClr val="accent1"/>
-          </a:effectRef>
-          <a:fontRef idx="minor">
-            <a:schemeClr val="lt1"/>
-          </a:fontRef>
-        </p:style>
-        <p:txBody>
-          <a:bodyPr rtlCol="0" anchor="ctr"/>
-          <a:lstStyle/>
-          <a:p>
-            <a:endParaRPr lang="pt-BR"/>
-          </a:p>
-        </p:txBody>
-      </p:sp>
-      <p:sp>
-        <p:nvSpPr>
-          <p:cNvPr id="5" name="Retângulo: Cantos Arredondados 4">
-            <a:extLst>
-              <a:ext uri="{FF2B5EF4-FFF2-40B4-BE49-F238E27FC236}">
-                <a16:creationId xmlns:a16="http://schemas.microsoft.com/office/drawing/2014/main" id="{E52B59DA-7444-A952-44E2-0A5A647FC95B}"/>
-              </a:ext>
-            </a:extLst>
-          </p:cNvPr>
-          <p:cNvSpPr/>
-          <p:nvPr/>
-        </p:nvSpPr>
-        <p:spPr>
-          <a:xfrm>
-            <a:off x="-177079" y="897622"/>
-            <a:ext cx="715733" cy="4337108"/>
-          </a:xfrm>
-          <a:prstGeom prst="roundRect">
-            <a:avLst/>
-          </a:prstGeom>
-          <a:solidFill>
-            <a:srgbClr val="010A52"/>
-          </a:solidFill>
-          <a:ln>
-            <a:noFill/>
-          </a:ln>
-          <a:effectLst>
-            <a:outerShdw blurRad="101600" dist="38100" dir="5400000" algn="t" rotWithShape="0">
-              <a:prstClr val="black">
-                <a:alpha val="20000"/>
-              </a:prstClr>
-            </a:outerShdw>
-          </a:effectLst>
-        </p:spPr>
-        <p:style>
-          <a:lnRef idx="2">
-            <a:schemeClr val="accent1">
-              <a:shade val="15000"/>
-            </a:schemeClr>
-          </a:lnRef>
-          <a:fillRef idx="1">
-            <a:schemeClr val="accent1"/>
-          </a:fillRef>
-          <a:effectRef idx="0">
-            <a:schemeClr val="accent1"/>
-          </a:effectRef>
-          <a:fontRef idx="minor">
-            <a:schemeClr val="lt1"/>
-          </a:fontRef>
-        </p:style>
-        <p:txBody>
-          <a:bodyPr rtlCol="0" anchor="ctr"/>
-          <a:lstStyle/>
-          <a:p>
-            <a:pPr algn="ctr"/>
-            <a:endParaRPr lang="pt-BR"/>
-          </a:p>
-        </p:txBody>
-      </p:sp>
-      <p:sp>
-        <p:nvSpPr>
-          <p:cNvPr id="43" name="Retângulo: Cantos Arredondados 42">
-            <a:extLst>
-              <a:ext uri="{FF2B5EF4-FFF2-40B4-BE49-F238E27FC236}">
-                <a16:creationId xmlns:a16="http://schemas.microsoft.com/office/drawing/2014/main" id="{34BB365B-6C57-DFDB-CEAE-61898CBB0450}"/>
-              </a:ext>
-            </a:extLst>
-          </p:cNvPr>
-          <p:cNvSpPr/>
-          <p:nvPr/>
-        </p:nvSpPr>
-        <p:spPr>
-          <a:xfrm>
-            <a:off x="-1170" y="-45343"/>
-            <a:ext cx="12233684" cy="853130"/>
-          </a:xfrm>
-          <a:custGeom>
-            <a:avLst/>
-            <a:gdLst>
-              <a:gd name="connsiteX0" fmla="*/ 0 w 12192000"/>
-              <a:gd name="connsiteY0" fmla="*/ 245786 h 491571"/>
-              <a:gd name="connsiteX1" fmla="*/ 245786 w 12192000"/>
-              <a:gd name="connsiteY1" fmla="*/ 0 h 491571"/>
-              <a:gd name="connsiteX2" fmla="*/ 11946215 w 12192000"/>
-              <a:gd name="connsiteY2" fmla="*/ 0 h 491571"/>
-              <a:gd name="connsiteX3" fmla="*/ 12192001 w 12192000"/>
-              <a:gd name="connsiteY3" fmla="*/ 245786 h 491571"/>
-              <a:gd name="connsiteX4" fmla="*/ 12192000 w 12192000"/>
-              <a:gd name="connsiteY4" fmla="*/ 245786 h 491571"/>
-              <a:gd name="connsiteX5" fmla="*/ 11946214 w 12192000"/>
-              <a:gd name="connsiteY5" fmla="*/ 491572 h 491571"/>
-              <a:gd name="connsiteX6" fmla="*/ 245786 w 12192000"/>
-              <a:gd name="connsiteY6" fmla="*/ 491571 h 491571"/>
-              <a:gd name="connsiteX7" fmla="*/ 0 w 12192000"/>
-              <a:gd name="connsiteY7" fmla="*/ 245785 h 491571"/>
-              <a:gd name="connsiteX8" fmla="*/ 0 w 12192000"/>
-              <a:gd name="connsiteY8" fmla="*/ 245786 h 491571"/>
-              <a:gd name="connsiteX0" fmla="*/ 8746 w 12200747"/>
-              <a:gd name="connsiteY0" fmla="*/ 245786 h 525126"/>
-              <a:gd name="connsiteX1" fmla="*/ 254532 w 12200747"/>
-              <a:gd name="connsiteY1" fmla="*/ 0 h 525126"/>
-              <a:gd name="connsiteX2" fmla="*/ 11954961 w 12200747"/>
-              <a:gd name="connsiteY2" fmla="*/ 0 h 525126"/>
-              <a:gd name="connsiteX3" fmla="*/ 12200747 w 12200747"/>
-              <a:gd name="connsiteY3" fmla="*/ 245786 h 525126"/>
-              <a:gd name="connsiteX4" fmla="*/ 12200746 w 12200747"/>
-              <a:gd name="connsiteY4" fmla="*/ 245786 h 525126"/>
-              <a:gd name="connsiteX5" fmla="*/ 11954960 w 12200747"/>
-              <a:gd name="connsiteY5" fmla="*/ 491572 h 525126"/>
-              <a:gd name="connsiteX6" fmla="*/ 95141 w 12200747"/>
-              <a:gd name="connsiteY6" fmla="*/ 525126 h 525126"/>
-              <a:gd name="connsiteX7" fmla="*/ 8746 w 12200747"/>
-              <a:gd name="connsiteY7" fmla="*/ 245785 h 525126"/>
-              <a:gd name="connsiteX8" fmla="*/ 8746 w 12200747"/>
-              <a:gd name="connsiteY8" fmla="*/ 245786 h 525126"/>
-              <a:gd name="connsiteX0" fmla="*/ 7009 w 12199010"/>
-              <a:gd name="connsiteY0" fmla="*/ 245786 h 539413"/>
-              <a:gd name="connsiteX1" fmla="*/ 252795 w 12199010"/>
-              <a:gd name="connsiteY1" fmla="*/ 0 h 539413"/>
-              <a:gd name="connsiteX2" fmla="*/ 11953224 w 12199010"/>
-              <a:gd name="connsiteY2" fmla="*/ 0 h 539413"/>
-              <a:gd name="connsiteX3" fmla="*/ 12199010 w 12199010"/>
-              <a:gd name="connsiteY3" fmla="*/ 245786 h 539413"/>
-              <a:gd name="connsiteX4" fmla="*/ 12199009 w 12199010"/>
-              <a:gd name="connsiteY4" fmla="*/ 245786 h 539413"/>
-              <a:gd name="connsiteX5" fmla="*/ 11953223 w 12199010"/>
-              <a:gd name="connsiteY5" fmla="*/ 491572 h 539413"/>
-              <a:gd name="connsiteX6" fmla="*/ 98167 w 12199010"/>
-              <a:gd name="connsiteY6" fmla="*/ 539413 h 539413"/>
-              <a:gd name="connsiteX7" fmla="*/ 7009 w 12199010"/>
-              <a:gd name="connsiteY7" fmla="*/ 245785 h 539413"/>
-              <a:gd name="connsiteX8" fmla="*/ 7009 w 12199010"/>
-              <a:gd name="connsiteY8" fmla="*/ 245786 h 539413"/>
-              <a:gd name="connsiteX0" fmla="*/ 4473 w 12196474"/>
-              <a:gd name="connsiteY0" fmla="*/ 245786 h 539439"/>
-              <a:gd name="connsiteX1" fmla="*/ 250259 w 12196474"/>
-              <a:gd name="connsiteY1" fmla="*/ 0 h 539439"/>
-              <a:gd name="connsiteX2" fmla="*/ 11950688 w 12196474"/>
-              <a:gd name="connsiteY2" fmla="*/ 0 h 539439"/>
-              <a:gd name="connsiteX3" fmla="*/ 12196474 w 12196474"/>
-              <a:gd name="connsiteY3" fmla="*/ 245786 h 539439"/>
-              <a:gd name="connsiteX4" fmla="*/ 12196473 w 12196474"/>
-              <a:gd name="connsiteY4" fmla="*/ 245786 h 539439"/>
-              <a:gd name="connsiteX5" fmla="*/ 11950687 w 12196474"/>
-              <a:gd name="connsiteY5" fmla="*/ 491572 h 539439"/>
-              <a:gd name="connsiteX6" fmla="*/ 95631 w 12196474"/>
-              <a:gd name="connsiteY6" fmla="*/ 539413 h 539439"/>
-              <a:gd name="connsiteX7" fmla="*/ 4473 w 12196474"/>
-              <a:gd name="connsiteY7" fmla="*/ 245785 h 539439"/>
-              <a:gd name="connsiteX8" fmla="*/ 4473 w 12196474"/>
-              <a:gd name="connsiteY8" fmla="*/ 245786 h 539439"/>
-              <a:gd name="connsiteX0" fmla="*/ 48673 w 12240674"/>
-              <a:gd name="connsiteY0" fmla="*/ 245786 h 539439"/>
-              <a:gd name="connsiteX1" fmla="*/ 294459 w 12240674"/>
-              <a:gd name="connsiteY1" fmla="*/ 0 h 539439"/>
-              <a:gd name="connsiteX2" fmla="*/ 11994888 w 12240674"/>
-              <a:gd name="connsiteY2" fmla="*/ 0 h 539439"/>
-              <a:gd name="connsiteX3" fmla="*/ 12240674 w 12240674"/>
-              <a:gd name="connsiteY3" fmla="*/ 245786 h 539439"/>
-              <a:gd name="connsiteX4" fmla="*/ 12240673 w 12240674"/>
-              <a:gd name="connsiteY4" fmla="*/ 245786 h 539439"/>
-              <a:gd name="connsiteX5" fmla="*/ 11994887 w 12240674"/>
-              <a:gd name="connsiteY5" fmla="*/ 491572 h 539439"/>
-              <a:gd name="connsiteX6" fmla="*/ 58868 w 12240674"/>
-              <a:gd name="connsiteY6" fmla="*/ 539413 h 539439"/>
-              <a:gd name="connsiteX7" fmla="*/ 48673 w 12240674"/>
-              <a:gd name="connsiteY7" fmla="*/ 245785 h 539439"/>
-              <a:gd name="connsiteX8" fmla="*/ 48673 w 12240674"/>
-              <a:gd name="connsiteY8" fmla="*/ 245786 h 539439"/>
-              <a:gd name="connsiteX0" fmla="*/ 0 w 12192001"/>
-              <a:gd name="connsiteY0" fmla="*/ 245786 h 540522"/>
-              <a:gd name="connsiteX1" fmla="*/ 245786 w 12192001"/>
-              <a:gd name="connsiteY1" fmla="*/ 0 h 540522"/>
-              <a:gd name="connsiteX2" fmla="*/ 11946215 w 12192001"/>
-              <a:gd name="connsiteY2" fmla="*/ 0 h 540522"/>
-              <a:gd name="connsiteX3" fmla="*/ 12192001 w 12192001"/>
-              <a:gd name="connsiteY3" fmla="*/ 245786 h 540522"/>
-              <a:gd name="connsiteX4" fmla="*/ 12192000 w 12192001"/>
-              <a:gd name="connsiteY4" fmla="*/ 245786 h 540522"/>
-              <a:gd name="connsiteX5" fmla="*/ 11946214 w 12192001"/>
-              <a:gd name="connsiteY5" fmla="*/ 491572 h 540522"/>
-              <a:gd name="connsiteX6" fmla="*/ 10195 w 12192001"/>
-              <a:gd name="connsiteY6" fmla="*/ 539413 h 540522"/>
-              <a:gd name="connsiteX7" fmla="*/ 0 w 12192001"/>
-              <a:gd name="connsiteY7" fmla="*/ 245785 h 540522"/>
-              <a:gd name="connsiteX8" fmla="*/ 0 w 12192001"/>
-              <a:gd name="connsiteY8" fmla="*/ 245786 h 540522"/>
-              <a:gd name="connsiteX0" fmla="*/ 1172 w 12193173"/>
-              <a:gd name="connsiteY0" fmla="*/ 245786 h 540522"/>
-              <a:gd name="connsiteX1" fmla="*/ 246958 w 12193173"/>
-              <a:gd name="connsiteY1" fmla="*/ 0 h 540522"/>
-              <a:gd name="connsiteX2" fmla="*/ 11947387 w 12193173"/>
-              <a:gd name="connsiteY2" fmla="*/ 0 h 540522"/>
-              <a:gd name="connsiteX3" fmla="*/ 12193173 w 12193173"/>
-              <a:gd name="connsiteY3" fmla="*/ 245786 h 540522"/>
-              <a:gd name="connsiteX4" fmla="*/ 12193172 w 12193173"/>
-              <a:gd name="connsiteY4" fmla="*/ 245786 h 540522"/>
-              <a:gd name="connsiteX5" fmla="*/ 11947386 w 12193173"/>
-              <a:gd name="connsiteY5" fmla="*/ 491572 h 540522"/>
-              <a:gd name="connsiteX6" fmla="*/ 4223 w 12193173"/>
-              <a:gd name="connsiteY6" fmla="*/ 539413 h 540522"/>
-              <a:gd name="connsiteX7" fmla="*/ 1172 w 12193173"/>
-              <a:gd name="connsiteY7" fmla="*/ 245785 h 540522"/>
-              <a:gd name="connsiteX8" fmla="*/ 1172 w 12193173"/>
-              <a:gd name="connsiteY8" fmla="*/ 245786 h 540522"/>
-              <a:gd name="connsiteX0" fmla="*/ 1172 w 12231428"/>
-              <a:gd name="connsiteY0" fmla="*/ 245786 h 540522"/>
-              <a:gd name="connsiteX1" fmla="*/ 246958 w 12231428"/>
-              <a:gd name="connsiteY1" fmla="*/ 0 h 540522"/>
-              <a:gd name="connsiteX2" fmla="*/ 11947387 w 12231428"/>
-              <a:gd name="connsiteY2" fmla="*/ 0 h 540522"/>
-              <a:gd name="connsiteX3" fmla="*/ 12193173 w 12231428"/>
-              <a:gd name="connsiteY3" fmla="*/ 245786 h 540522"/>
-              <a:gd name="connsiteX4" fmla="*/ 12193172 w 12231428"/>
-              <a:gd name="connsiteY4" fmla="*/ 245786 h 540522"/>
-              <a:gd name="connsiteX5" fmla="*/ 12161698 w 12231428"/>
-              <a:gd name="connsiteY5" fmla="*/ 486810 h 540522"/>
-              <a:gd name="connsiteX6" fmla="*/ 4223 w 12231428"/>
-              <a:gd name="connsiteY6" fmla="*/ 539413 h 540522"/>
-              <a:gd name="connsiteX7" fmla="*/ 1172 w 12231428"/>
-              <a:gd name="connsiteY7" fmla="*/ 245785 h 540522"/>
-              <a:gd name="connsiteX8" fmla="*/ 1172 w 12231428"/>
-              <a:gd name="connsiteY8" fmla="*/ 245786 h 540522"/>
-              <a:gd name="connsiteX0" fmla="*/ 1172 w 12195146"/>
-              <a:gd name="connsiteY0" fmla="*/ 245786 h 540522"/>
-              <a:gd name="connsiteX1" fmla="*/ 246958 w 12195146"/>
-              <a:gd name="connsiteY1" fmla="*/ 0 h 540522"/>
-              <a:gd name="connsiteX2" fmla="*/ 11947387 w 12195146"/>
-              <a:gd name="connsiteY2" fmla="*/ 0 h 540522"/>
-              <a:gd name="connsiteX3" fmla="*/ 12193173 w 12195146"/>
-              <a:gd name="connsiteY3" fmla="*/ 245786 h 540522"/>
-              <a:gd name="connsiteX4" fmla="*/ 12193172 w 12195146"/>
-              <a:gd name="connsiteY4" fmla="*/ 245786 h 540522"/>
-              <a:gd name="connsiteX5" fmla="*/ 12161698 w 12195146"/>
-              <a:gd name="connsiteY5" fmla="*/ 486810 h 540522"/>
-              <a:gd name="connsiteX6" fmla="*/ 4223 w 12195146"/>
-              <a:gd name="connsiteY6" fmla="*/ 539413 h 540522"/>
-              <a:gd name="connsiteX7" fmla="*/ 1172 w 12195146"/>
-              <a:gd name="connsiteY7" fmla="*/ 245785 h 540522"/>
-              <a:gd name="connsiteX8" fmla="*/ 1172 w 12195146"/>
-              <a:gd name="connsiteY8" fmla="*/ 245786 h 540522"/>
-              <a:gd name="connsiteX0" fmla="*/ 1172 w 12244277"/>
-              <a:gd name="connsiteY0" fmla="*/ 245786 h 540522"/>
-              <a:gd name="connsiteX1" fmla="*/ 246958 w 12244277"/>
-              <a:gd name="connsiteY1" fmla="*/ 0 h 540522"/>
-              <a:gd name="connsiteX2" fmla="*/ 11947387 w 12244277"/>
-              <a:gd name="connsiteY2" fmla="*/ 0 h 540522"/>
-              <a:gd name="connsiteX3" fmla="*/ 12193173 w 12244277"/>
-              <a:gd name="connsiteY3" fmla="*/ 245786 h 540522"/>
-              <a:gd name="connsiteX4" fmla="*/ 12193172 w 12244277"/>
-              <a:gd name="connsiteY4" fmla="*/ 245786 h 540522"/>
-              <a:gd name="connsiteX5" fmla="*/ 12230754 w 12244277"/>
-              <a:gd name="connsiteY5" fmla="*/ 484428 h 540522"/>
-              <a:gd name="connsiteX6" fmla="*/ 4223 w 12244277"/>
-              <a:gd name="connsiteY6" fmla="*/ 539413 h 540522"/>
-              <a:gd name="connsiteX7" fmla="*/ 1172 w 12244277"/>
-              <a:gd name="connsiteY7" fmla="*/ 245785 h 540522"/>
-              <a:gd name="connsiteX8" fmla="*/ 1172 w 12244277"/>
-              <a:gd name="connsiteY8" fmla="*/ 245786 h 540522"/>
-              <a:gd name="connsiteX0" fmla="*/ 1172 w 12222094"/>
-              <a:gd name="connsiteY0" fmla="*/ 245786 h 540522"/>
-              <a:gd name="connsiteX1" fmla="*/ 246958 w 12222094"/>
-              <a:gd name="connsiteY1" fmla="*/ 0 h 540522"/>
-              <a:gd name="connsiteX2" fmla="*/ 11947387 w 12222094"/>
-              <a:gd name="connsiteY2" fmla="*/ 0 h 540522"/>
-              <a:gd name="connsiteX3" fmla="*/ 12193173 w 12222094"/>
-              <a:gd name="connsiteY3" fmla="*/ 245786 h 540522"/>
-              <a:gd name="connsiteX4" fmla="*/ 12193172 w 12222094"/>
-              <a:gd name="connsiteY4" fmla="*/ 245786 h 540522"/>
-              <a:gd name="connsiteX5" fmla="*/ 12204561 w 12222094"/>
-              <a:gd name="connsiteY5" fmla="*/ 489190 h 540522"/>
-              <a:gd name="connsiteX6" fmla="*/ 4223 w 12222094"/>
-              <a:gd name="connsiteY6" fmla="*/ 539413 h 540522"/>
-              <a:gd name="connsiteX7" fmla="*/ 1172 w 12222094"/>
-              <a:gd name="connsiteY7" fmla="*/ 245785 h 540522"/>
-              <a:gd name="connsiteX8" fmla="*/ 1172 w 12222094"/>
-              <a:gd name="connsiteY8" fmla="*/ 245786 h 540522"/>
-              <a:gd name="connsiteX0" fmla="*/ 1172 w 12207823"/>
-              <a:gd name="connsiteY0" fmla="*/ 245786 h 540522"/>
-              <a:gd name="connsiteX1" fmla="*/ 246958 w 12207823"/>
-              <a:gd name="connsiteY1" fmla="*/ 0 h 540522"/>
-              <a:gd name="connsiteX2" fmla="*/ 11947387 w 12207823"/>
-              <a:gd name="connsiteY2" fmla="*/ 0 h 540522"/>
-              <a:gd name="connsiteX3" fmla="*/ 12193173 w 12207823"/>
-              <a:gd name="connsiteY3" fmla="*/ 245786 h 540522"/>
-              <a:gd name="connsiteX4" fmla="*/ 12193172 w 12207823"/>
-              <a:gd name="connsiteY4" fmla="*/ 245786 h 540522"/>
-              <a:gd name="connsiteX5" fmla="*/ 12185511 w 12207823"/>
-              <a:gd name="connsiteY5" fmla="*/ 491571 h 540522"/>
-              <a:gd name="connsiteX6" fmla="*/ 4223 w 12207823"/>
-              <a:gd name="connsiteY6" fmla="*/ 539413 h 540522"/>
-              <a:gd name="connsiteX7" fmla="*/ 1172 w 12207823"/>
-              <a:gd name="connsiteY7" fmla="*/ 245785 h 540522"/>
-              <a:gd name="connsiteX8" fmla="*/ 1172 w 12207823"/>
-              <a:gd name="connsiteY8" fmla="*/ 245786 h 540522"/>
-              <a:gd name="connsiteX0" fmla="*/ 1172 w 12202618"/>
-              <a:gd name="connsiteY0" fmla="*/ 245786 h 540522"/>
-              <a:gd name="connsiteX1" fmla="*/ 246958 w 12202618"/>
-              <a:gd name="connsiteY1" fmla="*/ 0 h 540522"/>
-              <a:gd name="connsiteX2" fmla="*/ 11947387 w 12202618"/>
-              <a:gd name="connsiteY2" fmla="*/ 0 h 540522"/>
-              <a:gd name="connsiteX3" fmla="*/ 12193173 w 12202618"/>
-              <a:gd name="connsiteY3" fmla="*/ 245786 h 540522"/>
-              <a:gd name="connsiteX4" fmla="*/ 12193172 w 12202618"/>
-              <a:gd name="connsiteY4" fmla="*/ 245786 h 540522"/>
-              <a:gd name="connsiteX5" fmla="*/ 12185511 w 12202618"/>
-              <a:gd name="connsiteY5" fmla="*/ 491571 h 540522"/>
-              <a:gd name="connsiteX6" fmla="*/ 4223 w 12202618"/>
-              <a:gd name="connsiteY6" fmla="*/ 539413 h 540522"/>
-              <a:gd name="connsiteX7" fmla="*/ 1172 w 12202618"/>
-              <a:gd name="connsiteY7" fmla="*/ 245785 h 540522"/>
-              <a:gd name="connsiteX8" fmla="*/ 1172 w 12202618"/>
-              <a:gd name="connsiteY8" fmla="*/ 245786 h 540522"/>
-              <a:gd name="connsiteX0" fmla="*/ 1172 w 12213078"/>
-              <a:gd name="connsiteY0" fmla="*/ 245786 h 540522"/>
-              <a:gd name="connsiteX1" fmla="*/ 246958 w 12213078"/>
-              <a:gd name="connsiteY1" fmla="*/ 0 h 540522"/>
-              <a:gd name="connsiteX2" fmla="*/ 11947387 w 12213078"/>
-              <a:gd name="connsiteY2" fmla="*/ 0 h 540522"/>
-              <a:gd name="connsiteX3" fmla="*/ 12193173 w 12213078"/>
-              <a:gd name="connsiteY3" fmla="*/ 245786 h 540522"/>
-              <a:gd name="connsiteX4" fmla="*/ 12193172 w 12213078"/>
-              <a:gd name="connsiteY4" fmla="*/ 245786 h 540522"/>
-              <a:gd name="connsiteX5" fmla="*/ 12199798 w 12213078"/>
-              <a:gd name="connsiteY5" fmla="*/ 491571 h 540522"/>
-              <a:gd name="connsiteX6" fmla="*/ 4223 w 12213078"/>
-              <a:gd name="connsiteY6" fmla="*/ 539413 h 540522"/>
-              <a:gd name="connsiteX7" fmla="*/ 1172 w 12213078"/>
-              <a:gd name="connsiteY7" fmla="*/ 245785 h 540522"/>
-              <a:gd name="connsiteX8" fmla="*/ 1172 w 12213078"/>
-              <a:gd name="connsiteY8" fmla="*/ 245786 h 540522"/>
-              <a:gd name="connsiteX0" fmla="*/ 1172 w 12198313"/>
-              <a:gd name="connsiteY0" fmla="*/ 245786 h 540522"/>
-              <a:gd name="connsiteX1" fmla="*/ 246958 w 12198313"/>
-              <a:gd name="connsiteY1" fmla="*/ 0 h 540522"/>
-              <a:gd name="connsiteX2" fmla="*/ 11947387 w 12198313"/>
-              <a:gd name="connsiteY2" fmla="*/ 0 h 540522"/>
-              <a:gd name="connsiteX3" fmla="*/ 12193173 w 12198313"/>
-              <a:gd name="connsiteY3" fmla="*/ 245786 h 540522"/>
-              <a:gd name="connsiteX4" fmla="*/ 12193172 w 12198313"/>
-              <a:gd name="connsiteY4" fmla="*/ 245786 h 540522"/>
-              <a:gd name="connsiteX5" fmla="*/ 12178366 w 12198313"/>
-              <a:gd name="connsiteY5" fmla="*/ 526990 h 540522"/>
-              <a:gd name="connsiteX6" fmla="*/ 4223 w 12198313"/>
-              <a:gd name="connsiteY6" fmla="*/ 539413 h 540522"/>
-              <a:gd name="connsiteX7" fmla="*/ 1172 w 12198313"/>
-              <a:gd name="connsiteY7" fmla="*/ 245785 h 540522"/>
-              <a:gd name="connsiteX8" fmla="*/ 1172 w 12198313"/>
-              <a:gd name="connsiteY8" fmla="*/ 245786 h 540522"/>
-              <a:gd name="connsiteX0" fmla="*/ 1172 w 12233684"/>
-              <a:gd name="connsiteY0" fmla="*/ 245786 h 551725"/>
-              <a:gd name="connsiteX1" fmla="*/ 246958 w 12233684"/>
-              <a:gd name="connsiteY1" fmla="*/ 0 h 551725"/>
-              <a:gd name="connsiteX2" fmla="*/ 11947387 w 12233684"/>
-              <a:gd name="connsiteY2" fmla="*/ 0 h 551725"/>
-              <a:gd name="connsiteX3" fmla="*/ 12193173 w 12233684"/>
-              <a:gd name="connsiteY3" fmla="*/ 245786 h 551725"/>
-              <a:gd name="connsiteX4" fmla="*/ 12193172 w 12233684"/>
-              <a:gd name="connsiteY4" fmla="*/ 245786 h 551725"/>
-              <a:gd name="connsiteX5" fmla="*/ 12224086 w 12233684"/>
-              <a:gd name="connsiteY5" fmla="*/ 551630 h 551725"/>
-              <a:gd name="connsiteX6" fmla="*/ 4223 w 12233684"/>
-              <a:gd name="connsiteY6" fmla="*/ 539413 h 551725"/>
-              <a:gd name="connsiteX7" fmla="*/ 1172 w 12233684"/>
-              <a:gd name="connsiteY7" fmla="*/ 245785 h 551725"/>
-              <a:gd name="connsiteX8" fmla="*/ 1172 w 12233684"/>
-              <a:gd name="connsiteY8" fmla="*/ 245786 h 551725"/>
-            </a:gdLst>
-            <a:ahLst/>
-            <a:cxnLst>
-              <a:cxn ang="0">
-                <a:pos x="connsiteX0" y="connsiteY0"/>
-              </a:cxn>
-              <a:cxn ang="0">
-                <a:pos x="connsiteX1" y="connsiteY1"/>
-              </a:cxn>
-              <a:cxn ang="0">
-                <a:pos x="connsiteX2" y="connsiteY2"/>
-              </a:cxn>
-              <a:cxn ang="0">
-                <a:pos x="connsiteX3" y="connsiteY3"/>
-              </a:cxn>
-              <a:cxn ang="0">
-                <a:pos x="connsiteX4" y="connsiteY4"/>
-              </a:cxn>
-              <a:cxn ang="0">
-                <a:pos x="connsiteX5" y="connsiteY5"/>
-              </a:cxn>
-              <a:cxn ang="0">
-                <a:pos x="connsiteX6" y="connsiteY6"/>
-              </a:cxn>
-              <a:cxn ang="0">
-                <a:pos x="connsiteX7" y="connsiteY7"/>
-              </a:cxn>
-              <a:cxn ang="0">
-                <a:pos x="connsiteX8" y="connsiteY8"/>
-              </a:cxn>
-            </a:cxnLst>
-            <a:rect l="l" t="t" r="r" b="b"/>
-            <a:pathLst>
-              <a:path w="12233684" h="551725">
-                <a:moveTo>
-                  <a:pt x="1172" y="245786"/>
-                </a:moveTo>
-                <a:cubicBezTo>
-                  <a:pt x="1172" y="110042"/>
-                  <a:pt x="111214" y="0"/>
-                  <a:pt x="246958" y="0"/>
-                </a:cubicBezTo>
-                <a:lnTo>
-                  <a:pt x="11947387" y="0"/>
-                </a:lnTo>
-                <a:cubicBezTo>
-                  <a:pt x="12083131" y="0"/>
-                  <a:pt x="12193173" y="110042"/>
-                  <a:pt x="12193173" y="245786"/>
-                </a:cubicBezTo>
-                <a:lnTo>
-                  <a:pt x="12193172" y="245786"/>
-                </a:lnTo>
-                <a:cubicBezTo>
-                  <a:pt x="12193172" y="381530"/>
-                  <a:pt x="12257437" y="556393"/>
-                  <a:pt x="12224086" y="551630"/>
-                </a:cubicBezTo>
-                <a:lnTo>
-                  <a:pt x="4223" y="539413"/>
-                </a:lnTo>
-                <a:cubicBezTo>
-                  <a:pt x="-2934" y="556082"/>
-                  <a:pt x="1172" y="381529"/>
-                  <a:pt x="1172" y="245785"/>
-                </a:cubicBezTo>
-                <a:lnTo>
-                  <a:pt x="1172" y="245786"/>
-                </a:lnTo>
-                <a:close/>
-              </a:path>
-            </a:pathLst>
-          </a:custGeom>
-          <a:solidFill>
-            <a:schemeClr val="bg1"/>
-          </a:solidFill>
-          <a:ln>
-            <a:noFill/>
-          </a:ln>
-          <a:effectLst/>
-        </p:spPr>
-        <p:style>
-          <a:lnRef idx="2">
-            <a:schemeClr val="accent1">
-              <a:shade val="15000"/>
-            </a:schemeClr>
-          </a:lnRef>
-          <a:fillRef idx="1">
-            <a:schemeClr val="accent1"/>
-          </a:fillRef>
-          <a:effectRef idx="0">
-            <a:schemeClr val="accent1"/>
-          </a:effectRef>
-          <a:fontRef idx="minor">
-            <a:schemeClr val="lt1"/>
-          </a:fontRef>
-        </p:style>
-        <p:txBody>
-          <a:bodyPr rtlCol="0" anchor="ctr"/>
-          <a:lstStyle/>
-          <a:p>
-            <a:pPr algn="ctr"/>
-            <a:endParaRPr lang="pt-BR"/>
-          </a:p>
-        </p:txBody>
-      </p:sp>
-      <p:sp>
-        <p:nvSpPr>
-          <p:cNvPr id="6" name="Retângulo: Cantos Arredondados 5">
-            <a:extLst>
-              <a:ext uri="{FF2B5EF4-FFF2-40B4-BE49-F238E27FC236}">
-                <a16:creationId xmlns:a16="http://schemas.microsoft.com/office/drawing/2014/main" id="{059EC8DE-693F-2D30-CDBC-C63E2A1AE36C}"/>
-              </a:ext>
-            </a:extLst>
-          </p:cNvPr>
-          <p:cNvSpPr/>
-          <p:nvPr/>
-        </p:nvSpPr>
-        <p:spPr>
-          <a:xfrm>
-            <a:off x="1049149" y="949534"/>
-            <a:ext cx="2387600" cy="853130"/>
-          </a:xfrm>
-          <a:prstGeom prst="roundRect">
-            <a:avLst>
-              <a:gd name="adj" fmla="val 8257"/>
-            </a:avLst>
-          </a:prstGeom>
-          <a:solidFill>
-            <a:schemeClr val="bg1"/>
-          </a:solidFill>
-          <a:ln>
-            <a:noFill/>
-          </a:ln>
-          <a:effectLst>
-            <a:outerShdw blurRad="101600" dist="38100" dir="5400000" algn="t" rotWithShape="0">
-              <a:prstClr val="black">
-                <a:alpha val="20000"/>
-              </a:prstClr>
-            </a:outerShdw>
-          </a:effectLst>
-        </p:spPr>
-        <p:style>
-          <a:lnRef idx="2">
-            <a:schemeClr val="accent1">
-              <a:shade val="15000"/>
-            </a:schemeClr>
-          </a:lnRef>
-          <a:fillRef idx="1">
-            <a:schemeClr val="accent1"/>
-          </a:fillRef>
-          <a:effectRef idx="0">
-            <a:schemeClr val="accent1"/>
-          </a:effectRef>
-          <a:fontRef idx="minor">
-            <a:schemeClr val="lt1"/>
-          </a:fontRef>
-        </p:style>
-        <p:txBody>
-          <a:bodyPr rtlCol="0" anchor="ctr"/>
-          <a:lstStyle/>
-          <a:p>
-            <a:pPr algn="ctr"/>
-            <a:endParaRPr lang="pt-BR"/>
-          </a:p>
-        </p:txBody>
-      </p:sp>
-      <p:sp>
-        <p:nvSpPr>
-          <p:cNvPr id="7" name="Retângulo: Cantos Arredondados 6">
-            <a:extLst>
-              <a:ext uri="{FF2B5EF4-FFF2-40B4-BE49-F238E27FC236}">
-                <a16:creationId xmlns:a16="http://schemas.microsoft.com/office/drawing/2014/main" id="{935B4D87-7F10-AB36-968D-D4D6730226AA}"/>
-              </a:ext>
-            </a:extLst>
-          </p:cNvPr>
-          <p:cNvSpPr/>
-          <p:nvPr/>
-        </p:nvSpPr>
-        <p:spPr>
-          <a:xfrm>
-            <a:off x="3813903" y="949534"/>
-            <a:ext cx="2387600" cy="853130"/>
-          </a:xfrm>
-          <a:prstGeom prst="roundRect">
-            <a:avLst>
-              <a:gd name="adj" fmla="val 7416"/>
-            </a:avLst>
-          </a:prstGeom>
-          <a:solidFill>
-            <a:schemeClr val="bg1"/>
-          </a:solidFill>
-          <a:ln>
-            <a:noFill/>
-          </a:ln>
-          <a:effectLst>
-            <a:outerShdw blurRad="101600" dist="38100" dir="5400000" algn="t" rotWithShape="0">
-              <a:prstClr val="black">
-                <a:alpha val="20000"/>
-              </a:prstClr>
-            </a:outerShdw>
-          </a:effectLst>
-        </p:spPr>
-        <p:style>
-          <a:lnRef idx="2">
-            <a:schemeClr val="accent1">
-              <a:shade val="15000"/>
-            </a:schemeClr>
-          </a:lnRef>
-          <a:fillRef idx="1">
-            <a:schemeClr val="accent1"/>
-          </a:fillRef>
-          <a:effectRef idx="0">
-            <a:schemeClr val="accent1"/>
-          </a:effectRef>
-          <a:fontRef idx="minor">
-            <a:schemeClr val="lt1"/>
-          </a:fontRef>
-        </p:style>
-        <p:txBody>
-          <a:bodyPr rtlCol="0" anchor="ctr"/>
-          <a:lstStyle/>
-          <a:p>
-            <a:pPr algn="ctr"/>
-            <a:endParaRPr lang="pt-BR"/>
-          </a:p>
-        </p:txBody>
-      </p:sp>
-      <p:sp>
-        <p:nvSpPr>
-          <p:cNvPr id="8" name="Retângulo: Cantos Arredondados 7">
-            <a:extLst>
-              <a:ext uri="{FF2B5EF4-FFF2-40B4-BE49-F238E27FC236}">
-                <a16:creationId xmlns:a16="http://schemas.microsoft.com/office/drawing/2014/main" id="{16B04D69-7B73-6177-C7B1-F20FA93BF3AF}"/>
-              </a:ext>
-            </a:extLst>
-          </p:cNvPr>
-          <p:cNvSpPr/>
-          <p:nvPr/>
-        </p:nvSpPr>
-        <p:spPr>
-          <a:xfrm>
-            <a:off x="9380638" y="950110"/>
-            <a:ext cx="2387600" cy="847474"/>
-          </a:xfrm>
-          <a:prstGeom prst="roundRect">
-            <a:avLst>
-              <a:gd name="adj" fmla="val 7416"/>
-            </a:avLst>
-          </a:prstGeom>
-          <a:solidFill>
-            <a:schemeClr val="bg1"/>
-          </a:solidFill>
-          <a:ln>
-            <a:noFill/>
-          </a:ln>
-          <a:effectLst>
-            <a:outerShdw blurRad="101600" dist="38100" dir="5400000" algn="t" rotWithShape="0">
-              <a:prstClr val="black">
-                <a:alpha val="20000"/>
-              </a:prstClr>
-            </a:outerShdw>
-          </a:effectLst>
-        </p:spPr>
-        <p:style>
-          <a:lnRef idx="2">
-            <a:schemeClr val="accent1">
-              <a:shade val="15000"/>
-            </a:schemeClr>
-          </a:lnRef>
-          <a:fillRef idx="1">
-            <a:schemeClr val="accent1"/>
-          </a:fillRef>
-          <a:effectRef idx="0">
-            <a:schemeClr val="accent1"/>
-          </a:effectRef>
-          <a:fontRef idx="minor">
-            <a:schemeClr val="lt1"/>
-          </a:fontRef>
-        </p:style>
-        <p:txBody>
-          <a:bodyPr rtlCol="0" anchor="ctr"/>
-          <a:lstStyle/>
-          <a:p>
-            <a:pPr algn="ctr"/>
-            <a:endParaRPr lang="pt-BR"/>
-          </a:p>
-        </p:txBody>
-      </p:sp>
-      <p:sp>
-        <p:nvSpPr>
-          <p:cNvPr id="10" name="Retângulo: Cantos Arredondados 9">
-            <a:extLst>
-              <a:ext uri="{FF2B5EF4-FFF2-40B4-BE49-F238E27FC236}">
-                <a16:creationId xmlns:a16="http://schemas.microsoft.com/office/drawing/2014/main" id="{E600486A-A0F4-6258-BBAA-18F2F9FE4F3A}"/>
-              </a:ext>
-            </a:extLst>
-          </p:cNvPr>
-          <p:cNvSpPr/>
-          <p:nvPr/>
-        </p:nvSpPr>
-        <p:spPr>
-          <a:xfrm>
-            <a:off x="1049149" y="1944411"/>
-            <a:ext cx="5266984" cy="2619127"/>
-          </a:xfrm>
-          <a:prstGeom prst="roundRect">
-            <a:avLst>
-              <a:gd name="adj" fmla="val 5297"/>
-            </a:avLst>
-          </a:prstGeom>
-          <a:solidFill>
-            <a:schemeClr val="bg1"/>
-          </a:solidFill>
-          <a:ln>
-            <a:noFill/>
-          </a:ln>
-          <a:effectLst>
-            <a:outerShdw blurRad="101600" dist="38100" dir="5400000" algn="t" rotWithShape="0">
-              <a:prstClr val="black">
-                <a:alpha val="20000"/>
-              </a:prstClr>
-            </a:outerShdw>
-          </a:effectLst>
-        </p:spPr>
-        <p:style>
-          <a:lnRef idx="2">
-            <a:schemeClr val="accent1">
-              <a:shade val="15000"/>
-            </a:schemeClr>
-          </a:lnRef>
-          <a:fillRef idx="1">
-            <a:schemeClr val="accent1"/>
-          </a:fillRef>
-          <a:effectRef idx="0">
-            <a:schemeClr val="accent1"/>
-          </a:effectRef>
-          <a:fontRef idx="minor">
-            <a:schemeClr val="lt1"/>
-          </a:fontRef>
-        </p:style>
-        <p:txBody>
-          <a:bodyPr rtlCol="0" anchor="ctr"/>
-          <a:lstStyle/>
-          <a:p>
-            <a:pPr algn="ctr"/>
-            <a:endParaRPr lang="pt-BR"/>
-          </a:p>
-        </p:txBody>
-      </p:sp>
-      <p:sp>
-        <p:nvSpPr>
-          <p:cNvPr id="12" name="Retângulo: Cantos Arredondados 11">
-            <a:extLst>
-              <a:ext uri="{FF2B5EF4-FFF2-40B4-BE49-F238E27FC236}">
-                <a16:creationId xmlns:a16="http://schemas.microsoft.com/office/drawing/2014/main" id="{8D72F93A-4356-D4B9-B706-F422863C2413}"/>
-              </a:ext>
-            </a:extLst>
-          </p:cNvPr>
-          <p:cNvSpPr/>
-          <p:nvPr/>
-        </p:nvSpPr>
-        <p:spPr>
-          <a:xfrm>
-            <a:off x="1049149" y="4820478"/>
-            <a:ext cx="10737908" cy="1921835"/>
-          </a:xfrm>
-          <a:prstGeom prst="roundRect">
-            <a:avLst>
-              <a:gd name="adj" fmla="val 4729"/>
-            </a:avLst>
-          </a:prstGeom>
-          <a:solidFill>
-            <a:schemeClr val="bg1"/>
-          </a:solidFill>
-          <a:ln>
-            <a:noFill/>
-          </a:ln>
-          <a:effectLst>
-            <a:outerShdw blurRad="101600" dist="38100" dir="5400000" algn="t" rotWithShape="0">
-              <a:prstClr val="black">
-                <a:alpha val="20000"/>
-              </a:prstClr>
-            </a:outerShdw>
-          </a:effectLst>
-        </p:spPr>
-        <p:style>
-          <a:lnRef idx="2">
-            <a:schemeClr val="accent1">
-              <a:shade val="15000"/>
-            </a:schemeClr>
-          </a:lnRef>
-          <a:fillRef idx="1">
-            <a:schemeClr val="accent1"/>
-          </a:fillRef>
-          <a:effectRef idx="0">
-            <a:schemeClr val="accent1"/>
-          </a:effectRef>
-          <a:fontRef idx="minor">
-            <a:schemeClr val="lt1"/>
-          </a:fontRef>
-        </p:style>
-        <p:txBody>
-          <a:bodyPr rtlCol="0" anchor="ctr"/>
-          <a:lstStyle/>
-          <a:p>
-            <a:pPr algn="ctr"/>
-            <a:endParaRPr lang="pt-BR"/>
-          </a:p>
-        </p:txBody>
-      </p:sp>
-      <p:sp>
-        <p:nvSpPr>
-          <p:cNvPr id="34" name="Rectangle 1">
-            <a:extLst>
-              <a:ext uri="{FF2B5EF4-FFF2-40B4-BE49-F238E27FC236}">
-                <a16:creationId xmlns:a16="http://schemas.microsoft.com/office/drawing/2014/main" id="{99360A99-0724-5818-A79E-82A878AD47FA}"/>
-              </a:ext>
-            </a:extLst>
-          </p:cNvPr>
-          <p:cNvSpPr>
-            <a:spLocks noChangeArrowheads="1"/>
-          </p:cNvSpPr>
-          <p:nvPr/>
-        </p:nvSpPr>
-        <p:spPr bwMode="auto">
-          <a:xfrm>
-            <a:off x="0" y="0"/>
-            <a:ext cx="12192000" cy="0"/>
-          </a:xfrm>
-          <a:prstGeom prst="rect">
-            <a:avLst/>
-          </a:prstGeom>
-          <a:noFill/>
-          <a:ln>
-            <a:noFill/>
-          </a:ln>
-          <a:effectLst/>
-          <a:extLst>
-            <a:ext uri="{909E8E84-426E-40DD-AFC4-6F175D3DCCD1}">
-              <a14:hiddenFill xmlns:a14="http://schemas.microsoft.com/office/drawing/2010/main">
-                <a:solidFill>
-                  <a:schemeClr val="accent1"/>
-                </a:solidFill>
-              </a14:hiddenFill>
-            </a:ext>
-            <a:ext uri="{91240B29-F687-4F45-9708-019B960494DF}">
-              <a14:hiddenLine xmlns:a14="http://schemas.microsoft.com/office/drawing/2010/main" w="9525">
-                <a:solidFill>
-                  <a:schemeClr val="tx1"/>
-                </a:solidFill>
-                <a:miter lim="800000"/>
-                <a:headEnd/>
-                <a:tailEnd/>
-              </a14:hiddenLine>
-            </a:ext>
-            <a:ext uri="{AF507438-7753-43E0-B8FC-AC1667EBCBE1}">
-              <a14:hiddenEffects xmlns:a14="http://schemas.microsoft.com/office/drawing/2010/main">
-                <a:effectLst>
-                  <a:outerShdw dist="35921" dir="2700000" algn="ctr" rotWithShape="0">
-                    <a:schemeClr val="bg2"/>
-                  </a:outerShdw>
-                </a:effectLst>
-              </a14:hiddenEffects>
-            </a:ext>
-          </a:extLst>
-        </p:spPr>
-        <p:txBody>
-          <a:bodyPr vert="horz" wrap="none" lIns="91440" tIns="45720" rIns="91440" bIns="45720" numCol="1" anchor="ctr" anchorCtr="0" compatLnSpc="1">
-            <a:prstTxWarp prst="textNoShape">
-              <a:avLst/>
-            </a:prstTxWarp>
-            <a:spAutoFit/>
-          </a:bodyPr>
-          <a:lstStyle/>
-          <a:p>
-            <a:endParaRPr lang="pt-BR"/>
-          </a:p>
-        </p:txBody>
-      </p:sp>
-      <p:pic>
-        <p:nvPicPr>
-          <p:cNvPr id="40" name="Imagem 39" descr="Logotipo&#10;&#10;O conteúdo gerado por IA pode estar incorreto.">
-            <a:extLst>
-              <a:ext uri="{FF2B5EF4-FFF2-40B4-BE49-F238E27FC236}">
-                <a16:creationId xmlns:a16="http://schemas.microsoft.com/office/drawing/2014/main" id="{8552B86D-A995-EDF7-59A3-BEB4F67C88E0}"/>
-              </a:ext>
-            </a:extLst>
-          </p:cNvPr>
-          <p:cNvPicPr>
-            <a:picLocks noChangeAspect="1"/>
-          </p:cNvPicPr>
-          <p:nvPr/>
-        </p:nvPicPr>
-        <p:blipFill>
-          <a:blip r:embed="rId2">
-            <a:extLst>
-              <a:ext uri="{28A0092B-C50C-407E-A947-70E740481C1C}">
-                <a14:useLocalDpi xmlns:a14="http://schemas.microsoft.com/office/drawing/2010/main" val="0"/>
-              </a:ext>
-            </a:extLst>
-          </a:blip>
-          <a:stretch>
-            <a:fillRect/>
-          </a:stretch>
-        </p:blipFill>
-        <p:spPr>
-          <a:xfrm>
-            <a:off x="-151400" y="-496476"/>
-            <a:ext cx="2342499" cy="1801131"/>
-          </a:xfrm>
-          <a:prstGeom prst="rect">
-            <a:avLst/>
-          </a:prstGeom>
-        </p:spPr>
-      </p:pic>
-      <p:sp>
-        <p:nvSpPr>
-          <p:cNvPr id="46" name="Retângulo: Cantos Arredondados 45">
-            <a:extLst>
-              <a:ext uri="{FF2B5EF4-FFF2-40B4-BE49-F238E27FC236}">
-                <a16:creationId xmlns:a16="http://schemas.microsoft.com/office/drawing/2014/main" id="{F0C0851D-FD33-9335-CB95-D188E50A92BB}"/>
-              </a:ext>
-            </a:extLst>
-          </p:cNvPr>
-          <p:cNvSpPr/>
-          <p:nvPr/>
-        </p:nvSpPr>
-        <p:spPr>
-          <a:xfrm>
-            <a:off x="1699975" y="227802"/>
-            <a:ext cx="3205399" cy="309954"/>
-          </a:xfrm>
-          <a:prstGeom prst="roundRect">
-            <a:avLst>
-              <a:gd name="adj" fmla="val 26287"/>
-            </a:avLst>
-          </a:prstGeom>
-          <a:solidFill>
-            <a:srgbClr val="010A52"/>
-          </a:solidFill>
-          <a:ln>
-            <a:noFill/>
-          </a:ln>
-        </p:spPr>
-        <p:style>
-          <a:lnRef idx="2">
-            <a:schemeClr val="accent1">
-              <a:shade val="15000"/>
-            </a:schemeClr>
-          </a:lnRef>
-          <a:fillRef idx="1">
-            <a:schemeClr val="accent1"/>
-          </a:fillRef>
-          <a:effectRef idx="0">
-            <a:schemeClr val="accent1"/>
-          </a:effectRef>
-          <a:fontRef idx="minor">
-            <a:schemeClr val="lt1"/>
-          </a:fontRef>
-        </p:style>
-        <p:txBody>
-          <a:bodyPr rtlCol="0" anchor="ctr"/>
-          <a:lstStyle/>
-          <a:p>
-            <a:pPr algn="ctr"/>
-            <a:r>
-              <a:rPr lang="pt-BR" sz="1400" dirty="0" err="1"/>
-              <a:t>Analytics</a:t>
-            </a:r>
-            <a:r>
-              <a:rPr lang="pt-BR" sz="1400" dirty="0"/>
-              <a:t> – Evolução e tendências</a:t>
+              <a:t>Analytics – Evolução e tendências</a:t>
             </a:r>
           </a:p>
         </p:txBody>

</xml_diff>

<commit_message>
fix: Padronização de cor dos rotulos de dados.
</commit_message>
<xml_diff>
--- a/dashboards/Mockup dashboard (em construção).pptx
+++ b/dashboards/Mockup dashboard (em construção).pptx
@@ -263,7 +263,7 @@
           <a:p>
             <a:fld id="{2DB56B22-234B-48A0-9B90-72A4AF419D03}" type="datetimeFigureOut">
               <a:rPr lang="pt-BR" smtClean="0"/>
-              <a:t>22/03/2026</a:t>
+              <a:t>28/03/2026</a:t>
             </a:fld>
             <a:endParaRPr lang="pt-BR"/>
           </a:p>
@@ -461,7 +461,7 @@
           <a:p>
             <a:fld id="{2DB56B22-234B-48A0-9B90-72A4AF419D03}" type="datetimeFigureOut">
               <a:rPr lang="pt-BR" smtClean="0"/>
-              <a:t>22/03/2026</a:t>
+              <a:t>28/03/2026</a:t>
             </a:fld>
             <a:endParaRPr lang="pt-BR"/>
           </a:p>
@@ -669,7 +669,7 @@
           <a:p>
             <a:fld id="{2DB56B22-234B-48A0-9B90-72A4AF419D03}" type="datetimeFigureOut">
               <a:rPr lang="pt-BR" smtClean="0"/>
-              <a:t>22/03/2026</a:t>
+              <a:t>28/03/2026</a:t>
             </a:fld>
             <a:endParaRPr lang="pt-BR"/>
           </a:p>
@@ -867,7 +867,7 @@
           <a:p>
             <a:fld id="{2DB56B22-234B-48A0-9B90-72A4AF419D03}" type="datetimeFigureOut">
               <a:rPr lang="pt-BR" smtClean="0"/>
-              <a:t>22/03/2026</a:t>
+              <a:t>28/03/2026</a:t>
             </a:fld>
             <a:endParaRPr lang="pt-BR"/>
           </a:p>
@@ -1142,7 +1142,7 @@
           <a:p>
             <a:fld id="{2DB56B22-234B-48A0-9B90-72A4AF419D03}" type="datetimeFigureOut">
               <a:rPr lang="pt-BR" smtClean="0"/>
-              <a:t>22/03/2026</a:t>
+              <a:t>28/03/2026</a:t>
             </a:fld>
             <a:endParaRPr lang="pt-BR"/>
           </a:p>
@@ -1407,7 +1407,7 @@
           <a:p>
             <a:fld id="{2DB56B22-234B-48A0-9B90-72A4AF419D03}" type="datetimeFigureOut">
               <a:rPr lang="pt-BR" smtClean="0"/>
-              <a:t>22/03/2026</a:t>
+              <a:t>28/03/2026</a:t>
             </a:fld>
             <a:endParaRPr lang="pt-BR"/>
           </a:p>
@@ -1819,7 +1819,7 @@
           <a:p>
             <a:fld id="{2DB56B22-234B-48A0-9B90-72A4AF419D03}" type="datetimeFigureOut">
               <a:rPr lang="pt-BR" smtClean="0"/>
-              <a:t>22/03/2026</a:t>
+              <a:t>28/03/2026</a:t>
             </a:fld>
             <a:endParaRPr lang="pt-BR"/>
           </a:p>
@@ -1960,7 +1960,7 @@
           <a:p>
             <a:fld id="{2DB56B22-234B-48A0-9B90-72A4AF419D03}" type="datetimeFigureOut">
               <a:rPr lang="pt-BR" smtClean="0"/>
-              <a:t>22/03/2026</a:t>
+              <a:t>28/03/2026</a:t>
             </a:fld>
             <a:endParaRPr lang="pt-BR"/>
           </a:p>
@@ -2073,7 +2073,7 @@
           <a:p>
             <a:fld id="{2DB56B22-234B-48A0-9B90-72A4AF419D03}" type="datetimeFigureOut">
               <a:rPr lang="pt-BR" smtClean="0"/>
-              <a:t>22/03/2026</a:t>
+              <a:t>28/03/2026</a:t>
             </a:fld>
             <a:endParaRPr lang="pt-BR"/>
           </a:p>
@@ -2384,7 +2384,7 @@
           <a:p>
             <a:fld id="{2DB56B22-234B-48A0-9B90-72A4AF419D03}" type="datetimeFigureOut">
               <a:rPr lang="pt-BR" smtClean="0"/>
-              <a:t>22/03/2026</a:t>
+              <a:t>28/03/2026</a:t>
             </a:fld>
             <a:endParaRPr lang="pt-BR"/>
           </a:p>
@@ -2672,7 +2672,7 @@
           <a:p>
             <a:fld id="{2DB56B22-234B-48A0-9B90-72A4AF419D03}" type="datetimeFigureOut">
               <a:rPr lang="pt-BR" smtClean="0"/>
-              <a:t>22/03/2026</a:t>
+              <a:t>28/03/2026</a:t>
             </a:fld>
             <a:endParaRPr lang="pt-BR"/>
           </a:p>
@@ -2913,7 +2913,7 @@
           <a:p>
             <a:fld id="{2DB56B22-234B-48A0-9B90-72A4AF419D03}" type="datetimeFigureOut">
               <a:rPr lang="pt-BR" smtClean="0"/>
-              <a:t>22/03/2026</a:t>
+              <a:t>28/03/2026</a:t>
             </a:fld>
             <a:endParaRPr lang="pt-BR"/>
           </a:p>
@@ -10275,7 +10275,7 @@
         <p:spPr>
           <a:xfrm>
             <a:off x="1049149" y="1944411"/>
-            <a:ext cx="5266984" cy="2619127"/>
+            <a:ext cx="5266984" cy="2405546"/>
           </a:xfrm>
           <a:prstGeom prst="roundRect">
             <a:avLst>
@@ -10335,8 +10335,8 @@
         </p:nvSpPr>
         <p:spPr>
           <a:xfrm>
-            <a:off x="1049149" y="4820478"/>
-            <a:ext cx="10737908" cy="1921835"/>
+            <a:off x="1049149" y="4544896"/>
+            <a:ext cx="10737908" cy="2197418"/>
           </a:xfrm>
           <a:prstGeom prst="roundRect">
             <a:avLst>
@@ -11221,7 +11221,7 @@
         <p:spPr>
           <a:xfrm>
             <a:off x="9088315" y="1933872"/>
-            <a:ext cx="2698742" cy="2611022"/>
+            <a:ext cx="2698742" cy="2398102"/>
           </a:xfrm>
           <a:prstGeom prst="roundRect">
             <a:avLst>
@@ -11282,7 +11282,7 @@
         <p:spPr>
           <a:xfrm>
             <a:off x="6418103" y="1952516"/>
-            <a:ext cx="2568242" cy="2611022"/>
+            <a:ext cx="2568242" cy="2398102"/>
           </a:xfrm>
           <a:prstGeom prst="roundRect">
             <a:avLst>

</xml_diff>